<commit_message>
Enhance component library: directional markers, court-scale sizing, team sets
- Add directional player markers (circle + direction triangle, grouped):
  rotate the group in PowerPoint to show any body orientation
- Correct all marker sizes to true court scale: 0.14" = ~1.7m on 40m court
  (previous 0.26" markers = ~3.2m, too large for court diagrams)
- Add Team A (numbered 1-5, blue) and Team B (numbered 1-5, dark) sets
  with instruction to recolour Team B to opponent colour
- Scale proportional equipment sizes (cone, pole, ball)
- Add rotation HOW TO callout on component library slide
- Add scale/colour notes for coaches

https://claude.ai/code/session_018tafNEeKNQ7u7wPXfzwa7T
</commit_message>
<xml_diff>
--- a/futsal_session_template.pptx
+++ b/futsal_session_template.pptx
@@ -24251,7 +24251,7 @@
         <p:spPr>
           <a:xfrm>
             <a:off x="137160" y="45720"/>
-            <a:ext cx="8229600" cy="457200"/>
+            <a:ext cx="9144000" cy="457200"/>
           </a:xfrm>
           <a:prstGeom prst="rect">
             <a:avLst/>
@@ -24285,7 +24285,7 @@
                 </a:solidFill>
                 <a:latin typeface="Calibri"/>
               </a:rPr>
-              <a:t>Copy any element into a diagram zone. Consistent sizes and line weights — duplicate freely.</a:t>
+              <a:t>All markers are at true court scale (≈1.7 m on a 40 m court). Copy and paste directly onto any diagram — they will be proportionally correct.</a:t>
             </a:r>
           </a:p>
         </p:txBody>
@@ -24342,7 +24342,7 @@
         </p:nvSpPr>
         <p:spPr>
           <a:xfrm>
-            <a:off x="365760" y="896112"/>
+            <a:off x="365760" y="685800"/>
             <a:ext cx="36576" cy="146304"/>
           </a:xfrm>
           <a:prstGeom prst="rect">
@@ -24386,7 +24386,7 @@
         </p:nvSpPr>
         <p:spPr>
           <a:xfrm>
-            <a:off x="438912" y="868680"/>
+            <a:off x="438912" y="658368"/>
             <a:ext cx="2377440" cy="201168"/>
           </a:xfrm>
           <a:prstGeom prst="rect">
@@ -24409,7 +24409,7 @@
                 </a:solidFill>
                 <a:latin typeface="Calibri"/>
               </a:rPr>
-              <a:t>PLAYERS</a:t>
+              <a:t>PLAYER MARKERS  (plain)</a:t>
             </a:r>
           </a:p>
         </p:txBody>
@@ -24422,8 +24422,8 @@
         </p:nvSpPr>
         <p:spPr>
           <a:xfrm>
-            <a:off x="493776" y="1161288"/>
-            <a:ext cx="237744" cy="237744"/>
+            <a:off x="420624" y="896112"/>
+            <a:ext cx="128016" cy="128016"/>
           </a:xfrm>
           <a:prstGeom prst="ellipse">
             <a:avLst/>
@@ -24456,13 +24456,13 @@
           <a:p>
             <a:pPr algn="ctr"/>
             <a:r>
-              <a:rPr sz="900" b="1">
+              <a:rPr sz="700" b="1">
                 <a:solidFill>
                   <a:srgbClr val="FFFFFF"/>
                 </a:solidFill>
                 <a:latin typeface="Calibri"/>
               </a:rPr>
-              <a:t>1</a:t>
+              <a:t>A</a:t>
             </a:r>
           </a:p>
         </p:txBody>
@@ -24475,8 +24475,8 @@
         </p:nvSpPr>
         <p:spPr>
           <a:xfrm>
-            <a:off x="365760" y="1435608"/>
-            <a:ext cx="640080" cy="164592"/>
+            <a:off x="384048" y="1060704"/>
+            <a:ext cx="402336" cy="164592"/>
           </a:xfrm>
           <a:prstGeom prst="rect">
             <a:avLst/>
@@ -24511,8 +24511,8 @@
         </p:nvSpPr>
         <p:spPr>
           <a:xfrm>
-            <a:off x="1152144" y="1161288"/>
-            <a:ext cx="237744" cy="237744"/>
+            <a:off x="877824" y="896112"/>
+            <a:ext cx="128016" cy="128016"/>
           </a:xfrm>
           <a:prstGeom prst="ellipse">
             <a:avLst/>
@@ -24520,7 +24520,7 @@
           <a:solidFill>
             <a:srgbClr val="FFFFFF"/>
           </a:solidFill>
-          <a:ln w="15875">
+          <a:ln w="12700">
             <a:solidFill>
               <a:srgbClr val="6B6B6B"/>
             </a:solidFill>
@@ -24547,13 +24547,13 @@
           <a:p>
             <a:pPr algn="ctr"/>
             <a:r>
-              <a:rPr sz="900" b="1">
+              <a:rPr sz="700" b="1">
                 <a:solidFill>
                   <a:srgbClr val="6B6B6B"/>
                 </a:solidFill>
                 <a:latin typeface="Calibri"/>
               </a:rPr>
-              <a:t>1</a:t>
+              <a:t>D</a:t>
             </a:r>
           </a:p>
         </p:txBody>
@@ -24566,8 +24566,8 @@
         </p:nvSpPr>
         <p:spPr>
           <a:xfrm>
-            <a:off x="1024128" y="1435608"/>
-            <a:ext cx="640080" cy="164592"/>
+            <a:off x="841248" y="1060704"/>
+            <a:ext cx="402336" cy="164592"/>
           </a:xfrm>
           <a:prstGeom prst="rect">
             <a:avLst/>
@@ -24602,8 +24602,8 @@
         </p:nvSpPr>
         <p:spPr>
           <a:xfrm>
-            <a:off x="1810512" y="1161288"/>
-            <a:ext cx="237744" cy="237744"/>
+            <a:off x="1335024" y="896112"/>
+            <a:ext cx="128016" cy="128016"/>
           </a:xfrm>
           <a:prstGeom prst="ellipse">
             <a:avLst/>
@@ -24636,7 +24636,7 @@
           <a:p>
             <a:pPr algn="ctr"/>
             <a:r>
-              <a:rPr sz="900" b="1">
+              <a:rPr sz="700" b="1">
                 <a:solidFill>
                   <a:srgbClr val="FFFFFF"/>
                 </a:solidFill>
@@ -24655,8 +24655,8 @@
         </p:nvSpPr>
         <p:spPr>
           <a:xfrm>
-            <a:off x="1682496" y="1435608"/>
-            <a:ext cx="640080" cy="164592"/>
+            <a:off x="1298448" y="1060704"/>
+            <a:ext cx="402336" cy="164592"/>
           </a:xfrm>
           <a:prstGeom prst="rect">
             <a:avLst/>
@@ -24691,8 +24691,8 @@
         </p:nvSpPr>
         <p:spPr>
           <a:xfrm>
-            <a:off x="2468880" y="1161288"/>
-            <a:ext cx="237744" cy="237744"/>
+            <a:off x="1792224" y="896112"/>
+            <a:ext cx="128016" cy="128016"/>
           </a:xfrm>
           <a:prstGeom prst="ellipse">
             <a:avLst/>
@@ -24700,7 +24700,7 @@
           <a:solidFill>
             <a:srgbClr val="FFFFFF"/>
           </a:solidFill>
-          <a:ln w="15875">
+          <a:ln w="12700">
             <a:solidFill>
               <a:srgbClr val="6B6B6B"/>
             </a:solidFill>
@@ -24728,7 +24728,7 @@
           <a:p>
             <a:pPr algn="ctr"/>
             <a:r>
-              <a:rPr sz="900" b="1">
+              <a:rPr sz="700" b="1">
                 <a:solidFill>
                   <a:srgbClr val="6B6B6B"/>
                 </a:solidFill>
@@ -24747,8 +24747,8 @@
         </p:nvSpPr>
         <p:spPr>
           <a:xfrm>
-            <a:off x="2340864" y="1435608"/>
-            <a:ext cx="640080" cy="164592"/>
+            <a:off x="1755648" y="1060704"/>
+            <a:ext cx="402336" cy="164592"/>
           </a:xfrm>
           <a:prstGeom prst="rect">
             <a:avLst/>
@@ -24783,7 +24783,7 @@
         </p:nvSpPr>
         <p:spPr>
           <a:xfrm>
-            <a:off x="3246120" y="896112"/>
+            <a:off x="2331720" y="685800"/>
             <a:ext cx="36576" cy="146304"/>
           </a:xfrm>
           <a:prstGeom prst="rect">
@@ -24827,7 +24827,7 @@
         </p:nvSpPr>
         <p:spPr>
           <a:xfrm>
-            <a:off x="3319272" y="868680"/>
+            <a:off x="2404872" y="658368"/>
             <a:ext cx="2377440" cy="201168"/>
           </a:xfrm>
           <a:prstGeom prst="rect">
@@ -24863,8 +24863,8 @@
         </p:nvSpPr>
         <p:spPr>
           <a:xfrm>
-            <a:off x="3337560" y="1179576"/>
-            <a:ext cx="201168" cy="182880"/>
+            <a:off x="2404872" y="914400"/>
+            <a:ext cx="82296" cy="73152"/>
           </a:xfrm>
           <a:prstGeom prst="triangle">
             <a:avLst/>
@@ -24907,8 +24907,8 @@
         </p:nvSpPr>
         <p:spPr>
           <a:xfrm>
-            <a:off x="3154680" y="1435608"/>
-            <a:ext cx="566928" cy="164592"/>
+            <a:off x="2340864" y="1060704"/>
+            <a:ext cx="365760" cy="164592"/>
           </a:xfrm>
           <a:prstGeom prst="rect">
             <a:avLst/>
@@ -24943,8 +24943,8 @@
         </p:nvSpPr>
         <p:spPr>
           <a:xfrm>
-            <a:off x="3959352" y="1124712"/>
-            <a:ext cx="45720" cy="292608"/>
+            <a:off x="2898648" y="877824"/>
+            <a:ext cx="36576" cy="182880"/>
           </a:xfrm>
           <a:prstGeom prst="rect">
             <a:avLst/>
@@ -24987,8 +24987,8 @@
         </p:nvSpPr>
         <p:spPr>
           <a:xfrm>
-            <a:off x="3703320" y="1435608"/>
-            <a:ext cx="566928" cy="164592"/>
+            <a:off x="2761488" y="1060704"/>
+            <a:ext cx="365760" cy="164592"/>
           </a:xfrm>
           <a:prstGeom prst="rect">
             <a:avLst/>
@@ -25023,8 +25023,8 @@
         </p:nvSpPr>
         <p:spPr>
           <a:xfrm>
-            <a:off x="4471416" y="1216152"/>
-            <a:ext cx="118872" cy="118872"/>
+            <a:off x="3337560" y="932688"/>
+            <a:ext cx="64008" cy="64008"/>
           </a:xfrm>
           <a:prstGeom prst="ellipse">
             <a:avLst/>
@@ -25067,8 +25067,8 @@
         </p:nvSpPr>
         <p:spPr>
           <a:xfrm>
-            <a:off x="4251960" y="1435608"/>
-            <a:ext cx="566928" cy="164592"/>
+            <a:off x="3200400" y="1060704"/>
+            <a:ext cx="365760" cy="164592"/>
           </a:xfrm>
           <a:prstGeom prst="rect">
             <a:avLst/>
@@ -25103,7 +25103,7 @@
         </p:nvSpPr>
         <p:spPr>
           <a:xfrm>
-            <a:off x="5349240" y="896112"/>
+            <a:off x="3429000" y="685800"/>
             <a:ext cx="36576" cy="146304"/>
           </a:xfrm>
           <a:prstGeom prst="rect">
@@ -25147,7 +25147,7 @@
         </p:nvSpPr>
         <p:spPr>
           <a:xfrm>
-            <a:off x="5422392" y="868680"/>
+            <a:off x="3502152" y="658368"/>
             <a:ext cx="2377440" cy="201168"/>
           </a:xfrm>
           <a:prstGeom prst="rect">
@@ -25183,8 +25183,8 @@
         </p:nvCxnSpPr>
         <p:spPr>
           <a:xfrm>
-            <a:off x="5394960" y="1252728"/>
-            <a:ext cx="822960" cy="0"/>
+            <a:off x="3474720" y="1005840"/>
+            <a:ext cx="685800" cy="0"/>
           </a:xfrm>
           <a:prstGeom prst="line">
             <a:avLst/>
@@ -25220,8 +25220,8 @@
         </p:nvSpPr>
         <p:spPr>
           <a:xfrm>
-            <a:off x="5349240" y="1325880"/>
-            <a:ext cx="914400" cy="164592"/>
+            <a:off x="3429000" y="1060704"/>
+            <a:ext cx="822960" cy="164592"/>
           </a:xfrm>
           <a:prstGeom prst="rect">
             <a:avLst/>
@@ -25243,7 +25243,7 @@
                 </a:solidFill>
                 <a:latin typeface="Calibri"/>
               </a:rPr>
-              <a:t>Movement run</a:t>
+              <a:t>Run</a:t>
             </a:r>
           </a:p>
         </p:txBody>
@@ -25256,8 +25256,8 @@
         </p:nvCxnSpPr>
         <p:spPr>
           <a:xfrm>
-            <a:off x="6400800" y="1252728"/>
-            <a:ext cx="822960" cy="0"/>
+            <a:off x="4343400" y="1005840"/>
+            <a:ext cx="685800" cy="0"/>
           </a:xfrm>
           <a:prstGeom prst="line">
             <a:avLst/>
@@ -25294,8 +25294,8 @@
         </p:nvSpPr>
         <p:spPr>
           <a:xfrm>
-            <a:off x="6355080" y="1325880"/>
-            <a:ext cx="914400" cy="164592"/>
+            <a:off x="4297680" y="1060704"/>
+            <a:ext cx="822960" cy="164592"/>
           </a:xfrm>
           <a:prstGeom prst="rect">
             <a:avLst/>
@@ -25330,8 +25330,8 @@
         </p:nvCxnSpPr>
         <p:spPr>
           <a:xfrm>
-            <a:off x="7406640" y="1252728"/>
-            <a:ext cx="822960" cy="0"/>
+            <a:off x="5212080" y="1005840"/>
+            <a:ext cx="685800" cy="0"/>
           </a:xfrm>
           <a:prstGeom prst="line">
             <a:avLst/>
@@ -25368,8 +25368,8 @@
         </p:nvSpPr>
         <p:spPr>
           <a:xfrm>
-            <a:off x="7360920" y="1325880"/>
-            <a:ext cx="914400" cy="164592"/>
+            <a:off x="5166360" y="1060704"/>
+            <a:ext cx="822960" cy="164592"/>
           </a:xfrm>
           <a:prstGeom prst="rect">
             <a:avLst/>
@@ -25404,7 +25404,7 @@
         </p:nvSpPr>
         <p:spPr>
           <a:xfrm>
-            <a:off x="8823960" y="896112"/>
+            <a:off x="6446520" y="685800"/>
             <a:ext cx="36576" cy="146304"/>
           </a:xfrm>
           <a:prstGeom prst="rect">
@@ -25448,7 +25448,7 @@
         </p:nvSpPr>
         <p:spPr>
           <a:xfrm>
-            <a:off x="8897112" y="868680"/>
+            <a:off x="6519672" y="658368"/>
             <a:ext cx="2377440" cy="201168"/>
           </a:xfrm>
           <a:prstGeom prst="rect">
@@ -25484,8 +25484,8 @@
         </p:nvSpPr>
         <p:spPr>
           <a:xfrm>
-            <a:off x="8869680" y="1143000"/>
-            <a:ext cx="777240" cy="365760"/>
+            <a:off x="6492240" y="896112"/>
+            <a:ext cx="640080" cy="219456"/>
           </a:xfrm>
           <a:prstGeom prst="rect">
             <a:avLst/>
@@ -25530,8 +25530,8 @@
         </p:nvSpPr>
         <p:spPr>
           <a:xfrm>
-            <a:off x="8823960" y="1527048"/>
-            <a:ext cx="868680" cy="164592"/>
+            <a:off x="6464808" y="1060704"/>
+            <a:ext cx="694944" cy="164592"/>
           </a:xfrm>
           <a:prstGeom prst="rect">
             <a:avLst/>
@@ -25553,7 +25553,7 @@
                 </a:solidFill>
                 <a:latin typeface="Calibri"/>
               </a:rPr>
-              <a:t>Shaded zone</a:t>
+              <a:t>Zone</a:t>
             </a:r>
           </a:p>
         </p:txBody>
@@ -25566,8 +25566,8 @@
         </p:nvSpPr>
         <p:spPr>
           <a:xfrm>
-            <a:off x="9921240" y="1289304"/>
-            <a:ext cx="411480" cy="64008"/>
+            <a:off x="7360920" y="969264"/>
+            <a:ext cx="329184" cy="54864"/>
           </a:xfrm>
           <a:prstGeom prst="roundRect">
             <a:avLst/>
@@ -25610,8 +25610,8 @@
         </p:nvSpPr>
         <p:spPr>
           <a:xfrm>
-            <a:off x="9784080" y="1527048"/>
-            <a:ext cx="731520" cy="164592"/>
+            <a:off x="7251192" y="1060704"/>
+            <a:ext cx="566928" cy="164592"/>
           </a:xfrm>
           <a:prstGeom prst="rect">
             <a:avLst/>
@@ -25633,20 +25633,56 @@
                 </a:solidFill>
                 <a:latin typeface="Calibri"/>
               </a:rPr>
-              <a:t>Screen / block</a:t>
+              <a:t>Screen</a:t>
             </a:r>
           </a:p>
         </p:txBody>
       </p:sp>
+      <p:cxnSp>
+        <p:nvCxnSpPr>
+          <p:cNvPr id="36" name="Connector 35"/>
+          <p:cNvCxnSpPr/>
+          <p:nvPr/>
+        </p:nvCxnSpPr>
+        <p:spPr>
+          <a:xfrm>
+            <a:off x="137160" y="1508760"/>
+            <a:ext cx="11917375" cy="0"/>
+          </a:xfrm>
+          <a:prstGeom prst="line">
+            <a:avLst/>
+          </a:prstGeom>
+          <a:ln w="6350">
+            <a:solidFill>
+              <a:srgbClr val="D9D9D9"/>
+            </a:solidFill>
+          </a:ln>
+          <a:effectLst/>
+        </p:spPr>
+        <p:style>
+          <a:lnRef idx="2">
+            <a:schemeClr val="accent1"/>
+          </a:lnRef>
+          <a:fillRef idx="0">
+            <a:schemeClr val="accent1"/>
+          </a:fillRef>
+          <a:effectRef idx="1">
+            <a:schemeClr val="accent1"/>
+          </a:effectRef>
+          <a:fontRef idx="minor">
+            <a:schemeClr val="tx1"/>
+          </a:fontRef>
+        </p:style>
+      </p:cxnSp>
       <p:sp>
         <p:nvSpPr>
-          <p:cNvPr id="36" name="Rectangle 35"/>
+          <p:cNvPr id="37" name="Rectangle 36"/>
           <p:cNvSpPr/>
           <p:nvPr/>
         </p:nvSpPr>
         <p:spPr>
           <a:xfrm>
-            <a:off x="365760" y="2130552"/>
+            <a:off x="365760" y="1600200"/>
             <a:ext cx="36576" cy="146304"/>
           </a:xfrm>
           <a:prstGeom prst="rect">
@@ -25684,13 +25720,13 @@
       </p:sp>
       <p:sp>
         <p:nvSpPr>
-          <p:cNvPr id="37" name="TextBox 36"/>
+          <p:cNvPr id="38" name="TextBox 37"/>
           <p:cNvSpPr txBox="1"/>
           <p:nvPr/>
         </p:nvSpPr>
         <p:spPr>
           <a:xfrm>
-            <a:off x="438912" y="2103120"/>
+            <a:off x="438912" y="1572768"/>
             <a:ext cx="2377440" cy="201168"/>
           </a:xfrm>
           <a:prstGeom prst="rect">
@@ -25713,34 +25749,2096 @@
                 </a:solidFill>
                 <a:latin typeface="Calibri"/>
               </a:rPr>
-              <a:t>FULL COURT  (40m x 20m)</a:t>
+              <a:t>DIRECTIONAL MARKERS  —  rotate the group to show body orientation</a:t>
             </a:r>
           </a:p>
         </p:txBody>
       </p:sp>
       <p:grpSp>
         <p:nvGrpSpPr>
-          <p:cNvPr id="9005" name="Library full court"/>
+          <p:cNvPr id="9005" name="dm_A"/>
           <p:cNvGrpSpPr/>
           <p:nvPr/>
         </p:nvGrpSpPr>
         <p:grpSpPr>
           <a:xfrm>
-            <a:off x="438912" y="2423160"/>
-            <a:ext cx="4151376" cy="2011680"/>
-            <a:chOff x="438912" y="2423160"/>
-            <a:chExt cx="4151376" cy="2011680"/>
+            <a:off x="429768" y="1819656"/>
+            <a:ext cx="128016" cy="208666"/>
+            <a:chOff x="429768" y="1819656"/>
+            <a:chExt cx="128016" cy="208666"/>
           </a:xfrm>
         </p:grpSpPr>
         <p:sp>
           <p:nvSpPr>
-            <p:cNvPr id="38" name="Rectangle 37"/>
+            <p:cNvPr id="39" name="Isosceles Triangle 38"/>
             <p:cNvSpPr/>
             <p:nvPr/>
           </p:nvSpPr>
           <p:spPr>
             <a:xfrm>
-              <a:off x="502920" y="2423160"/>
+              <a:off x="448970" y="1819656"/>
+              <a:ext cx="89611" cy="70409"/>
+            </a:xfrm>
+            <a:prstGeom prst="triangle">
+              <a:avLst/>
+            </a:prstGeom>
+            <a:solidFill>
+              <a:srgbClr val="0057B8"/>
+            </a:solidFill>
+            <a:ln>
+              <a:noFill/>
+            </a:ln>
+            <a:effectLst/>
+          </p:spPr>
+          <p:style>
+            <a:lnRef idx="1">
+              <a:schemeClr val="accent1"/>
+            </a:lnRef>
+            <a:fillRef idx="3">
+              <a:schemeClr val="accent1"/>
+            </a:fillRef>
+            <a:effectRef idx="2">
+              <a:schemeClr val="accent1"/>
+            </a:effectRef>
+            <a:fontRef idx="minor">
+              <a:schemeClr val="lt1"/>
+            </a:fontRef>
+          </p:style>
+          <p:txBody>
+            <a:bodyPr rtlCol="0" anchor="ctr"/>
+            <a:lstStyle/>
+            <a:p>
+              <a:pPr algn="ctr"/>
+            </a:p>
+          </p:txBody>
+        </p:sp>
+        <p:sp>
+          <p:nvSpPr>
+            <p:cNvPr id="40" name="Oval 39"/>
+            <p:cNvSpPr/>
+            <p:nvPr/>
+          </p:nvSpPr>
+          <p:spPr>
+            <a:xfrm>
+              <a:off x="429768" y="1900306"/>
+              <a:ext cx="128016" cy="128016"/>
+            </a:xfrm>
+            <a:prstGeom prst="ellipse">
+              <a:avLst/>
+            </a:prstGeom>
+            <a:solidFill>
+              <a:srgbClr val="0057B8"/>
+            </a:solidFill>
+            <a:ln>
+              <a:noFill/>
+            </a:ln>
+            <a:effectLst/>
+          </p:spPr>
+          <p:style>
+            <a:lnRef idx="1">
+              <a:schemeClr val="accent1"/>
+            </a:lnRef>
+            <a:fillRef idx="3">
+              <a:schemeClr val="accent1"/>
+            </a:fillRef>
+            <a:effectRef idx="2">
+              <a:schemeClr val="accent1"/>
+            </a:effectRef>
+            <a:fontRef idx="minor">
+              <a:schemeClr val="lt1"/>
+            </a:fontRef>
+          </p:style>
+          <p:txBody>
+            <a:bodyPr rtlCol="0" anchor="ctr" wrap="none" lIns="0" rIns="0" tIns="0" bIns="0"/>
+            <a:lstStyle/>
+            <a:p>
+              <a:pPr algn="ctr"/>
+              <a:r>
+                <a:rPr sz="700" b="1">
+                  <a:solidFill>
+                    <a:srgbClr val="FFFFFF"/>
+                  </a:solidFill>
+                  <a:latin typeface="Calibri"/>
+                </a:rPr>
+                <a:t>A</a:t>
+              </a:r>
+            </a:p>
+          </p:txBody>
+        </p:sp>
+      </p:grpSp>
+      <p:sp>
+        <p:nvSpPr>
+          <p:cNvPr id="9006" name="TextBox 9005"/>
+          <p:cNvSpPr txBox="1"/>
+          <p:nvPr/>
+        </p:nvSpPr>
+        <p:spPr>
+          <a:xfrm>
+            <a:off x="402336" y="2055754"/>
+            <a:ext cx="402336" cy="164592"/>
+          </a:xfrm>
+          <a:prstGeom prst="rect">
+            <a:avLst/>
+          </a:prstGeom>
+          <a:noFill/>
+          <a:effectLst/>
+        </p:spPr>
+        <p:txBody>
+          <a:bodyPr wrap="square" anchor="t" lIns="27432" rIns="27432" tIns="13716" bIns="13716">
+            <a:spAutoFit/>
+          </a:bodyPr>
+          <a:lstStyle/>
+          <a:p>
+            <a:pPr algn="ctr"/>
+            <a:r>
+              <a:rPr sz="650" b="0" lang="en-GB">
+                <a:solidFill>
+                  <a:srgbClr val="6B6B6B"/>
+                </a:solidFill>
+                <a:latin typeface="Calibri"/>
+              </a:rPr>
+              <a:t>Attacker</a:t>
+            </a:r>
+          </a:p>
+        </p:txBody>
+      </p:sp>
+      <p:grpSp>
+        <p:nvGrpSpPr>
+          <p:cNvPr id="9006" name="dm_D"/>
+          <p:cNvGrpSpPr/>
+          <p:nvPr/>
+        </p:nvGrpSpPr>
+        <p:grpSpPr>
+          <a:xfrm>
+            <a:off x="960120" y="1819656"/>
+            <a:ext cx="128016" cy="208666"/>
+            <a:chOff x="960120" y="1819656"/>
+            <a:chExt cx="128016" cy="208666"/>
+          </a:xfrm>
+        </p:grpSpPr>
+        <p:sp>
+          <p:nvSpPr>
+            <p:cNvPr id="9007" name="Isosceles Triangle 9006"/>
+            <p:cNvSpPr/>
+            <p:nvPr/>
+          </p:nvSpPr>
+          <p:spPr>
+            <a:xfrm>
+              <a:off x="979322" y="1819656"/>
+              <a:ext cx="89611" cy="70409"/>
+            </a:xfrm>
+            <a:prstGeom prst="triangle">
+              <a:avLst/>
+            </a:prstGeom>
+            <a:solidFill>
+              <a:srgbClr val="6B6B6B"/>
+            </a:solidFill>
+            <a:ln>
+              <a:noFill/>
+            </a:ln>
+            <a:effectLst/>
+          </p:spPr>
+          <p:style>
+            <a:lnRef idx="1">
+              <a:schemeClr val="accent1"/>
+            </a:lnRef>
+            <a:fillRef idx="3">
+              <a:schemeClr val="accent1"/>
+            </a:fillRef>
+            <a:effectRef idx="2">
+              <a:schemeClr val="accent1"/>
+            </a:effectRef>
+            <a:fontRef idx="minor">
+              <a:schemeClr val="lt1"/>
+            </a:fontRef>
+          </p:style>
+          <p:txBody>
+            <a:bodyPr rtlCol="0" anchor="ctr"/>
+            <a:lstStyle/>
+            <a:p>
+              <a:pPr algn="ctr"/>
+            </a:p>
+          </p:txBody>
+        </p:sp>
+        <p:sp>
+          <p:nvSpPr>
+            <p:cNvPr id="9008" name="Oval 9007"/>
+            <p:cNvSpPr/>
+            <p:nvPr/>
+          </p:nvSpPr>
+          <p:spPr>
+            <a:xfrm>
+              <a:off x="960120" y="1900306"/>
+              <a:ext cx="128016" cy="128016"/>
+            </a:xfrm>
+            <a:prstGeom prst="ellipse">
+              <a:avLst/>
+            </a:prstGeom>
+            <a:solidFill>
+              <a:srgbClr val="FFFFFF"/>
+            </a:solidFill>
+            <a:ln w="12700">
+              <a:solidFill>
+                <a:srgbClr val="6B6B6B"/>
+              </a:solidFill>
+            </a:ln>
+            <a:effectLst/>
+          </p:spPr>
+          <p:style>
+            <a:lnRef idx="1">
+              <a:schemeClr val="accent1"/>
+            </a:lnRef>
+            <a:fillRef idx="3">
+              <a:schemeClr val="accent1"/>
+            </a:fillRef>
+            <a:effectRef idx="2">
+              <a:schemeClr val="accent1"/>
+            </a:effectRef>
+            <a:fontRef idx="minor">
+              <a:schemeClr val="lt1"/>
+            </a:fontRef>
+          </p:style>
+          <p:txBody>
+            <a:bodyPr rtlCol="0" anchor="ctr" wrap="none" lIns="0" rIns="0" tIns="0" bIns="0"/>
+            <a:lstStyle/>
+            <a:p>
+              <a:pPr algn="ctr"/>
+              <a:r>
+                <a:rPr sz="700" b="1">
+                  <a:solidFill>
+                    <a:srgbClr val="6B6B6B"/>
+                  </a:solidFill>
+                  <a:latin typeface="Calibri"/>
+                </a:rPr>
+                <a:t>D</a:t>
+              </a:r>
+            </a:p>
+          </p:txBody>
+        </p:sp>
+      </p:grpSp>
+      <p:sp>
+        <p:nvSpPr>
+          <p:cNvPr id="9009" name="TextBox 9008"/>
+          <p:cNvSpPr txBox="1"/>
+          <p:nvPr/>
+        </p:nvSpPr>
+        <p:spPr>
+          <a:xfrm>
+            <a:off x="932688" y="2055754"/>
+            <a:ext cx="402336" cy="164592"/>
+          </a:xfrm>
+          <a:prstGeom prst="rect">
+            <a:avLst/>
+          </a:prstGeom>
+          <a:noFill/>
+          <a:effectLst/>
+        </p:spPr>
+        <p:txBody>
+          <a:bodyPr wrap="square" anchor="t" lIns="27432" rIns="27432" tIns="13716" bIns="13716">
+            <a:spAutoFit/>
+          </a:bodyPr>
+          <a:lstStyle/>
+          <a:p>
+            <a:pPr algn="ctr"/>
+            <a:r>
+              <a:rPr sz="650" b="0" lang="en-GB">
+                <a:solidFill>
+                  <a:srgbClr val="6B6B6B"/>
+                </a:solidFill>
+                <a:latin typeface="Calibri"/>
+              </a:rPr>
+              <a:t>Defender</a:t>
+            </a:r>
+          </a:p>
+        </p:txBody>
+      </p:sp>
+      <p:grpSp>
+        <p:nvGrpSpPr>
+          <p:cNvPr id="9007" name="dm_G"/>
+          <p:cNvGrpSpPr/>
+          <p:nvPr/>
+        </p:nvGrpSpPr>
+        <p:grpSpPr>
+          <a:xfrm>
+            <a:off x="1490472" y="1819656"/>
+            <a:ext cx="128016" cy="208666"/>
+            <a:chOff x="1490472" y="1819656"/>
+            <a:chExt cx="128016" cy="208666"/>
+          </a:xfrm>
+        </p:grpSpPr>
+        <p:sp>
+          <p:nvSpPr>
+            <p:cNvPr id="9010" name="Isosceles Triangle 9009"/>
+            <p:cNvSpPr/>
+            <p:nvPr/>
+          </p:nvSpPr>
+          <p:spPr>
+            <a:xfrm>
+              <a:off x="1509674" y="1819656"/>
+              <a:ext cx="89611" cy="70409"/>
+            </a:xfrm>
+            <a:prstGeom prst="triangle">
+              <a:avLst/>
+            </a:prstGeom>
+            <a:solidFill>
+              <a:srgbClr val="1A1A1A"/>
+            </a:solidFill>
+            <a:ln>
+              <a:noFill/>
+            </a:ln>
+            <a:effectLst/>
+          </p:spPr>
+          <p:style>
+            <a:lnRef idx="1">
+              <a:schemeClr val="accent1"/>
+            </a:lnRef>
+            <a:fillRef idx="3">
+              <a:schemeClr val="accent1"/>
+            </a:fillRef>
+            <a:effectRef idx="2">
+              <a:schemeClr val="accent1"/>
+            </a:effectRef>
+            <a:fontRef idx="minor">
+              <a:schemeClr val="lt1"/>
+            </a:fontRef>
+          </p:style>
+          <p:txBody>
+            <a:bodyPr rtlCol="0" anchor="ctr"/>
+            <a:lstStyle/>
+            <a:p>
+              <a:pPr algn="ctr"/>
+            </a:p>
+          </p:txBody>
+        </p:sp>
+        <p:sp>
+          <p:nvSpPr>
+            <p:cNvPr id="9011" name="Oval 9010"/>
+            <p:cNvSpPr/>
+            <p:nvPr/>
+          </p:nvSpPr>
+          <p:spPr>
+            <a:xfrm>
+              <a:off x="1490472" y="1900306"/>
+              <a:ext cx="128016" cy="128016"/>
+            </a:xfrm>
+            <a:prstGeom prst="ellipse">
+              <a:avLst/>
+            </a:prstGeom>
+            <a:solidFill>
+              <a:srgbClr val="1A1A1A"/>
+            </a:solidFill>
+            <a:ln>
+              <a:noFill/>
+            </a:ln>
+            <a:effectLst/>
+          </p:spPr>
+          <p:style>
+            <a:lnRef idx="1">
+              <a:schemeClr val="accent1"/>
+            </a:lnRef>
+            <a:fillRef idx="3">
+              <a:schemeClr val="accent1"/>
+            </a:fillRef>
+            <a:effectRef idx="2">
+              <a:schemeClr val="accent1"/>
+            </a:effectRef>
+            <a:fontRef idx="minor">
+              <a:schemeClr val="lt1"/>
+            </a:fontRef>
+          </p:style>
+          <p:txBody>
+            <a:bodyPr rtlCol="0" anchor="ctr" wrap="none" lIns="0" rIns="0" tIns="0" bIns="0"/>
+            <a:lstStyle/>
+            <a:p>
+              <a:pPr algn="ctr"/>
+              <a:r>
+                <a:rPr sz="700" b="1">
+                  <a:solidFill>
+                    <a:srgbClr val="FFFFFF"/>
+                  </a:solidFill>
+                  <a:latin typeface="Calibri"/>
+                </a:rPr>
+                <a:t>G</a:t>
+              </a:r>
+            </a:p>
+          </p:txBody>
+        </p:sp>
+      </p:grpSp>
+      <p:sp>
+        <p:nvSpPr>
+          <p:cNvPr id="9012" name="TextBox 9011"/>
+          <p:cNvSpPr txBox="1"/>
+          <p:nvPr/>
+        </p:nvSpPr>
+        <p:spPr>
+          <a:xfrm>
+            <a:off x="1463040" y="2055754"/>
+            <a:ext cx="402336" cy="164592"/>
+          </a:xfrm>
+          <a:prstGeom prst="rect">
+            <a:avLst/>
+          </a:prstGeom>
+          <a:noFill/>
+          <a:effectLst/>
+        </p:spPr>
+        <p:txBody>
+          <a:bodyPr wrap="square" anchor="t" lIns="27432" rIns="27432" tIns="13716" bIns="13716">
+            <a:spAutoFit/>
+          </a:bodyPr>
+          <a:lstStyle/>
+          <a:p>
+            <a:pPr algn="ctr"/>
+            <a:r>
+              <a:rPr sz="650" b="0" lang="en-GB">
+                <a:solidFill>
+                  <a:srgbClr val="6B6B6B"/>
+                </a:solidFill>
+                <a:latin typeface="Calibri"/>
+              </a:rPr>
+              <a:t>GK</a:t>
+            </a:r>
+          </a:p>
+        </p:txBody>
+      </p:sp>
+      <p:grpSp>
+        <p:nvGrpSpPr>
+          <p:cNvPr id="9008" name="dm_N"/>
+          <p:cNvGrpSpPr/>
+          <p:nvPr/>
+        </p:nvGrpSpPr>
+        <p:grpSpPr>
+          <a:xfrm>
+            <a:off x="2020824" y="1819656"/>
+            <a:ext cx="128016" cy="208666"/>
+            <a:chOff x="2020824" y="1819656"/>
+            <a:chExt cx="128016" cy="208666"/>
+          </a:xfrm>
+        </p:grpSpPr>
+        <p:sp>
+          <p:nvSpPr>
+            <p:cNvPr id="9013" name="Isosceles Triangle 9012"/>
+            <p:cNvSpPr/>
+            <p:nvPr/>
+          </p:nvSpPr>
+          <p:spPr>
+            <a:xfrm>
+              <a:off x="2040026" y="1819656"/>
+              <a:ext cx="89611" cy="70409"/>
+            </a:xfrm>
+            <a:prstGeom prst="triangle">
+              <a:avLst/>
+            </a:prstGeom>
+            <a:solidFill>
+              <a:srgbClr val="6B6B6B"/>
+            </a:solidFill>
+            <a:ln>
+              <a:noFill/>
+            </a:ln>
+            <a:effectLst/>
+          </p:spPr>
+          <p:style>
+            <a:lnRef idx="1">
+              <a:schemeClr val="accent1"/>
+            </a:lnRef>
+            <a:fillRef idx="3">
+              <a:schemeClr val="accent1"/>
+            </a:fillRef>
+            <a:effectRef idx="2">
+              <a:schemeClr val="accent1"/>
+            </a:effectRef>
+            <a:fontRef idx="minor">
+              <a:schemeClr val="lt1"/>
+            </a:fontRef>
+          </p:style>
+          <p:txBody>
+            <a:bodyPr rtlCol="0" anchor="ctr"/>
+            <a:lstStyle/>
+            <a:p>
+              <a:pPr algn="ctr"/>
+            </a:p>
+          </p:txBody>
+        </p:sp>
+        <p:sp>
+          <p:nvSpPr>
+            <p:cNvPr id="9014" name="Oval 9013"/>
+            <p:cNvSpPr/>
+            <p:nvPr/>
+          </p:nvSpPr>
+          <p:spPr>
+            <a:xfrm>
+              <a:off x="2020824" y="1900306"/>
+              <a:ext cx="128016" cy="128016"/>
+            </a:xfrm>
+            <a:prstGeom prst="ellipse">
+              <a:avLst/>
+            </a:prstGeom>
+            <a:solidFill>
+              <a:srgbClr val="FFFFFF"/>
+            </a:solidFill>
+            <a:ln w="12700">
+              <a:solidFill>
+                <a:srgbClr val="6B6B6B"/>
+              </a:solidFill>
+              <a:prstDash val="dash"/>
+            </a:ln>
+            <a:effectLst/>
+          </p:spPr>
+          <p:style>
+            <a:lnRef idx="1">
+              <a:schemeClr val="accent1"/>
+            </a:lnRef>
+            <a:fillRef idx="3">
+              <a:schemeClr val="accent1"/>
+            </a:fillRef>
+            <a:effectRef idx="2">
+              <a:schemeClr val="accent1"/>
+            </a:effectRef>
+            <a:fontRef idx="minor">
+              <a:schemeClr val="lt1"/>
+            </a:fontRef>
+          </p:style>
+          <p:txBody>
+            <a:bodyPr rtlCol="0" anchor="ctr" wrap="none" lIns="0" rIns="0" tIns="0" bIns="0"/>
+            <a:lstStyle/>
+            <a:p>
+              <a:pPr algn="ctr"/>
+              <a:r>
+                <a:rPr sz="700" b="1">
+                  <a:solidFill>
+                    <a:srgbClr val="6B6B6B"/>
+                  </a:solidFill>
+                  <a:latin typeface="Calibri"/>
+                </a:rPr>
+                <a:t>N</a:t>
+              </a:r>
+            </a:p>
+          </p:txBody>
+        </p:sp>
+      </p:grpSp>
+      <p:sp>
+        <p:nvSpPr>
+          <p:cNvPr id="9015" name="TextBox 9014"/>
+          <p:cNvSpPr txBox="1"/>
+          <p:nvPr/>
+        </p:nvSpPr>
+        <p:spPr>
+          <a:xfrm>
+            <a:off x="1993392" y="2055754"/>
+            <a:ext cx="402336" cy="164592"/>
+          </a:xfrm>
+          <a:prstGeom prst="rect">
+            <a:avLst/>
+          </a:prstGeom>
+          <a:noFill/>
+          <a:effectLst/>
+        </p:spPr>
+        <p:txBody>
+          <a:bodyPr wrap="square" anchor="t" lIns="27432" rIns="27432" tIns="13716" bIns="13716">
+            <a:spAutoFit/>
+          </a:bodyPr>
+          <a:lstStyle/>
+          <a:p>
+            <a:pPr algn="ctr"/>
+            <a:r>
+              <a:rPr sz="650" b="0" lang="en-GB">
+                <a:solidFill>
+                  <a:srgbClr val="6B6B6B"/>
+                </a:solidFill>
+                <a:latin typeface="Calibri"/>
+              </a:rPr>
+              <a:t>Neutral</a:t>
+            </a:r>
+          </a:p>
+        </p:txBody>
+      </p:sp>
+      <p:sp>
+        <p:nvSpPr>
+          <p:cNvPr id="9016" name="Rectangle 9015"/>
+          <p:cNvSpPr/>
+          <p:nvPr/>
+        </p:nvSpPr>
+        <p:spPr>
+          <a:xfrm>
+            <a:off x="2788920" y="1773936"/>
+            <a:ext cx="4114800" cy="457200"/>
+          </a:xfrm>
+          <a:prstGeom prst="rect">
+            <a:avLst/>
+          </a:prstGeom>
+          <a:solidFill>
+            <a:srgbClr val="FAFAFA"/>
+          </a:solidFill>
+          <a:ln w="9525">
+            <a:solidFill>
+              <a:srgbClr val="D9D9D9"/>
+            </a:solidFill>
+          </a:ln>
+          <a:effectLst/>
+        </p:spPr>
+        <p:style>
+          <a:lnRef idx="1">
+            <a:schemeClr val="accent1"/>
+          </a:lnRef>
+          <a:fillRef idx="3">
+            <a:schemeClr val="accent1"/>
+          </a:fillRef>
+          <a:effectRef idx="2">
+            <a:schemeClr val="accent1"/>
+          </a:effectRef>
+          <a:fontRef idx="minor">
+            <a:schemeClr val="lt1"/>
+          </a:fontRef>
+        </p:style>
+        <p:txBody>
+          <a:bodyPr rtlCol="0" anchor="ctr" wrap="square" lIns="54864" rIns="54864" tIns="36576" bIns="36576"/>
+          <a:lstStyle/>
+          <a:p>
+            <a:pPr algn="ctr"/>
+            <a:r>
+              <a:rPr sz="750">
+                <a:solidFill>
+                  <a:srgbClr val="6B6B6B"/>
+                </a:solidFill>
+                <a:latin typeface="Calibri"/>
+              </a:rPr>
+              <a:t>HOW TO USE  ·  Select any directional marker → right-click → Format Shape → Rotation.  Or drag the circular rotation handle above the shape.  The triangle always points where the player faces.</a:t>
+            </a:r>
+          </a:p>
+        </p:txBody>
+      </p:sp>
+      <p:cxnSp>
+        <p:nvCxnSpPr>
+          <p:cNvPr id="9017" name="Connector 9016"/>
+          <p:cNvCxnSpPr/>
+          <p:nvPr/>
+        </p:nvCxnSpPr>
+        <p:spPr>
+          <a:xfrm>
+            <a:off x="137160" y="2359152"/>
+            <a:ext cx="11917375" cy="0"/>
+          </a:xfrm>
+          <a:prstGeom prst="line">
+            <a:avLst/>
+          </a:prstGeom>
+          <a:ln w="6350">
+            <a:solidFill>
+              <a:srgbClr val="D9D9D9"/>
+            </a:solidFill>
+          </a:ln>
+          <a:effectLst/>
+        </p:spPr>
+        <p:style>
+          <a:lnRef idx="2">
+            <a:schemeClr val="accent1"/>
+          </a:lnRef>
+          <a:fillRef idx="0">
+            <a:schemeClr val="accent1"/>
+          </a:fillRef>
+          <a:effectRef idx="1">
+            <a:schemeClr val="accent1"/>
+          </a:effectRef>
+          <a:fontRef idx="minor">
+            <a:schemeClr val="tx1"/>
+          </a:fontRef>
+        </p:style>
+      </p:cxnSp>
+      <p:sp>
+        <p:nvSpPr>
+          <p:cNvPr id="9018" name="TextBox 9017"/>
+          <p:cNvSpPr txBox="1"/>
+          <p:nvPr/>
+        </p:nvSpPr>
+        <p:spPr>
+          <a:xfrm>
+            <a:off x="365760" y="2423160"/>
+            <a:ext cx="2194560" cy="182880"/>
+          </a:xfrm>
+          <a:prstGeom prst="rect">
+            <a:avLst/>
+          </a:prstGeom>
+          <a:noFill/>
+          <a:effectLst/>
+        </p:spPr>
+        <p:txBody>
+          <a:bodyPr wrap="square" anchor="t" lIns="27432" rIns="27432" tIns="13716" bIns="13716">
+            <a:spAutoFit/>
+          </a:bodyPr>
+          <a:lstStyle/>
+          <a:p>
+            <a:pPr algn="l"/>
+            <a:r>
+              <a:rPr sz="800" b="1" lang="en-GB">
+                <a:solidFill>
+                  <a:srgbClr val="0057B8"/>
+                </a:solidFill>
+                <a:latin typeface="Calibri"/>
+              </a:rPr>
+              <a:t>TEAM A  </a:t>
+            </a:r>
+            <a:r>
+              <a:rPr sz="750" b="0" lang="en-GB">
+                <a:solidFill>
+                  <a:srgbClr val="6B6B6B"/>
+                </a:solidFill>
+                <a:latin typeface="Calibri"/>
+              </a:rPr>
+              <a:t>your team</a:t>
+            </a:r>
+          </a:p>
+        </p:txBody>
+      </p:sp>
+      <p:grpSp>
+        <p:nvGrpSpPr>
+          <p:cNvPr id="9009" name="dm_1"/>
+          <p:cNvGrpSpPr/>
+          <p:nvPr/>
+        </p:nvGrpSpPr>
+        <p:grpSpPr>
+          <a:xfrm>
+            <a:off x="365760" y="2642616"/>
+            <a:ext cx="128016" cy="208666"/>
+            <a:chOff x="365760" y="2642616"/>
+            <a:chExt cx="128016" cy="208666"/>
+          </a:xfrm>
+        </p:grpSpPr>
+        <p:sp>
+          <p:nvSpPr>
+            <p:cNvPr id="9019" name="Isosceles Triangle 9018"/>
+            <p:cNvSpPr/>
+            <p:nvPr/>
+          </p:nvSpPr>
+          <p:spPr>
+            <a:xfrm>
+              <a:off x="384962" y="2642616"/>
+              <a:ext cx="89611" cy="70409"/>
+            </a:xfrm>
+            <a:prstGeom prst="triangle">
+              <a:avLst/>
+            </a:prstGeom>
+            <a:solidFill>
+              <a:srgbClr val="0057B8"/>
+            </a:solidFill>
+            <a:ln>
+              <a:noFill/>
+            </a:ln>
+            <a:effectLst/>
+          </p:spPr>
+          <p:style>
+            <a:lnRef idx="1">
+              <a:schemeClr val="accent1"/>
+            </a:lnRef>
+            <a:fillRef idx="3">
+              <a:schemeClr val="accent1"/>
+            </a:fillRef>
+            <a:effectRef idx="2">
+              <a:schemeClr val="accent1"/>
+            </a:effectRef>
+            <a:fontRef idx="minor">
+              <a:schemeClr val="lt1"/>
+            </a:fontRef>
+          </p:style>
+          <p:txBody>
+            <a:bodyPr rtlCol="0" anchor="ctr"/>
+            <a:lstStyle/>
+            <a:p>
+              <a:pPr algn="ctr"/>
+            </a:p>
+          </p:txBody>
+        </p:sp>
+        <p:sp>
+          <p:nvSpPr>
+            <p:cNvPr id="9020" name="Oval 9019"/>
+            <p:cNvSpPr/>
+            <p:nvPr/>
+          </p:nvSpPr>
+          <p:spPr>
+            <a:xfrm>
+              <a:off x="365760" y="2723266"/>
+              <a:ext cx="128016" cy="128016"/>
+            </a:xfrm>
+            <a:prstGeom prst="ellipse">
+              <a:avLst/>
+            </a:prstGeom>
+            <a:solidFill>
+              <a:srgbClr val="0057B8"/>
+            </a:solidFill>
+            <a:ln>
+              <a:noFill/>
+            </a:ln>
+            <a:effectLst/>
+          </p:spPr>
+          <p:style>
+            <a:lnRef idx="1">
+              <a:schemeClr val="accent1"/>
+            </a:lnRef>
+            <a:fillRef idx="3">
+              <a:schemeClr val="accent1"/>
+            </a:fillRef>
+            <a:effectRef idx="2">
+              <a:schemeClr val="accent1"/>
+            </a:effectRef>
+            <a:fontRef idx="minor">
+              <a:schemeClr val="lt1"/>
+            </a:fontRef>
+          </p:style>
+          <p:txBody>
+            <a:bodyPr rtlCol="0" anchor="ctr" wrap="none" lIns="0" rIns="0" tIns="0" bIns="0"/>
+            <a:lstStyle/>
+            <a:p>
+              <a:pPr algn="ctr"/>
+              <a:r>
+                <a:rPr sz="700" b="1">
+                  <a:solidFill>
+                    <a:srgbClr val="FFFFFF"/>
+                  </a:solidFill>
+                  <a:latin typeface="Calibri"/>
+                </a:rPr>
+                <a:t>1</a:t>
+              </a:r>
+            </a:p>
+          </p:txBody>
+        </p:sp>
+      </p:grpSp>
+      <p:grpSp>
+        <p:nvGrpSpPr>
+          <p:cNvPr id="9010" name="dm_2"/>
+          <p:cNvGrpSpPr/>
+          <p:nvPr/>
+        </p:nvGrpSpPr>
+        <p:grpSpPr>
+          <a:xfrm>
+            <a:off x="768096" y="2642616"/>
+            <a:ext cx="128016" cy="208666"/>
+            <a:chOff x="768096" y="2642616"/>
+            <a:chExt cx="128016" cy="208666"/>
+          </a:xfrm>
+        </p:grpSpPr>
+        <p:sp>
+          <p:nvSpPr>
+            <p:cNvPr id="9021" name="Isosceles Triangle 9020"/>
+            <p:cNvSpPr/>
+            <p:nvPr/>
+          </p:nvSpPr>
+          <p:spPr>
+            <a:xfrm>
+              <a:off x="787298" y="2642616"/>
+              <a:ext cx="89611" cy="70409"/>
+            </a:xfrm>
+            <a:prstGeom prst="triangle">
+              <a:avLst/>
+            </a:prstGeom>
+            <a:solidFill>
+              <a:srgbClr val="0057B8"/>
+            </a:solidFill>
+            <a:ln>
+              <a:noFill/>
+            </a:ln>
+            <a:effectLst/>
+          </p:spPr>
+          <p:style>
+            <a:lnRef idx="1">
+              <a:schemeClr val="accent1"/>
+            </a:lnRef>
+            <a:fillRef idx="3">
+              <a:schemeClr val="accent1"/>
+            </a:fillRef>
+            <a:effectRef idx="2">
+              <a:schemeClr val="accent1"/>
+            </a:effectRef>
+            <a:fontRef idx="minor">
+              <a:schemeClr val="lt1"/>
+            </a:fontRef>
+          </p:style>
+          <p:txBody>
+            <a:bodyPr rtlCol="0" anchor="ctr"/>
+            <a:lstStyle/>
+            <a:p>
+              <a:pPr algn="ctr"/>
+            </a:p>
+          </p:txBody>
+        </p:sp>
+        <p:sp>
+          <p:nvSpPr>
+            <p:cNvPr id="9022" name="Oval 9021"/>
+            <p:cNvSpPr/>
+            <p:nvPr/>
+          </p:nvSpPr>
+          <p:spPr>
+            <a:xfrm>
+              <a:off x="768096" y="2723266"/>
+              <a:ext cx="128016" cy="128016"/>
+            </a:xfrm>
+            <a:prstGeom prst="ellipse">
+              <a:avLst/>
+            </a:prstGeom>
+            <a:solidFill>
+              <a:srgbClr val="0057B8"/>
+            </a:solidFill>
+            <a:ln>
+              <a:noFill/>
+            </a:ln>
+            <a:effectLst/>
+          </p:spPr>
+          <p:style>
+            <a:lnRef idx="1">
+              <a:schemeClr val="accent1"/>
+            </a:lnRef>
+            <a:fillRef idx="3">
+              <a:schemeClr val="accent1"/>
+            </a:fillRef>
+            <a:effectRef idx="2">
+              <a:schemeClr val="accent1"/>
+            </a:effectRef>
+            <a:fontRef idx="minor">
+              <a:schemeClr val="lt1"/>
+            </a:fontRef>
+          </p:style>
+          <p:txBody>
+            <a:bodyPr rtlCol="0" anchor="ctr" wrap="none" lIns="0" rIns="0" tIns="0" bIns="0"/>
+            <a:lstStyle/>
+            <a:p>
+              <a:pPr algn="ctr"/>
+              <a:r>
+                <a:rPr sz="700" b="1">
+                  <a:solidFill>
+                    <a:srgbClr val="FFFFFF"/>
+                  </a:solidFill>
+                  <a:latin typeface="Calibri"/>
+                </a:rPr>
+                <a:t>2</a:t>
+              </a:r>
+            </a:p>
+          </p:txBody>
+        </p:sp>
+      </p:grpSp>
+      <p:grpSp>
+        <p:nvGrpSpPr>
+          <p:cNvPr id="9011" name="dm_3"/>
+          <p:cNvGrpSpPr/>
+          <p:nvPr/>
+        </p:nvGrpSpPr>
+        <p:grpSpPr>
+          <a:xfrm>
+            <a:off x="1170432" y="2642616"/>
+            <a:ext cx="128016" cy="208666"/>
+            <a:chOff x="1170432" y="2642616"/>
+            <a:chExt cx="128016" cy="208666"/>
+          </a:xfrm>
+        </p:grpSpPr>
+        <p:sp>
+          <p:nvSpPr>
+            <p:cNvPr id="9023" name="Isosceles Triangle 9022"/>
+            <p:cNvSpPr/>
+            <p:nvPr/>
+          </p:nvSpPr>
+          <p:spPr>
+            <a:xfrm>
+              <a:off x="1189634" y="2642616"/>
+              <a:ext cx="89611" cy="70409"/>
+            </a:xfrm>
+            <a:prstGeom prst="triangle">
+              <a:avLst/>
+            </a:prstGeom>
+            <a:solidFill>
+              <a:srgbClr val="0057B8"/>
+            </a:solidFill>
+            <a:ln>
+              <a:noFill/>
+            </a:ln>
+            <a:effectLst/>
+          </p:spPr>
+          <p:style>
+            <a:lnRef idx="1">
+              <a:schemeClr val="accent1"/>
+            </a:lnRef>
+            <a:fillRef idx="3">
+              <a:schemeClr val="accent1"/>
+            </a:fillRef>
+            <a:effectRef idx="2">
+              <a:schemeClr val="accent1"/>
+            </a:effectRef>
+            <a:fontRef idx="minor">
+              <a:schemeClr val="lt1"/>
+            </a:fontRef>
+          </p:style>
+          <p:txBody>
+            <a:bodyPr rtlCol="0" anchor="ctr"/>
+            <a:lstStyle/>
+            <a:p>
+              <a:pPr algn="ctr"/>
+            </a:p>
+          </p:txBody>
+        </p:sp>
+        <p:sp>
+          <p:nvSpPr>
+            <p:cNvPr id="9024" name="Oval 9023"/>
+            <p:cNvSpPr/>
+            <p:nvPr/>
+          </p:nvSpPr>
+          <p:spPr>
+            <a:xfrm>
+              <a:off x="1170432" y="2723266"/>
+              <a:ext cx="128016" cy="128016"/>
+            </a:xfrm>
+            <a:prstGeom prst="ellipse">
+              <a:avLst/>
+            </a:prstGeom>
+            <a:solidFill>
+              <a:srgbClr val="0057B8"/>
+            </a:solidFill>
+            <a:ln>
+              <a:noFill/>
+            </a:ln>
+            <a:effectLst/>
+          </p:spPr>
+          <p:style>
+            <a:lnRef idx="1">
+              <a:schemeClr val="accent1"/>
+            </a:lnRef>
+            <a:fillRef idx="3">
+              <a:schemeClr val="accent1"/>
+            </a:fillRef>
+            <a:effectRef idx="2">
+              <a:schemeClr val="accent1"/>
+            </a:effectRef>
+            <a:fontRef idx="minor">
+              <a:schemeClr val="lt1"/>
+            </a:fontRef>
+          </p:style>
+          <p:txBody>
+            <a:bodyPr rtlCol="0" anchor="ctr" wrap="none" lIns="0" rIns="0" tIns="0" bIns="0"/>
+            <a:lstStyle/>
+            <a:p>
+              <a:pPr algn="ctr"/>
+              <a:r>
+                <a:rPr sz="700" b="1">
+                  <a:solidFill>
+                    <a:srgbClr val="FFFFFF"/>
+                  </a:solidFill>
+                  <a:latin typeface="Calibri"/>
+                </a:rPr>
+                <a:t>3</a:t>
+              </a:r>
+            </a:p>
+          </p:txBody>
+        </p:sp>
+      </p:grpSp>
+      <p:grpSp>
+        <p:nvGrpSpPr>
+          <p:cNvPr id="9012" name="dm_4"/>
+          <p:cNvGrpSpPr/>
+          <p:nvPr/>
+        </p:nvGrpSpPr>
+        <p:grpSpPr>
+          <a:xfrm>
+            <a:off x="1572768" y="2642616"/>
+            <a:ext cx="128016" cy="208666"/>
+            <a:chOff x="1572768" y="2642616"/>
+            <a:chExt cx="128016" cy="208666"/>
+          </a:xfrm>
+        </p:grpSpPr>
+        <p:sp>
+          <p:nvSpPr>
+            <p:cNvPr id="9025" name="Isosceles Triangle 9024"/>
+            <p:cNvSpPr/>
+            <p:nvPr/>
+          </p:nvSpPr>
+          <p:spPr>
+            <a:xfrm>
+              <a:off x="1591970" y="2642616"/>
+              <a:ext cx="89611" cy="70409"/>
+            </a:xfrm>
+            <a:prstGeom prst="triangle">
+              <a:avLst/>
+            </a:prstGeom>
+            <a:solidFill>
+              <a:srgbClr val="0057B8"/>
+            </a:solidFill>
+            <a:ln>
+              <a:noFill/>
+            </a:ln>
+            <a:effectLst/>
+          </p:spPr>
+          <p:style>
+            <a:lnRef idx="1">
+              <a:schemeClr val="accent1"/>
+            </a:lnRef>
+            <a:fillRef idx="3">
+              <a:schemeClr val="accent1"/>
+            </a:fillRef>
+            <a:effectRef idx="2">
+              <a:schemeClr val="accent1"/>
+            </a:effectRef>
+            <a:fontRef idx="minor">
+              <a:schemeClr val="lt1"/>
+            </a:fontRef>
+          </p:style>
+          <p:txBody>
+            <a:bodyPr rtlCol="0" anchor="ctr"/>
+            <a:lstStyle/>
+            <a:p>
+              <a:pPr algn="ctr"/>
+            </a:p>
+          </p:txBody>
+        </p:sp>
+        <p:sp>
+          <p:nvSpPr>
+            <p:cNvPr id="9026" name="Oval 9025"/>
+            <p:cNvSpPr/>
+            <p:nvPr/>
+          </p:nvSpPr>
+          <p:spPr>
+            <a:xfrm>
+              <a:off x="1572768" y="2723266"/>
+              <a:ext cx="128016" cy="128016"/>
+            </a:xfrm>
+            <a:prstGeom prst="ellipse">
+              <a:avLst/>
+            </a:prstGeom>
+            <a:solidFill>
+              <a:srgbClr val="0057B8"/>
+            </a:solidFill>
+            <a:ln>
+              <a:noFill/>
+            </a:ln>
+            <a:effectLst/>
+          </p:spPr>
+          <p:style>
+            <a:lnRef idx="1">
+              <a:schemeClr val="accent1"/>
+            </a:lnRef>
+            <a:fillRef idx="3">
+              <a:schemeClr val="accent1"/>
+            </a:fillRef>
+            <a:effectRef idx="2">
+              <a:schemeClr val="accent1"/>
+            </a:effectRef>
+            <a:fontRef idx="minor">
+              <a:schemeClr val="lt1"/>
+            </a:fontRef>
+          </p:style>
+          <p:txBody>
+            <a:bodyPr rtlCol="0" anchor="ctr" wrap="none" lIns="0" rIns="0" tIns="0" bIns="0"/>
+            <a:lstStyle/>
+            <a:p>
+              <a:pPr algn="ctr"/>
+              <a:r>
+                <a:rPr sz="700" b="1">
+                  <a:solidFill>
+                    <a:srgbClr val="FFFFFF"/>
+                  </a:solidFill>
+                  <a:latin typeface="Calibri"/>
+                </a:rPr>
+                <a:t>4</a:t>
+              </a:r>
+            </a:p>
+          </p:txBody>
+        </p:sp>
+      </p:grpSp>
+      <p:grpSp>
+        <p:nvGrpSpPr>
+          <p:cNvPr id="9013" name="dm_5"/>
+          <p:cNvGrpSpPr/>
+          <p:nvPr/>
+        </p:nvGrpSpPr>
+        <p:grpSpPr>
+          <a:xfrm>
+            <a:off x="1975104" y="2642616"/>
+            <a:ext cx="128016" cy="208666"/>
+            <a:chOff x="1975104" y="2642616"/>
+            <a:chExt cx="128016" cy="208666"/>
+          </a:xfrm>
+        </p:grpSpPr>
+        <p:sp>
+          <p:nvSpPr>
+            <p:cNvPr id="9027" name="Isosceles Triangle 9026"/>
+            <p:cNvSpPr/>
+            <p:nvPr/>
+          </p:nvSpPr>
+          <p:spPr>
+            <a:xfrm>
+              <a:off x="1994306" y="2642616"/>
+              <a:ext cx="89611" cy="70409"/>
+            </a:xfrm>
+            <a:prstGeom prst="triangle">
+              <a:avLst/>
+            </a:prstGeom>
+            <a:solidFill>
+              <a:srgbClr val="0057B8"/>
+            </a:solidFill>
+            <a:ln>
+              <a:noFill/>
+            </a:ln>
+            <a:effectLst/>
+          </p:spPr>
+          <p:style>
+            <a:lnRef idx="1">
+              <a:schemeClr val="accent1"/>
+            </a:lnRef>
+            <a:fillRef idx="3">
+              <a:schemeClr val="accent1"/>
+            </a:fillRef>
+            <a:effectRef idx="2">
+              <a:schemeClr val="accent1"/>
+            </a:effectRef>
+            <a:fontRef idx="minor">
+              <a:schemeClr val="lt1"/>
+            </a:fontRef>
+          </p:style>
+          <p:txBody>
+            <a:bodyPr rtlCol="0" anchor="ctr"/>
+            <a:lstStyle/>
+            <a:p>
+              <a:pPr algn="ctr"/>
+            </a:p>
+          </p:txBody>
+        </p:sp>
+        <p:sp>
+          <p:nvSpPr>
+            <p:cNvPr id="9028" name="Oval 9027"/>
+            <p:cNvSpPr/>
+            <p:nvPr/>
+          </p:nvSpPr>
+          <p:spPr>
+            <a:xfrm>
+              <a:off x="1975104" y="2723266"/>
+              <a:ext cx="128016" cy="128016"/>
+            </a:xfrm>
+            <a:prstGeom prst="ellipse">
+              <a:avLst/>
+            </a:prstGeom>
+            <a:solidFill>
+              <a:srgbClr val="0057B8"/>
+            </a:solidFill>
+            <a:ln>
+              <a:noFill/>
+            </a:ln>
+            <a:effectLst/>
+          </p:spPr>
+          <p:style>
+            <a:lnRef idx="1">
+              <a:schemeClr val="accent1"/>
+            </a:lnRef>
+            <a:fillRef idx="3">
+              <a:schemeClr val="accent1"/>
+            </a:fillRef>
+            <a:effectRef idx="2">
+              <a:schemeClr val="accent1"/>
+            </a:effectRef>
+            <a:fontRef idx="minor">
+              <a:schemeClr val="lt1"/>
+            </a:fontRef>
+          </p:style>
+          <p:txBody>
+            <a:bodyPr rtlCol="0" anchor="ctr" wrap="none" lIns="0" rIns="0" tIns="0" bIns="0"/>
+            <a:lstStyle/>
+            <a:p>
+              <a:pPr algn="ctr"/>
+              <a:r>
+                <a:rPr sz="700" b="1">
+                  <a:solidFill>
+                    <a:srgbClr val="FFFFFF"/>
+                  </a:solidFill>
+                  <a:latin typeface="Calibri"/>
+                </a:rPr>
+                <a:t>5</a:t>
+              </a:r>
+            </a:p>
+          </p:txBody>
+        </p:sp>
+      </p:grpSp>
+      <p:sp>
+        <p:nvSpPr>
+          <p:cNvPr id="9029" name="TextBox 9028"/>
+          <p:cNvSpPr txBox="1"/>
+          <p:nvPr/>
+        </p:nvSpPr>
+        <p:spPr>
+          <a:xfrm>
+            <a:off x="2514600" y="2423160"/>
+            <a:ext cx="2743200" cy="182880"/>
+          </a:xfrm>
+          <a:prstGeom prst="rect">
+            <a:avLst/>
+          </a:prstGeom>
+          <a:noFill/>
+          <a:effectLst/>
+        </p:spPr>
+        <p:txBody>
+          <a:bodyPr wrap="square" anchor="t" lIns="27432" rIns="27432" tIns="13716" bIns="13716">
+            <a:spAutoFit/>
+          </a:bodyPr>
+          <a:lstStyle/>
+          <a:p>
+            <a:pPr algn="l"/>
+            <a:r>
+              <a:rPr sz="800" b="1" lang="en-GB">
+                <a:solidFill>
+                  <a:srgbClr val="1A1A1A"/>
+                </a:solidFill>
+                <a:latin typeface="Calibri"/>
+              </a:rPr>
+              <a:t>TEAM B  </a:t>
+            </a:r>
+            <a:r>
+              <a:rPr sz="750" b="0" lang="en-GB">
+                <a:solidFill>
+                  <a:srgbClr val="6B6B6B"/>
+                </a:solidFill>
+                <a:latin typeface="Calibri"/>
+              </a:rPr>
+              <a:t>opposition — change fill colour to match</a:t>
+            </a:r>
+          </a:p>
+        </p:txBody>
+      </p:sp>
+      <p:grpSp>
+        <p:nvGrpSpPr>
+          <p:cNvPr id="9014" name="dm_1"/>
+          <p:cNvGrpSpPr/>
+          <p:nvPr/>
+        </p:nvGrpSpPr>
+        <p:grpSpPr>
+          <a:xfrm>
+            <a:off x="2514600" y="2642616"/>
+            <a:ext cx="128016" cy="208666"/>
+            <a:chOff x="2514600" y="2642616"/>
+            <a:chExt cx="128016" cy="208666"/>
+          </a:xfrm>
+        </p:grpSpPr>
+        <p:sp>
+          <p:nvSpPr>
+            <p:cNvPr id="9030" name="Isosceles Triangle 9029"/>
+            <p:cNvSpPr/>
+            <p:nvPr/>
+          </p:nvSpPr>
+          <p:spPr>
+            <a:xfrm>
+              <a:off x="2533802" y="2642616"/>
+              <a:ext cx="89611" cy="70409"/>
+            </a:xfrm>
+            <a:prstGeom prst="triangle">
+              <a:avLst/>
+            </a:prstGeom>
+            <a:solidFill>
+              <a:srgbClr val="1A1A1A"/>
+            </a:solidFill>
+            <a:ln>
+              <a:noFill/>
+            </a:ln>
+            <a:effectLst/>
+          </p:spPr>
+          <p:style>
+            <a:lnRef idx="1">
+              <a:schemeClr val="accent1"/>
+            </a:lnRef>
+            <a:fillRef idx="3">
+              <a:schemeClr val="accent1"/>
+            </a:fillRef>
+            <a:effectRef idx="2">
+              <a:schemeClr val="accent1"/>
+            </a:effectRef>
+            <a:fontRef idx="minor">
+              <a:schemeClr val="lt1"/>
+            </a:fontRef>
+          </p:style>
+          <p:txBody>
+            <a:bodyPr rtlCol="0" anchor="ctr"/>
+            <a:lstStyle/>
+            <a:p>
+              <a:pPr algn="ctr"/>
+            </a:p>
+          </p:txBody>
+        </p:sp>
+        <p:sp>
+          <p:nvSpPr>
+            <p:cNvPr id="9031" name="Oval 9030"/>
+            <p:cNvSpPr/>
+            <p:nvPr/>
+          </p:nvSpPr>
+          <p:spPr>
+            <a:xfrm>
+              <a:off x="2514600" y="2723266"/>
+              <a:ext cx="128016" cy="128016"/>
+            </a:xfrm>
+            <a:prstGeom prst="ellipse">
+              <a:avLst/>
+            </a:prstGeom>
+            <a:solidFill>
+              <a:srgbClr val="1A1A1A"/>
+            </a:solidFill>
+            <a:ln>
+              <a:noFill/>
+            </a:ln>
+            <a:effectLst/>
+          </p:spPr>
+          <p:style>
+            <a:lnRef idx="1">
+              <a:schemeClr val="accent1"/>
+            </a:lnRef>
+            <a:fillRef idx="3">
+              <a:schemeClr val="accent1"/>
+            </a:fillRef>
+            <a:effectRef idx="2">
+              <a:schemeClr val="accent1"/>
+            </a:effectRef>
+            <a:fontRef idx="minor">
+              <a:schemeClr val="lt1"/>
+            </a:fontRef>
+          </p:style>
+          <p:txBody>
+            <a:bodyPr rtlCol="0" anchor="ctr" wrap="none" lIns="0" rIns="0" tIns="0" bIns="0"/>
+            <a:lstStyle/>
+            <a:p>
+              <a:pPr algn="ctr"/>
+              <a:r>
+                <a:rPr sz="700" b="1">
+                  <a:solidFill>
+                    <a:srgbClr val="FFFFFF"/>
+                  </a:solidFill>
+                  <a:latin typeface="Calibri"/>
+                </a:rPr>
+                <a:t>1</a:t>
+              </a:r>
+            </a:p>
+          </p:txBody>
+        </p:sp>
+      </p:grpSp>
+      <p:grpSp>
+        <p:nvGrpSpPr>
+          <p:cNvPr id="9015" name="dm_2"/>
+          <p:cNvGrpSpPr/>
+          <p:nvPr/>
+        </p:nvGrpSpPr>
+        <p:grpSpPr>
+          <a:xfrm>
+            <a:off x="2916936" y="2642616"/>
+            <a:ext cx="128016" cy="208666"/>
+            <a:chOff x="2916936" y="2642616"/>
+            <a:chExt cx="128016" cy="208666"/>
+          </a:xfrm>
+        </p:grpSpPr>
+        <p:sp>
+          <p:nvSpPr>
+            <p:cNvPr id="9032" name="Isosceles Triangle 9031"/>
+            <p:cNvSpPr/>
+            <p:nvPr/>
+          </p:nvSpPr>
+          <p:spPr>
+            <a:xfrm>
+              <a:off x="2936138" y="2642616"/>
+              <a:ext cx="89611" cy="70409"/>
+            </a:xfrm>
+            <a:prstGeom prst="triangle">
+              <a:avLst/>
+            </a:prstGeom>
+            <a:solidFill>
+              <a:srgbClr val="1A1A1A"/>
+            </a:solidFill>
+            <a:ln>
+              <a:noFill/>
+            </a:ln>
+            <a:effectLst/>
+          </p:spPr>
+          <p:style>
+            <a:lnRef idx="1">
+              <a:schemeClr val="accent1"/>
+            </a:lnRef>
+            <a:fillRef idx="3">
+              <a:schemeClr val="accent1"/>
+            </a:fillRef>
+            <a:effectRef idx="2">
+              <a:schemeClr val="accent1"/>
+            </a:effectRef>
+            <a:fontRef idx="minor">
+              <a:schemeClr val="lt1"/>
+            </a:fontRef>
+          </p:style>
+          <p:txBody>
+            <a:bodyPr rtlCol="0" anchor="ctr"/>
+            <a:lstStyle/>
+            <a:p>
+              <a:pPr algn="ctr"/>
+            </a:p>
+          </p:txBody>
+        </p:sp>
+        <p:sp>
+          <p:nvSpPr>
+            <p:cNvPr id="9033" name="Oval 9032"/>
+            <p:cNvSpPr/>
+            <p:nvPr/>
+          </p:nvSpPr>
+          <p:spPr>
+            <a:xfrm>
+              <a:off x="2916936" y="2723266"/>
+              <a:ext cx="128016" cy="128016"/>
+            </a:xfrm>
+            <a:prstGeom prst="ellipse">
+              <a:avLst/>
+            </a:prstGeom>
+            <a:solidFill>
+              <a:srgbClr val="1A1A1A"/>
+            </a:solidFill>
+            <a:ln>
+              <a:noFill/>
+            </a:ln>
+            <a:effectLst/>
+          </p:spPr>
+          <p:style>
+            <a:lnRef idx="1">
+              <a:schemeClr val="accent1"/>
+            </a:lnRef>
+            <a:fillRef idx="3">
+              <a:schemeClr val="accent1"/>
+            </a:fillRef>
+            <a:effectRef idx="2">
+              <a:schemeClr val="accent1"/>
+            </a:effectRef>
+            <a:fontRef idx="minor">
+              <a:schemeClr val="lt1"/>
+            </a:fontRef>
+          </p:style>
+          <p:txBody>
+            <a:bodyPr rtlCol="0" anchor="ctr" wrap="none" lIns="0" rIns="0" tIns="0" bIns="0"/>
+            <a:lstStyle/>
+            <a:p>
+              <a:pPr algn="ctr"/>
+              <a:r>
+                <a:rPr sz="700" b="1">
+                  <a:solidFill>
+                    <a:srgbClr val="FFFFFF"/>
+                  </a:solidFill>
+                  <a:latin typeface="Calibri"/>
+                </a:rPr>
+                <a:t>2</a:t>
+              </a:r>
+            </a:p>
+          </p:txBody>
+        </p:sp>
+      </p:grpSp>
+      <p:grpSp>
+        <p:nvGrpSpPr>
+          <p:cNvPr id="9016" name="dm_3"/>
+          <p:cNvGrpSpPr/>
+          <p:nvPr/>
+        </p:nvGrpSpPr>
+        <p:grpSpPr>
+          <a:xfrm>
+            <a:off x="3319272" y="2642616"/>
+            <a:ext cx="128016" cy="208666"/>
+            <a:chOff x="3319272" y="2642616"/>
+            <a:chExt cx="128016" cy="208666"/>
+          </a:xfrm>
+        </p:grpSpPr>
+        <p:sp>
+          <p:nvSpPr>
+            <p:cNvPr id="9034" name="Isosceles Triangle 9033"/>
+            <p:cNvSpPr/>
+            <p:nvPr/>
+          </p:nvSpPr>
+          <p:spPr>
+            <a:xfrm>
+              <a:off x="3338474" y="2642616"/>
+              <a:ext cx="89611" cy="70409"/>
+            </a:xfrm>
+            <a:prstGeom prst="triangle">
+              <a:avLst/>
+            </a:prstGeom>
+            <a:solidFill>
+              <a:srgbClr val="1A1A1A"/>
+            </a:solidFill>
+            <a:ln>
+              <a:noFill/>
+            </a:ln>
+            <a:effectLst/>
+          </p:spPr>
+          <p:style>
+            <a:lnRef idx="1">
+              <a:schemeClr val="accent1"/>
+            </a:lnRef>
+            <a:fillRef idx="3">
+              <a:schemeClr val="accent1"/>
+            </a:fillRef>
+            <a:effectRef idx="2">
+              <a:schemeClr val="accent1"/>
+            </a:effectRef>
+            <a:fontRef idx="minor">
+              <a:schemeClr val="lt1"/>
+            </a:fontRef>
+          </p:style>
+          <p:txBody>
+            <a:bodyPr rtlCol="0" anchor="ctr"/>
+            <a:lstStyle/>
+            <a:p>
+              <a:pPr algn="ctr"/>
+            </a:p>
+          </p:txBody>
+        </p:sp>
+        <p:sp>
+          <p:nvSpPr>
+            <p:cNvPr id="9035" name="Oval 9034"/>
+            <p:cNvSpPr/>
+            <p:nvPr/>
+          </p:nvSpPr>
+          <p:spPr>
+            <a:xfrm>
+              <a:off x="3319272" y="2723266"/>
+              <a:ext cx="128016" cy="128016"/>
+            </a:xfrm>
+            <a:prstGeom prst="ellipse">
+              <a:avLst/>
+            </a:prstGeom>
+            <a:solidFill>
+              <a:srgbClr val="1A1A1A"/>
+            </a:solidFill>
+            <a:ln>
+              <a:noFill/>
+            </a:ln>
+            <a:effectLst/>
+          </p:spPr>
+          <p:style>
+            <a:lnRef idx="1">
+              <a:schemeClr val="accent1"/>
+            </a:lnRef>
+            <a:fillRef idx="3">
+              <a:schemeClr val="accent1"/>
+            </a:fillRef>
+            <a:effectRef idx="2">
+              <a:schemeClr val="accent1"/>
+            </a:effectRef>
+            <a:fontRef idx="minor">
+              <a:schemeClr val="lt1"/>
+            </a:fontRef>
+          </p:style>
+          <p:txBody>
+            <a:bodyPr rtlCol="0" anchor="ctr" wrap="none" lIns="0" rIns="0" tIns="0" bIns="0"/>
+            <a:lstStyle/>
+            <a:p>
+              <a:pPr algn="ctr"/>
+              <a:r>
+                <a:rPr sz="700" b="1">
+                  <a:solidFill>
+                    <a:srgbClr val="FFFFFF"/>
+                  </a:solidFill>
+                  <a:latin typeface="Calibri"/>
+                </a:rPr>
+                <a:t>3</a:t>
+              </a:r>
+            </a:p>
+          </p:txBody>
+        </p:sp>
+      </p:grpSp>
+      <p:grpSp>
+        <p:nvGrpSpPr>
+          <p:cNvPr id="9017" name="dm_4"/>
+          <p:cNvGrpSpPr/>
+          <p:nvPr/>
+        </p:nvGrpSpPr>
+        <p:grpSpPr>
+          <a:xfrm>
+            <a:off x="3721608" y="2642616"/>
+            <a:ext cx="128016" cy="208666"/>
+            <a:chOff x="3721608" y="2642616"/>
+            <a:chExt cx="128016" cy="208666"/>
+          </a:xfrm>
+        </p:grpSpPr>
+        <p:sp>
+          <p:nvSpPr>
+            <p:cNvPr id="9036" name="Isosceles Triangle 9035"/>
+            <p:cNvSpPr/>
+            <p:nvPr/>
+          </p:nvSpPr>
+          <p:spPr>
+            <a:xfrm>
+              <a:off x="3740810" y="2642616"/>
+              <a:ext cx="89611" cy="70409"/>
+            </a:xfrm>
+            <a:prstGeom prst="triangle">
+              <a:avLst/>
+            </a:prstGeom>
+            <a:solidFill>
+              <a:srgbClr val="1A1A1A"/>
+            </a:solidFill>
+            <a:ln>
+              <a:noFill/>
+            </a:ln>
+            <a:effectLst/>
+          </p:spPr>
+          <p:style>
+            <a:lnRef idx="1">
+              <a:schemeClr val="accent1"/>
+            </a:lnRef>
+            <a:fillRef idx="3">
+              <a:schemeClr val="accent1"/>
+            </a:fillRef>
+            <a:effectRef idx="2">
+              <a:schemeClr val="accent1"/>
+            </a:effectRef>
+            <a:fontRef idx="minor">
+              <a:schemeClr val="lt1"/>
+            </a:fontRef>
+          </p:style>
+          <p:txBody>
+            <a:bodyPr rtlCol="0" anchor="ctr"/>
+            <a:lstStyle/>
+            <a:p>
+              <a:pPr algn="ctr"/>
+            </a:p>
+          </p:txBody>
+        </p:sp>
+        <p:sp>
+          <p:nvSpPr>
+            <p:cNvPr id="9037" name="Oval 9036"/>
+            <p:cNvSpPr/>
+            <p:nvPr/>
+          </p:nvSpPr>
+          <p:spPr>
+            <a:xfrm>
+              <a:off x="3721608" y="2723266"/>
+              <a:ext cx="128016" cy="128016"/>
+            </a:xfrm>
+            <a:prstGeom prst="ellipse">
+              <a:avLst/>
+            </a:prstGeom>
+            <a:solidFill>
+              <a:srgbClr val="1A1A1A"/>
+            </a:solidFill>
+            <a:ln>
+              <a:noFill/>
+            </a:ln>
+            <a:effectLst/>
+          </p:spPr>
+          <p:style>
+            <a:lnRef idx="1">
+              <a:schemeClr val="accent1"/>
+            </a:lnRef>
+            <a:fillRef idx="3">
+              <a:schemeClr val="accent1"/>
+            </a:fillRef>
+            <a:effectRef idx="2">
+              <a:schemeClr val="accent1"/>
+            </a:effectRef>
+            <a:fontRef idx="minor">
+              <a:schemeClr val="lt1"/>
+            </a:fontRef>
+          </p:style>
+          <p:txBody>
+            <a:bodyPr rtlCol="0" anchor="ctr" wrap="none" lIns="0" rIns="0" tIns="0" bIns="0"/>
+            <a:lstStyle/>
+            <a:p>
+              <a:pPr algn="ctr"/>
+              <a:r>
+                <a:rPr sz="700" b="1">
+                  <a:solidFill>
+                    <a:srgbClr val="FFFFFF"/>
+                  </a:solidFill>
+                  <a:latin typeface="Calibri"/>
+                </a:rPr>
+                <a:t>4</a:t>
+              </a:r>
+            </a:p>
+          </p:txBody>
+        </p:sp>
+      </p:grpSp>
+      <p:grpSp>
+        <p:nvGrpSpPr>
+          <p:cNvPr id="9018" name="dm_5"/>
+          <p:cNvGrpSpPr/>
+          <p:nvPr/>
+        </p:nvGrpSpPr>
+        <p:grpSpPr>
+          <a:xfrm>
+            <a:off x="4123944" y="2642616"/>
+            <a:ext cx="128016" cy="208666"/>
+            <a:chOff x="4123944" y="2642616"/>
+            <a:chExt cx="128016" cy="208666"/>
+          </a:xfrm>
+        </p:grpSpPr>
+        <p:sp>
+          <p:nvSpPr>
+            <p:cNvPr id="9038" name="Isosceles Triangle 9037"/>
+            <p:cNvSpPr/>
+            <p:nvPr/>
+          </p:nvSpPr>
+          <p:spPr>
+            <a:xfrm>
+              <a:off x="4143146" y="2642616"/>
+              <a:ext cx="89611" cy="70409"/>
+            </a:xfrm>
+            <a:prstGeom prst="triangle">
+              <a:avLst/>
+            </a:prstGeom>
+            <a:solidFill>
+              <a:srgbClr val="1A1A1A"/>
+            </a:solidFill>
+            <a:ln>
+              <a:noFill/>
+            </a:ln>
+            <a:effectLst/>
+          </p:spPr>
+          <p:style>
+            <a:lnRef idx="1">
+              <a:schemeClr val="accent1"/>
+            </a:lnRef>
+            <a:fillRef idx="3">
+              <a:schemeClr val="accent1"/>
+            </a:fillRef>
+            <a:effectRef idx="2">
+              <a:schemeClr val="accent1"/>
+            </a:effectRef>
+            <a:fontRef idx="minor">
+              <a:schemeClr val="lt1"/>
+            </a:fontRef>
+          </p:style>
+          <p:txBody>
+            <a:bodyPr rtlCol="0" anchor="ctr"/>
+            <a:lstStyle/>
+            <a:p>
+              <a:pPr algn="ctr"/>
+            </a:p>
+          </p:txBody>
+        </p:sp>
+        <p:sp>
+          <p:nvSpPr>
+            <p:cNvPr id="9039" name="Oval 9038"/>
+            <p:cNvSpPr/>
+            <p:nvPr/>
+          </p:nvSpPr>
+          <p:spPr>
+            <a:xfrm>
+              <a:off x="4123944" y="2723266"/>
+              <a:ext cx="128016" cy="128016"/>
+            </a:xfrm>
+            <a:prstGeom prst="ellipse">
+              <a:avLst/>
+            </a:prstGeom>
+            <a:solidFill>
+              <a:srgbClr val="1A1A1A"/>
+            </a:solidFill>
+            <a:ln>
+              <a:noFill/>
+            </a:ln>
+            <a:effectLst/>
+          </p:spPr>
+          <p:style>
+            <a:lnRef idx="1">
+              <a:schemeClr val="accent1"/>
+            </a:lnRef>
+            <a:fillRef idx="3">
+              <a:schemeClr val="accent1"/>
+            </a:fillRef>
+            <a:effectRef idx="2">
+              <a:schemeClr val="accent1"/>
+            </a:effectRef>
+            <a:fontRef idx="minor">
+              <a:schemeClr val="lt1"/>
+            </a:fontRef>
+          </p:style>
+          <p:txBody>
+            <a:bodyPr rtlCol="0" anchor="ctr" wrap="none" lIns="0" rIns="0" tIns="0" bIns="0"/>
+            <a:lstStyle/>
+            <a:p>
+              <a:pPr algn="ctr"/>
+              <a:r>
+                <a:rPr sz="700" b="1">
+                  <a:solidFill>
+                    <a:srgbClr val="FFFFFF"/>
+                  </a:solidFill>
+                  <a:latin typeface="Calibri"/>
+                </a:rPr>
+                <a:t>5</a:t>
+              </a:r>
+            </a:p>
+          </p:txBody>
+        </p:sp>
+      </p:grpSp>
+      <p:sp>
+        <p:nvSpPr>
+          <p:cNvPr id="9040" name="TextBox 9039"/>
+          <p:cNvSpPr txBox="1"/>
+          <p:nvPr/>
+        </p:nvSpPr>
+        <p:spPr>
+          <a:xfrm>
+            <a:off x="4754880" y="2423160"/>
+            <a:ext cx="7132320" cy="640080"/>
+          </a:xfrm>
+          <a:prstGeom prst="rect">
+            <a:avLst/>
+          </a:prstGeom>
+          <a:noFill/>
+          <a:effectLst/>
+        </p:spPr>
+        <p:txBody>
+          <a:bodyPr wrap="square" anchor="t" lIns="27432" rIns="27432" tIns="13716" bIns="13716">
+            <a:spAutoFit/>
+          </a:bodyPr>
+          <a:lstStyle/>
+          <a:p>
+            <a:pPr algn="l"/>
+            <a:r>
+              <a:rPr sz="700" b="1" lang="en-GB">
+                <a:solidFill>
+                  <a:srgbClr val="6B6B6B"/>
+                </a:solidFill>
+                <a:latin typeface="Calibri"/>
+              </a:rPr>
+              <a:t>SCALE + COLOUR</a:t>
+            </a:r>
+          </a:p>
+          <a:p>
+            <a:pPr algn="l"/>
+            <a:r>
+              <a:rPr sz="800" b="0" lang="en-GB">
+                <a:solidFill>
+                  <a:srgbClr val="1A1A1A"/>
+                </a:solidFill>
+                <a:latin typeface="Calibri"/>
+              </a:rPr>
+              <a:t>Markers are shown at true court scale — copy directly onto a diagram and they will be proportionally correct.  To recolour Team B: select all 5 markers, right-click → Format Shape → Fill → choose your opponent colour.</a:t>
+            </a:r>
+          </a:p>
+        </p:txBody>
+      </p:sp>
+      <p:cxnSp>
+        <p:nvCxnSpPr>
+          <p:cNvPr id="9041" name="Connector 9040"/>
+          <p:cNvCxnSpPr/>
+          <p:nvPr/>
+        </p:nvCxnSpPr>
+        <p:spPr>
+          <a:xfrm>
+            <a:off x="137160" y="3273552"/>
+            <a:ext cx="11917375" cy="0"/>
+          </a:xfrm>
+          <a:prstGeom prst="line">
+            <a:avLst/>
+          </a:prstGeom>
+          <a:ln w="6350">
+            <a:solidFill>
+              <a:srgbClr val="D9D9D9"/>
+            </a:solidFill>
+          </a:ln>
+          <a:effectLst/>
+        </p:spPr>
+        <p:style>
+          <a:lnRef idx="2">
+            <a:schemeClr val="accent1"/>
+          </a:lnRef>
+          <a:fillRef idx="0">
+            <a:schemeClr val="accent1"/>
+          </a:fillRef>
+          <a:effectRef idx="1">
+            <a:schemeClr val="accent1"/>
+          </a:effectRef>
+          <a:fontRef idx="minor">
+            <a:schemeClr val="tx1"/>
+          </a:fontRef>
+        </p:style>
+      </p:cxnSp>
+      <p:sp>
+        <p:nvSpPr>
+          <p:cNvPr id="9042" name="Rectangle 9041"/>
+          <p:cNvSpPr/>
+          <p:nvPr/>
+        </p:nvSpPr>
+        <p:spPr>
+          <a:xfrm>
+            <a:off x="365760" y="3364992"/>
+            <a:ext cx="36576" cy="146304"/>
+          </a:xfrm>
+          <a:prstGeom prst="rect">
+            <a:avLst/>
+          </a:prstGeom>
+          <a:solidFill>
+            <a:srgbClr val="0057B8"/>
+          </a:solidFill>
+          <a:ln>
+            <a:noFill/>
+          </a:ln>
+          <a:effectLst/>
+        </p:spPr>
+        <p:style>
+          <a:lnRef idx="1">
+            <a:schemeClr val="accent1"/>
+          </a:lnRef>
+          <a:fillRef idx="3">
+            <a:schemeClr val="accent1"/>
+          </a:fillRef>
+          <a:effectRef idx="2">
+            <a:schemeClr val="accent1"/>
+          </a:effectRef>
+          <a:fontRef idx="minor">
+            <a:schemeClr val="lt1"/>
+          </a:fontRef>
+        </p:style>
+        <p:txBody>
+          <a:bodyPr rtlCol="0" anchor="ctr"/>
+          <a:lstStyle/>
+          <a:p>
+            <a:pPr algn="ctr"/>
+          </a:p>
+        </p:txBody>
+      </p:sp>
+      <p:sp>
+        <p:nvSpPr>
+          <p:cNvPr id="9043" name="TextBox 9042"/>
+          <p:cNvSpPr txBox="1"/>
+          <p:nvPr/>
+        </p:nvSpPr>
+        <p:spPr>
+          <a:xfrm>
+            <a:off x="438912" y="3337560"/>
+            <a:ext cx="2377440" cy="201168"/>
+          </a:xfrm>
+          <a:prstGeom prst="rect">
+            <a:avLst/>
+          </a:prstGeom>
+          <a:noFill/>
+          <a:effectLst/>
+        </p:spPr>
+        <p:txBody>
+          <a:bodyPr wrap="square" anchor="t" lIns="27432" rIns="27432" tIns="13716" bIns="13716">
+            <a:spAutoFit/>
+          </a:bodyPr>
+          <a:lstStyle/>
+          <a:p>
+            <a:pPr algn="l"/>
+            <a:r>
+              <a:rPr sz="900" b="1" lang="en-GB">
+                <a:solidFill>
+                  <a:srgbClr val="1A1A1A"/>
+                </a:solidFill>
+                <a:latin typeface="Calibri"/>
+              </a:rPr>
+              <a:t>FULL COURT  (40m × 20m)</a:t>
+            </a:r>
+          </a:p>
+        </p:txBody>
+      </p:sp>
+      <p:grpSp>
+        <p:nvGrpSpPr>
+          <p:cNvPr id="9019" name="Library full court"/>
+          <p:cNvGrpSpPr/>
+          <p:nvPr/>
+        </p:nvGrpSpPr>
+        <p:grpSpPr>
+          <a:xfrm>
+            <a:off x="438912" y="3630168"/>
+            <a:ext cx="4151376" cy="2011680"/>
+            <a:chOff x="438912" y="3630168"/>
+            <a:chExt cx="4151376" cy="2011680"/>
+          </a:xfrm>
+        </p:grpSpPr>
+        <p:sp>
+          <p:nvSpPr>
+            <p:cNvPr id="9044" name="Rectangle 9043"/>
+            <p:cNvSpPr/>
+            <p:nvPr/>
+          </p:nvSpPr>
+          <p:spPr>
+            <a:xfrm>
+              <a:off x="502920" y="3630168"/>
               <a:ext cx="4023360" cy="2011680"/>
             </a:xfrm>
             <a:prstGeom prst="rect">
@@ -25778,13 +27876,13 @@
         </p:sp>
         <p:cxnSp>
           <p:nvCxnSpPr>
-            <p:cNvPr id="39" name="Connector 38"/>
+            <p:cNvPr id="9045" name="Connector 9044"/>
             <p:cNvCxnSpPr/>
             <p:nvPr/>
           </p:nvCxnSpPr>
           <p:spPr>
             <a:xfrm>
-              <a:off x="2514600" y="2423160"/>
+              <a:off x="2514600" y="3630168"/>
               <a:ext cx="0" cy="2011680"/>
             </a:xfrm>
             <a:prstGeom prst="line">
@@ -25814,13 +27912,13 @@
         </p:cxnSp>
         <p:sp>
           <p:nvSpPr>
-            <p:cNvPr id="40" name="Oval 39"/>
+            <p:cNvPr id="9046" name="Oval 9045"/>
             <p:cNvSpPr/>
             <p:nvPr/>
           </p:nvSpPr>
           <p:spPr>
             <a:xfrm>
-              <a:off x="2212848" y="3127248"/>
+              <a:off x="2212848" y="4334256"/>
               <a:ext cx="603504" cy="603504"/>
             </a:xfrm>
             <a:prstGeom prst="ellipse">
@@ -25858,13 +27956,13 @@
         </p:sp>
         <p:sp>
           <p:nvSpPr>
-            <p:cNvPr id="41" name="Oval 40"/>
+            <p:cNvPr id="9047" name="Oval 9046"/>
             <p:cNvSpPr/>
             <p:nvPr/>
           </p:nvSpPr>
           <p:spPr>
             <a:xfrm>
-              <a:off x="2498598" y="3412998"/>
+              <a:off x="2498598" y="4620006"/>
               <a:ext cx="32004" cy="32004"/>
             </a:xfrm>
             <a:prstGeom prst="ellipse">
@@ -25902,13 +28000,13 @@
         </p:sp>
         <p:sp>
           <p:nvSpPr>
-            <p:cNvPr id="42" name="Arc 41"/>
+            <p:cNvPr id="9048" name="Arc 9047"/>
             <p:cNvSpPr/>
             <p:nvPr/>
           </p:nvSpPr>
           <p:spPr>
             <a:xfrm>
-              <a:off x="-100584" y="2674620"/>
+              <a:off x="-100584" y="3881628"/>
               <a:ext cx="1207008" cy="1207008"/>
             </a:xfrm>
             <a:prstGeom prst="arc">
@@ -25949,13 +28047,13 @@
         </p:sp>
         <p:sp>
           <p:nvSpPr>
-            <p:cNvPr id="43" name="Arc 42"/>
+            <p:cNvPr id="9049" name="Arc 9048"/>
             <p:cNvSpPr/>
             <p:nvPr/>
           </p:nvSpPr>
           <p:spPr>
             <a:xfrm>
-              <a:off x="-100584" y="2976372"/>
+              <a:off x="-100584" y="4183380"/>
               <a:ext cx="1207008" cy="1207008"/>
             </a:xfrm>
             <a:prstGeom prst="arc">
@@ -25996,13 +28094,13 @@
         </p:sp>
         <p:cxnSp>
           <p:nvCxnSpPr>
-            <p:cNvPr id="44" name="Connector 43"/>
+            <p:cNvPr id="9050" name="Connector 9049"/>
             <p:cNvCxnSpPr/>
             <p:nvPr/>
           </p:nvCxnSpPr>
           <p:spPr>
             <a:xfrm>
-              <a:off x="1106424" y="3278124"/>
+              <a:off x="1106424" y="4485132"/>
               <a:ext cx="0" cy="301752"/>
             </a:xfrm>
             <a:prstGeom prst="line">
@@ -26032,13 +28130,13 @@
         </p:cxnSp>
         <p:sp>
           <p:nvSpPr>
-            <p:cNvPr id="45" name="Oval 44"/>
+            <p:cNvPr id="9051" name="Oval 9050"/>
             <p:cNvSpPr/>
             <p:nvPr/>
           </p:nvSpPr>
           <p:spPr>
             <a:xfrm>
-              <a:off x="1090422" y="3412998"/>
+              <a:off x="1090422" y="4620006"/>
               <a:ext cx="32004" cy="32004"/>
             </a:xfrm>
             <a:prstGeom prst="ellipse">
@@ -26076,13 +28174,13 @@
         </p:sp>
         <p:sp>
           <p:nvSpPr>
-            <p:cNvPr id="46" name="Oval 45"/>
+            <p:cNvPr id="9052" name="Oval 9051"/>
             <p:cNvSpPr/>
             <p:nvPr/>
           </p:nvSpPr>
           <p:spPr>
             <a:xfrm>
-              <a:off x="1492758" y="3412998"/>
+              <a:off x="1492758" y="4620006"/>
               <a:ext cx="32004" cy="32004"/>
             </a:xfrm>
             <a:prstGeom prst="ellipse">
@@ -26120,13 +28218,13 @@
         </p:sp>
         <p:sp>
           <p:nvSpPr>
-            <p:cNvPr id="47" name="Rectangle 46"/>
+            <p:cNvPr id="9053" name="Rectangle 9052"/>
             <p:cNvSpPr/>
             <p:nvPr/>
           </p:nvSpPr>
           <p:spPr>
             <a:xfrm>
-              <a:off x="438912" y="3278124"/>
+              <a:off x="438912" y="4485132"/>
               <a:ext cx="64008" cy="301752"/>
             </a:xfrm>
             <a:prstGeom prst="rect">
@@ -26164,13 +28262,13 @@
         </p:sp>
         <p:sp>
           <p:nvSpPr>
-            <p:cNvPr id="48" name="Arc 47"/>
+            <p:cNvPr id="9054" name="Arc 9053"/>
             <p:cNvSpPr/>
             <p:nvPr/>
           </p:nvSpPr>
           <p:spPr>
             <a:xfrm>
-              <a:off x="3922776" y="2674620"/>
+              <a:off x="3922776" y="3881628"/>
               <a:ext cx="1207008" cy="1207008"/>
             </a:xfrm>
             <a:prstGeom prst="arc">
@@ -26211,13 +28309,13 @@
         </p:sp>
         <p:sp>
           <p:nvSpPr>
-            <p:cNvPr id="49" name="Arc 48"/>
+            <p:cNvPr id="9055" name="Arc 9054"/>
             <p:cNvSpPr/>
             <p:nvPr/>
           </p:nvSpPr>
           <p:spPr>
             <a:xfrm>
-              <a:off x="3922776" y="2976372"/>
+              <a:off x="3922776" y="4183380"/>
               <a:ext cx="1207008" cy="1207008"/>
             </a:xfrm>
             <a:prstGeom prst="arc">
@@ -26258,13 +28356,13 @@
         </p:sp>
         <p:cxnSp>
           <p:nvCxnSpPr>
-            <p:cNvPr id="50" name="Connector 49"/>
+            <p:cNvPr id="9056" name="Connector 9055"/>
             <p:cNvCxnSpPr/>
             <p:nvPr/>
           </p:nvCxnSpPr>
           <p:spPr>
             <a:xfrm>
-              <a:off x="3922776" y="3278124"/>
+              <a:off x="3922776" y="4485132"/>
               <a:ext cx="0" cy="301752"/>
             </a:xfrm>
             <a:prstGeom prst="line">
@@ -26294,13 +28392,13 @@
         </p:cxnSp>
         <p:sp>
           <p:nvSpPr>
-            <p:cNvPr id="51" name="Oval 50"/>
+            <p:cNvPr id="9057" name="Oval 9056"/>
             <p:cNvSpPr/>
             <p:nvPr/>
           </p:nvSpPr>
           <p:spPr>
             <a:xfrm>
-              <a:off x="3906774" y="3412998"/>
+              <a:off x="3906774" y="4620006"/>
               <a:ext cx="32004" cy="32004"/>
             </a:xfrm>
             <a:prstGeom prst="ellipse">
@@ -26338,13 +28436,13 @@
         </p:sp>
         <p:sp>
           <p:nvSpPr>
-            <p:cNvPr id="52" name="Oval 51"/>
+            <p:cNvPr id="9058" name="Oval 9057"/>
             <p:cNvSpPr/>
             <p:nvPr/>
           </p:nvSpPr>
           <p:spPr>
             <a:xfrm>
-              <a:off x="3504438" y="3412998"/>
+              <a:off x="3504438" y="4620006"/>
               <a:ext cx="32004" cy="32004"/>
             </a:xfrm>
             <a:prstGeom prst="ellipse">
@@ -26382,13 +28480,13 @@
         </p:sp>
         <p:sp>
           <p:nvSpPr>
-            <p:cNvPr id="53" name="Rectangle 52"/>
+            <p:cNvPr id="9059" name="Rectangle 9058"/>
             <p:cNvSpPr/>
             <p:nvPr/>
           </p:nvSpPr>
           <p:spPr>
             <a:xfrm>
-              <a:off x="4526280" y="3278124"/>
+              <a:off x="4526280" y="4485132"/>
               <a:ext cx="64008" cy="301752"/>
             </a:xfrm>
             <a:prstGeom prst="rect">
@@ -26427,13 +28525,13 @@
       </p:grpSp>
       <p:sp>
         <p:nvSpPr>
-          <p:cNvPr id="9006" name="Rectangle 9005"/>
+          <p:cNvPr id="9060" name="Rectangle 9059"/>
           <p:cNvSpPr/>
           <p:nvPr/>
         </p:nvSpPr>
         <p:spPr>
           <a:xfrm>
-            <a:off x="5669280" y="2130552"/>
+            <a:off x="5669280" y="3364992"/>
             <a:ext cx="36576" cy="146304"/>
           </a:xfrm>
           <a:prstGeom prst="rect">
@@ -26471,13 +28569,13 @@
       </p:sp>
       <p:sp>
         <p:nvSpPr>
-          <p:cNvPr id="9007" name="TextBox 9006"/>
+          <p:cNvPr id="9061" name="TextBox 9060"/>
           <p:cNvSpPr txBox="1"/>
           <p:nvPr/>
         </p:nvSpPr>
         <p:spPr>
           <a:xfrm>
-            <a:off x="5742432" y="2103120"/>
+            <a:off x="5742432" y="3337560"/>
             <a:ext cx="2377440" cy="201168"/>
           </a:xfrm>
           <a:prstGeom prst="rect">
@@ -26500,34 +28598,34 @@
                 </a:solidFill>
                 <a:latin typeface="Calibri"/>
               </a:rPr>
-              <a:t>HALF COURT  (20m x 20m)</a:t>
+              <a:t>HALF COURT  (20m × 20m)</a:t>
             </a:r>
           </a:p>
         </p:txBody>
       </p:sp>
       <p:grpSp>
         <p:nvGrpSpPr>
-          <p:cNvPr id="9006" name="Library half court"/>
+          <p:cNvPr id="9020" name="Library half court"/>
           <p:cNvGrpSpPr/>
           <p:nvPr/>
         </p:nvGrpSpPr>
         <p:grpSpPr>
           <a:xfrm>
-            <a:off x="5742432" y="2423160"/>
+            <a:off x="5742432" y="3630168"/>
             <a:ext cx="2075688" cy="2011680"/>
-            <a:chOff x="5742432" y="2423160"/>
+            <a:chOff x="5742432" y="3630168"/>
             <a:chExt cx="2075688" cy="2011680"/>
           </a:xfrm>
         </p:grpSpPr>
         <p:sp>
           <p:nvSpPr>
-            <p:cNvPr id="9008" name="Rectangle 9007"/>
+            <p:cNvPr id="9062" name="Rectangle 9061"/>
             <p:cNvSpPr/>
             <p:nvPr/>
           </p:nvSpPr>
           <p:spPr>
             <a:xfrm>
-              <a:off x="5806440" y="2423160"/>
+              <a:off x="5806440" y="3630168"/>
               <a:ext cx="2011680" cy="2011680"/>
             </a:xfrm>
             <a:prstGeom prst="rect">
@@ -26565,13 +28663,13 @@
         </p:sp>
         <p:sp>
           <p:nvSpPr>
-            <p:cNvPr id="9009" name="Arc 9008"/>
+            <p:cNvPr id="9063" name="Arc 9062"/>
             <p:cNvSpPr/>
             <p:nvPr/>
           </p:nvSpPr>
           <p:spPr>
             <a:xfrm>
-              <a:off x="7516368" y="3127248"/>
+              <a:off x="7516368" y="4334256"/>
               <a:ext cx="603504" cy="603504"/>
             </a:xfrm>
             <a:prstGeom prst="arc">
@@ -26612,13 +28710,13 @@
         </p:sp>
         <p:sp>
           <p:nvSpPr>
-            <p:cNvPr id="9010" name="Oval 9009"/>
+            <p:cNvPr id="9064" name="Oval 9063"/>
             <p:cNvSpPr/>
             <p:nvPr/>
           </p:nvSpPr>
           <p:spPr>
             <a:xfrm>
-              <a:off x="7802118" y="3412998"/>
+              <a:off x="7802118" y="4620006"/>
               <a:ext cx="32004" cy="32004"/>
             </a:xfrm>
             <a:prstGeom prst="ellipse">
@@ -26656,13 +28754,13 @@
         </p:sp>
         <p:sp>
           <p:nvSpPr>
-            <p:cNvPr id="9011" name="Arc 9010"/>
+            <p:cNvPr id="9065" name="Arc 9064"/>
             <p:cNvSpPr/>
             <p:nvPr/>
           </p:nvSpPr>
           <p:spPr>
             <a:xfrm>
-              <a:off x="5202936" y="2674620"/>
+              <a:off x="5202936" y="3881628"/>
               <a:ext cx="1207008" cy="1207008"/>
             </a:xfrm>
             <a:prstGeom prst="arc">
@@ -26703,13 +28801,13 @@
         </p:sp>
         <p:sp>
           <p:nvSpPr>
-            <p:cNvPr id="9012" name="Arc 9011"/>
+            <p:cNvPr id="9066" name="Arc 9065"/>
             <p:cNvSpPr/>
             <p:nvPr/>
           </p:nvSpPr>
           <p:spPr>
             <a:xfrm>
-              <a:off x="5202936" y="2976372"/>
+              <a:off x="5202936" y="4183380"/>
               <a:ext cx="1207008" cy="1207008"/>
             </a:xfrm>
             <a:prstGeom prst="arc">
@@ -26750,13 +28848,13 @@
         </p:sp>
         <p:cxnSp>
           <p:nvCxnSpPr>
-            <p:cNvPr id="9013" name="Connector 9012"/>
+            <p:cNvPr id="9067" name="Connector 9066"/>
             <p:cNvCxnSpPr/>
             <p:nvPr/>
           </p:nvCxnSpPr>
           <p:spPr>
             <a:xfrm>
-              <a:off x="6409944" y="3278124"/>
+              <a:off x="6409944" y="4485132"/>
               <a:ext cx="0" cy="301752"/>
             </a:xfrm>
             <a:prstGeom prst="line">
@@ -26786,13 +28884,13 @@
         </p:cxnSp>
         <p:sp>
           <p:nvSpPr>
-            <p:cNvPr id="9014" name="Oval 9013"/>
+            <p:cNvPr id="9068" name="Oval 9067"/>
             <p:cNvSpPr/>
             <p:nvPr/>
           </p:nvSpPr>
           <p:spPr>
             <a:xfrm>
-              <a:off x="6393942" y="3412998"/>
+              <a:off x="6393942" y="4620006"/>
               <a:ext cx="32004" cy="32004"/>
             </a:xfrm>
             <a:prstGeom prst="ellipse">
@@ -26830,13 +28928,13 @@
         </p:sp>
         <p:sp>
           <p:nvSpPr>
-            <p:cNvPr id="9015" name="Oval 9014"/>
+            <p:cNvPr id="9069" name="Oval 9068"/>
             <p:cNvSpPr/>
             <p:nvPr/>
           </p:nvSpPr>
           <p:spPr>
             <a:xfrm>
-              <a:off x="6796278" y="3412998"/>
+              <a:off x="6796278" y="4620006"/>
               <a:ext cx="32004" cy="32004"/>
             </a:xfrm>
             <a:prstGeom prst="ellipse">
@@ -26874,13 +28972,13 @@
         </p:sp>
         <p:sp>
           <p:nvSpPr>
-            <p:cNvPr id="9016" name="Rectangle 9015"/>
+            <p:cNvPr id="9070" name="Rectangle 9069"/>
             <p:cNvSpPr/>
             <p:nvPr/>
           </p:nvSpPr>
           <p:spPr>
             <a:xfrm>
-              <a:off x="5742432" y="3278124"/>
+              <a:off x="5742432" y="4485132"/>
               <a:ext cx="64008" cy="301752"/>
             </a:xfrm>
             <a:prstGeom prst="rect">
@@ -26919,14 +29017,14 @@
       </p:grpSp>
       <p:sp>
         <p:nvSpPr>
-          <p:cNvPr id="9017" name="TextBox 9016"/>
+          <p:cNvPr id="9071" name="TextBox 9070"/>
           <p:cNvSpPr txBox="1"/>
           <p:nvPr/>
         </p:nvSpPr>
         <p:spPr>
           <a:xfrm>
-            <a:off x="8823960" y="2423160"/>
-            <a:ext cx="3017520" cy="2103120"/>
+            <a:off x="8823960" y="3630168"/>
+            <a:ext cx="3017520" cy="2926080"/>
           </a:xfrm>
           <a:prstGeom prst="rect">
             <a:avLst/>
@@ -26960,7 +29058,7 @@
                 </a:solidFill>
                 <a:latin typeface="Calibri"/>
               </a:rPr>
-              <a:t>Courts are grouped — copy a whole court in one click, or ungroup to edit lines.</a:t>
+              <a:t>Courts are grouped — one click selects the whole court. Copy and paste onto any diagram, then resize to fit. Ungroup (Ctrl+Shift+G) to edit individual markings.</a:t>
             </a:r>
           </a:p>
           <a:p>
@@ -26984,14 +29082,38 @@
                 </a:solidFill>
                 <a:latin typeface="Calibri"/>
               </a:rPr>
-              <a:t>Markers, lines and zones are single objects. Copy, paste and drag onto any diagram. Numbers inside markers are editable text.</a:t>
+              <a:t>To change the accent colour on a slide: select all blue shapes (click one, then Edit → Select All Same Fill Colour) and choose Format Shape → Fill.</a:t>
+            </a:r>
+          </a:p>
+          <a:p>
+            <a:pPr algn="l"/>
+            <a:r>
+              <a:rPr sz="400" b="0" lang="en-GB">
+                <a:solidFill>
+                  <a:srgbClr val="1A1A1A"/>
+                </a:solidFill>
+                <a:latin typeface="Calibri"/>
+              </a:rPr>
+              <a:t/>
+            </a:r>
+          </a:p>
+          <a:p>
+            <a:pPr algn="l"/>
+            <a:r>
+              <a:rPr sz="800" b="0" lang="en-GB">
+                <a:solidFill>
+                  <a:srgbClr val="1A1A1A"/>
+                </a:solidFill>
+                <a:latin typeface="Calibri"/>
+              </a:rPr>
+              <a:t>All shapes are unlocked. Numbers inside markers are editable text — double-click to change.</a:t>
             </a:r>
           </a:p>
         </p:txBody>
       </p:sp>
       <p:sp>
         <p:nvSpPr>
-          <p:cNvPr id="9018" name="TextBox 9017"/>
+          <p:cNvPr id="9072" name="TextBox 9071"/>
           <p:cNvSpPr txBox="1"/>
           <p:nvPr/>
         </p:nvSpPr>
@@ -27020,7 +29142,7 @@
                 </a:solidFill>
                 <a:latin typeface="Calibri"/>
               </a:rPr>
-              <a:t>COMPONENT LIBRARY  —  futsal tactical symbols  ·  copy into any diagram zone</a:t>
+              <a:t>COMPONENT LIBRARY  —  court-scale tactical symbols  ·  copy into any diagram zone  ·  directional markers: rotate to show body shape</a:t>
             </a:r>
           </a:p>
         </p:txBody>

</xml_diff>

<commit_message>
Replace triangle markers with body-shape pucks and vision cones
Triangle indicators were generic; replaced with two purpose-built
orientation tools used in elite tactical software:

- Body-shape puck: circle with flattened back (CHORD shape) — the flat
  edge IS the shoulder line, the curve the chest. Single shape, no
  grouping, rotates in one click, reads open/closed body shape
  instantly at court scale. Team A/B numbered sets use these.
- Vision cone: translucent 70-degree wedge grouped behind the player
  circle showing facing direction AND field of view; doubles as a
  cover-shadow tool when placed on defenders (futsal pressing concept)
- All orientation markers default to facing UP so rotation angle maps
  intuitively to direction (0=up, 90=right...)
- Fix label/heading wrapping in the component library

https://claude.ai/code/session_018tafNEeKNQ7u7wPXfzwa7T
</commit_message>
<xml_diff>
--- a/futsal_session_template.pptx
+++ b/futsal_session_template.pptx
@@ -24396,7 +24396,7 @@
           <a:effectLst/>
         </p:spPr>
         <p:txBody>
-          <a:bodyPr wrap="square" anchor="t" lIns="27432" rIns="27432" tIns="13716" bIns="13716">
+          <a:bodyPr wrap="none" anchor="t" lIns="27432" rIns="27432" tIns="13716" bIns="13716">
             <a:spAutoFit/>
           </a:bodyPr>
           <a:lstStyle/>
@@ -24485,7 +24485,7 @@
           <a:effectLst/>
         </p:spPr>
         <p:txBody>
-          <a:bodyPr wrap="square" anchor="t" lIns="27432" rIns="27432" tIns="13716" bIns="13716">
+          <a:bodyPr wrap="none" anchor="t" lIns="27432" rIns="27432" tIns="13716" bIns="13716">
             <a:spAutoFit/>
           </a:bodyPr>
           <a:lstStyle/>
@@ -24576,7 +24576,7 @@
           <a:effectLst/>
         </p:spPr>
         <p:txBody>
-          <a:bodyPr wrap="square" anchor="t" lIns="27432" rIns="27432" tIns="13716" bIns="13716">
+          <a:bodyPr wrap="none" anchor="t" lIns="27432" rIns="27432" tIns="13716" bIns="13716">
             <a:spAutoFit/>
           </a:bodyPr>
           <a:lstStyle/>
@@ -24665,7 +24665,7 @@
           <a:effectLst/>
         </p:spPr>
         <p:txBody>
-          <a:bodyPr wrap="square" anchor="t" lIns="27432" rIns="27432" tIns="13716" bIns="13716">
+          <a:bodyPr wrap="none" anchor="t" lIns="27432" rIns="27432" tIns="13716" bIns="13716">
             <a:spAutoFit/>
           </a:bodyPr>
           <a:lstStyle/>
@@ -24757,7 +24757,7 @@
           <a:effectLst/>
         </p:spPr>
         <p:txBody>
-          <a:bodyPr wrap="square" anchor="t" lIns="27432" rIns="27432" tIns="13716" bIns="13716">
+          <a:bodyPr wrap="none" anchor="t" lIns="27432" rIns="27432" tIns="13716" bIns="13716">
             <a:spAutoFit/>
           </a:bodyPr>
           <a:lstStyle/>
@@ -24837,7 +24837,7 @@
           <a:effectLst/>
         </p:spPr>
         <p:txBody>
-          <a:bodyPr wrap="square" anchor="t" lIns="27432" rIns="27432" tIns="13716" bIns="13716">
+          <a:bodyPr wrap="none" anchor="t" lIns="27432" rIns="27432" tIns="13716" bIns="13716">
             <a:spAutoFit/>
           </a:bodyPr>
           <a:lstStyle/>
@@ -24917,7 +24917,7 @@
           <a:effectLst/>
         </p:spPr>
         <p:txBody>
-          <a:bodyPr wrap="square" anchor="t" lIns="27432" rIns="27432" tIns="13716" bIns="13716">
+          <a:bodyPr wrap="none" anchor="t" lIns="27432" rIns="27432" tIns="13716" bIns="13716">
             <a:spAutoFit/>
           </a:bodyPr>
           <a:lstStyle/>
@@ -24997,7 +24997,7 @@
           <a:effectLst/>
         </p:spPr>
         <p:txBody>
-          <a:bodyPr wrap="square" anchor="t" lIns="27432" rIns="27432" tIns="13716" bIns="13716">
+          <a:bodyPr wrap="none" anchor="t" lIns="27432" rIns="27432" tIns="13716" bIns="13716">
             <a:spAutoFit/>
           </a:bodyPr>
           <a:lstStyle/>
@@ -25077,7 +25077,7 @@
           <a:effectLst/>
         </p:spPr>
         <p:txBody>
-          <a:bodyPr wrap="square" anchor="t" lIns="27432" rIns="27432" tIns="13716" bIns="13716">
+          <a:bodyPr wrap="none" anchor="t" lIns="27432" rIns="27432" tIns="13716" bIns="13716">
             <a:spAutoFit/>
           </a:bodyPr>
           <a:lstStyle/>
@@ -25157,7 +25157,7 @@
           <a:effectLst/>
         </p:spPr>
         <p:txBody>
-          <a:bodyPr wrap="square" anchor="t" lIns="27432" rIns="27432" tIns="13716" bIns="13716">
+          <a:bodyPr wrap="none" anchor="t" lIns="27432" rIns="27432" tIns="13716" bIns="13716">
             <a:spAutoFit/>
           </a:bodyPr>
           <a:lstStyle/>
@@ -25230,7 +25230,7 @@
           <a:effectLst/>
         </p:spPr>
         <p:txBody>
-          <a:bodyPr wrap="square" anchor="t" lIns="27432" rIns="27432" tIns="13716" bIns="13716">
+          <a:bodyPr wrap="none" anchor="t" lIns="27432" rIns="27432" tIns="13716" bIns="13716">
             <a:spAutoFit/>
           </a:bodyPr>
           <a:lstStyle/>
@@ -25304,7 +25304,7 @@
           <a:effectLst/>
         </p:spPr>
         <p:txBody>
-          <a:bodyPr wrap="square" anchor="t" lIns="27432" rIns="27432" tIns="13716" bIns="13716">
+          <a:bodyPr wrap="none" anchor="t" lIns="27432" rIns="27432" tIns="13716" bIns="13716">
             <a:spAutoFit/>
           </a:bodyPr>
           <a:lstStyle/>
@@ -25378,7 +25378,7 @@
           <a:effectLst/>
         </p:spPr>
         <p:txBody>
-          <a:bodyPr wrap="square" anchor="t" lIns="27432" rIns="27432" tIns="13716" bIns="13716">
+          <a:bodyPr wrap="none" anchor="t" lIns="27432" rIns="27432" tIns="13716" bIns="13716">
             <a:spAutoFit/>
           </a:bodyPr>
           <a:lstStyle/>
@@ -25458,7 +25458,7 @@
           <a:effectLst/>
         </p:spPr>
         <p:txBody>
-          <a:bodyPr wrap="square" anchor="t" lIns="27432" rIns="27432" tIns="13716" bIns="13716">
+          <a:bodyPr wrap="none" anchor="t" lIns="27432" rIns="27432" tIns="13716" bIns="13716">
             <a:spAutoFit/>
           </a:bodyPr>
           <a:lstStyle/>
@@ -25540,7 +25540,7 @@
           <a:effectLst/>
         </p:spPr>
         <p:txBody>
-          <a:bodyPr wrap="square" anchor="t" lIns="27432" rIns="27432" tIns="13716" bIns="13716">
+          <a:bodyPr wrap="none" anchor="t" lIns="27432" rIns="27432" tIns="13716" bIns="13716">
             <a:spAutoFit/>
           </a:bodyPr>
           <a:lstStyle/>
@@ -25620,7 +25620,7 @@
           <a:effectLst/>
         </p:spPr>
         <p:txBody>
-          <a:bodyPr wrap="square" anchor="t" lIns="27432" rIns="27432" tIns="13716" bIns="13716">
+          <a:bodyPr wrap="none" anchor="t" lIns="27432" rIns="27432" tIns="13716" bIns="13716">
             <a:spAutoFit/>
           </a:bodyPr>
           <a:lstStyle/>
@@ -25736,6 +25736,415 @@
           <a:effectLst/>
         </p:spPr>
         <p:txBody>
+          <a:bodyPr wrap="none" anchor="t" lIns="27432" rIns="27432" tIns="13716" bIns="13716">
+            <a:spAutoFit/>
+          </a:bodyPr>
+          <a:lstStyle/>
+          <a:p>
+            <a:pPr algn="l"/>
+            <a:r>
+              <a:rPr sz="900" b="1" lang="en-GB">
+                <a:solidFill>
+                  <a:srgbClr val="1A1A1A"/>
+                </a:solidFill>
+                <a:latin typeface="Calibri"/>
+              </a:rPr>
+              <a:t>BODY SHAPE  —  shoulder-line pucks</a:t>
+            </a:r>
+          </a:p>
+        </p:txBody>
+      </p:sp>
+      <p:sp>
+        <p:nvSpPr>
+          <p:cNvPr id="39" name="Chord 38"/>
+          <p:cNvSpPr/>
+          <p:nvPr/>
+        </p:nvSpPr>
+        <p:spPr>
+          <a:xfrm>
+            <a:off x="429768" y="1828800"/>
+            <a:ext cx="128016" cy="128016"/>
+          </a:xfrm>
+          <a:prstGeom prst="chord">
+            <a:avLst>
+              <a:gd name="adj1" fmla="val 9000000"/>
+              <a:gd name="adj2" fmla="val 1800000"/>
+            </a:avLst>
+          </a:prstGeom>
+          <a:solidFill>
+            <a:srgbClr val="0057B8"/>
+          </a:solidFill>
+          <a:ln>
+            <a:noFill/>
+          </a:ln>
+          <a:effectLst/>
+        </p:spPr>
+        <p:style>
+          <a:lnRef idx="1">
+            <a:schemeClr val="accent1"/>
+          </a:lnRef>
+          <a:fillRef idx="3">
+            <a:schemeClr val="accent1"/>
+          </a:fillRef>
+          <a:effectRef idx="2">
+            <a:schemeClr val="accent1"/>
+          </a:effectRef>
+          <a:fontRef idx="minor">
+            <a:schemeClr val="lt1"/>
+          </a:fontRef>
+        </p:style>
+        <p:txBody>
+          <a:bodyPr rtlCol="0" anchor="ctr" wrap="none" lIns="0" rIns="0" tIns="0" bIns="27432"/>
+          <a:lstStyle/>
+          <a:p>
+            <a:pPr algn="ctr"/>
+            <a:r>
+              <a:rPr sz="700" b="1">
+                <a:solidFill>
+                  <a:srgbClr val="FFFFFF"/>
+                </a:solidFill>
+                <a:latin typeface="Calibri"/>
+              </a:rPr>
+              <a:t>A</a:t>
+            </a:r>
+          </a:p>
+        </p:txBody>
+      </p:sp>
+      <p:sp>
+        <p:nvSpPr>
+          <p:cNvPr id="40" name="TextBox 39"/>
+          <p:cNvSpPr txBox="1"/>
+          <p:nvPr/>
+        </p:nvSpPr>
+        <p:spPr>
+          <a:xfrm>
+            <a:off x="374904" y="1993392"/>
+            <a:ext cx="402336" cy="164592"/>
+          </a:xfrm>
+          <a:prstGeom prst="rect">
+            <a:avLst/>
+          </a:prstGeom>
+          <a:noFill/>
+          <a:effectLst/>
+        </p:spPr>
+        <p:txBody>
+          <a:bodyPr wrap="none" anchor="t" lIns="27432" rIns="27432" tIns="13716" bIns="13716">
+            <a:spAutoFit/>
+          </a:bodyPr>
+          <a:lstStyle/>
+          <a:p>
+            <a:pPr algn="ctr"/>
+            <a:r>
+              <a:rPr sz="650" b="0" lang="en-GB">
+                <a:solidFill>
+                  <a:srgbClr val="6B6B6B"/>
+                </a:solidFill>
+                <a:latin typeface="Calibri"/>
+              </a:rPr>
+              <a:t>Attacker</a:t>
+            </a:r>
+          </a:p>
+        </p:txBody>
+      </p:sp>
+      <p:sp>
+        <p:nvSpPr>
+          <p:cNvPr id="41" name="Chord 40"/>
+          <p:cNvSpPr/>
+          <p:nvPr/>
+        </p:nvSpPr>
+        <p:spPr>
+          <a:xfrm>
+            <a:off x="886968" y="1828800"/>
+            <a:ext cx="128016" cy="128016"/>
+          </a:xfrm>
+          <a:prstGeom prst="chord">
+            <a:avLst>
+              <a:gd name="adj1" fmla="val 9000000"/>
+              <a:gd name="adj2" fmla="val 1800000"/>
+            </a:avLst>
+          </a:prstGeom>
+          <a:solidFill>
+            <a:srgbClr val="FFFFFF"/>
+          </a:solidFill>
+          <a:ln w="12700">
+            <a:solidFill>
+              <a:srgbClr val="6B6B6B"/>
+            </a:solidFill>
+          </a:ln>
+          <a:effectLst/>
+        </p:spPr>
+        <p:style>
+          <a:lnRef idx="1">
+            <a:schemeClr val="accent1"/>
+          </a:lnRef>
+          <a:fillRef idx="3">
+            <a:schemeClr val="accent1"/>
+          </a:fillRef>
+          <a:effectRef idx="2">
+            <a:schemeClr val="accent1"/>
+          </a:effectRef>
+          <a:fontRef idx="minor">
+            <a:schemeClr val="lt1"/>
+          </a:fontRef>
+        </p:style>
+        <p:txBody>
+          <a:bodyPr rtlCol="0" anchor="ctr" wrap="none" lIns="0" rIns="0" tIns="0" bIns="27432"/>
+          <a:lstStyle/>
+          <a:p>
+            <a:pPr algn="ctr"/>
+            <a:r>
+              <a:rPr sz="700" b="1">
+                <a:solidFill>
+                  <a:srgbClr val="6B6B6B"/>
+                </a:solidFill>
+                <a:latin typeface="Calibri"/>
+              </a:rPr>
+              <a:t>D</a:t>
+            </a:r>
+          </a:p>
+        </p:txBody>
+      </p:sp>
+      <p:sp>
+        <p:nvSpPr>
+          <p:cNvPr id="42" name="TextBox 41"/>
+          <p:cNvSpPr txBox="1"/>
+          <p:nvPr/>
+        </p:nvSpPr>
+        <p:spPr>
+          <a:xfrm>
+            <a:off x="832104" y="1993392"/>
+            <a:ext cx="402336" cy="164592"/>
+          </a:xfrm>
+          <a:prstGeom prst="rect">
+            <a:avLst/>
+          </a:prstGeom>
+          <a:noFill/>
+          <a:effectLst/>
+        </p:spPr>
+        <p:txBody>
+          <a:bodyPr wrap="none" anchor="t" lIns="27432" rIns="27432" tIns="13716" bIns="13716">
+            <a:spAutoFit/>
+          </a:bodyPr>
+          <a:lstStyle/>
+          <a:p>
+            <a:pPr algn="ctr"/>
+            <a:r>
+              <a:rPr sz="650" b="0" lang="en-GB">
+                <a:solidFill>
+                  <a:srgbClr val="6B6B6B"/>
+                </a:solidFill>
+                <a:latin typeface="Calibri"/>
+              </a:rPr>
+              <a:t>Defender</a:t>
+            </a:r>
+          </a:p>
+        </p:txBody>
+      </p:sp>
+      <p:sp>
+        <p:nvSpPr>
+          <p:cNvPr id="43" name="Chord 42"/>
+          <p:cNvSpPr/>
+          <p:nvPr/>
+        </p:nvSpPr>
+        <p:spPr>
+          <a:xfrm>
+            <a:off x="1344168" y="1828800"/>
+            <a:ext cx="128016" cy="128016"/>
+          </a:xfrm>
+          <a:prstGeom prst="chord">
+            <a:avLst>
+              <a:gd name="adj1" fmla="val 9000000"/>
+              <a:gd name="adj2" fmla="val 1800000"/>
+            </a:avLst>
+          </a:prstGeom>
+          <a:solidFill>
+            <a:srgbClr val="1A1A1A"/>
+          </a:solidFill>
+          <a:ln>
+            <a:noFill/>
+          </a:ln>
+          <a:effectLst/>
+        </p:spPr>
+        <p:style>
+          <a:lnRef idx="1">
+            <a:schemeClr val="accent1"/>
+          </a:lnRef>
+          <a:fillRef idx="3">
+            <a:schemeClr val="accent1"/>
+          </a:fillRef>
+          <a:effectRef idx="2">
+            <a:schemeClr val="accent1"/>
+          </a:effectRef>
+          <a:fontRef idx="minor">
+            <a:schemeClr val="lt1"/>
+          </a:fontRef>
+        </p:style>
+        <p:txBody>
+          <a:bodyPr rtlCol="0" anchor="ctr" wrap="none" lIns="0" rIns="0" tIns="0" bIns="27432"/>
+          <a:lstStyle/>
+          <a:p>
+            <a:pPr algn="ctr"/>
+            <a:r>
+              <a:rPr sz="700" b="1">
+                <a:solidFill>
+                  <a:srgbClr val="FFFFFF"/>
+                </a:solidFill>
+                <a:latin typeface="Calibri"/>
+              </a:rPr>
+              <a:t>G</a:t>
+            </a:r>
+          </a:p>
+        </p:txBody>
+      </p:sp>
+      <p:sp>
+        <p:nvSpPr>
+          <p:cNvPr id="44" name="TextBox 43"/>
+          <p:cNvSpPr txBox="1"/>
+          <p:nvPr/>
+        </p:nvSpPr>
+        <p:spPr>
+          <a:xfrm>
+            <a:off x="1289304" y="1993392"/>
+            <a:ext cx="402336" cy="164592"/>
+          </a:xfrm>
+          <a:prstGeom prst="rect">
+            <a:avLst/>
+          </a:prstGeom>
+          <a:noFill/>
+          <a:effectLst/>
+        </p:spPr>
+        <p:txBody>
+          <a:bodyPr wrap="none" anchor="t" lIns="27432" rIns="27432" tIns="13716" bIns="13716">
+            <a:spAutoFit/>
+          </a:bodyPr>
+          <a:lstStyle/>
+          <a:p>
+            <a:pPr algn="ctr"/>
+            <a:r>
+              <a:rPr sz="650" b="0" lang="en-GB">
+                <a:solidFill>
+                  <a:srgbClr val="6B6B6B"/>
+                </a:solidFill>
+                <a:latin typeface="Calibri"/>
+              </a:rPr>
+              <a:t>GK</a:t>
+            </a:r>
+          </a:p>
+        </p:txBody>
+      </p:sp>
+      <p:sp>
+        <p:nvSpPr>
+          <p:cNvPr id="45" name="Chord 44"/>
+          <p:cNvSpPr/>
+          <p:nvPr/>
+        </p:nvSpPr>
+        <p:spPr>
+          <a:xfrm>
+            <a:off x="1801368" y="1828800"/>
+            <a:ext cx="128016" cy="128016"/>
+          </a:xfrm>
+          <a:prstGeom prst="chord">
+            <a:avLst>
+              <a:gd name="adj1" fmla="val 9000000"/>
+              <a:gd name="adj2" fmla="val 1800000"/>
+            </a:avLst>
+          </a:prstGeom>
+          <a:solidFill>
+            <a:srgbClr val="FFFFFF"/>
+          </a:solidFill>
+          <a:ln w="12700">
+            <a:solidFill>
+              <a:srgbClr val="6B6B6B"/>
+            </a:solidFill>
+            <a:prstDash val="dash"/>
+          </a:ln>
+          <a:effectLst/>
+        </p:spPr>
+        <p:style>
+          <a:lnRef idx="1">
+            <a:schemeClr val="accent1"/>
+          </a:lnRef>
+          <a:fillRef idx="3">
+            <a:schemeClr val="accent1"/>
+          </a:fillRef>
+          <a:effectRef idx="2">
+            <a:schemeClr val="accent1"/>
+          </a:effectRef>
+          <a:fontRef idx="minor">
+            <a:schemeClr val="lt1"/>
+          </a:fontRef>
+        </p:style>
+        <p:txBody>
+          <a:bodyPr rtlCol="0" anchor="ctr" wrap="none" lIns="0" rIns="0" tIns="0" bIns="27432"/>
+          <a:lstStyle/>
+          <a:p>
+            <a:pPr algn="ctr"/>
+            <a:r>
+              <a:rPr sz="700" b="1">
+                <a:solidFill>
+                  <a:srgbClr val="6B6B6B"/>
+                </a:solidFill>
+                <a:latin typeface="Calibri"/>
+              </a:rPr>
+              <a:t>N</a:t>
+            </a:r>
+          </a:p>
+        </p:txBody>
+      </p:sp>
+      <p:sp>
+        <p:nvSpPr>
+          <p:cNvPr id="46" name="TextBox 45"/>
+          <p:cNvSpPr txBox="1"/>
+          <p:nvPr/>
+        </p:nvSpPr>
+        <p:spPr>
+          <a:xfrm>
+            <a:off x="1746504" y="1993392"/>
+            <a:ext cx="402336" cy="164592"/>
+          </a:xfrm>
+          <a:prstGeom prst="rect">
+            <a:avLst/>
+          </a:prstGeom>
+          <a:noFill/>
+          <a:effectLst/>
+        </p:spPr>
+        <p:txBody>
+          <a:bodyPr wrap="none" anchor="t" lIns="27432" rIns="27432" tIns="13716" bIns="13716">
+            <a:spAutoFit/>
+          </a:bodyPr>
+          <a:lstStyle/>
+          <a:p>
+            <a:pPr algn="ctr"/>
+            <a:r>
+              <a:rPr sz="650" b="0" lang="en-GB">
+                <a:solidFill>
+                  <a:srgbClr val="6B6B6B"/>
+                </a:solidFill>
+                <a:latin typeface="Calibri"/>
+              </a:rPr>
+              <a:t>Neutral</a:t>
+            </a:r>
+          </a:p>
+        </p:txBody>
+      </p:sp>
+      <p:sp>
+        <p:nvSpPr>
+          <p:cNvPr id="47" name="TextBox 46"/>
+          <p:cNvSpPr txBox="1"/>
+          <p:nvPr/>
+        </p:nvSpPr>
+        <p:spPr>
+          <a:xfrm>
+            <a:off x="365760" y="2176272"/>
+            <a:ext cx="2331720" cy="329184"/>
+          </a:xfrm>
+          <a:prstGeom prst="rect">
+            <a:avLst/>
+          </a:prstGeom>
+          <a:noFill/>
+          <a:effectLst/>
+        </p:spPr>
+        <p:txBody>
           <a:bodyPr wrap="square" anchor="t" lIns="27432" rIns="27432" tIns="13716" bIns="13716">
             <a:spAutoFit/>
           </a:bodyPr>
@@ -25743,47 +26152,132 @@
           <a:p>
             <a:pPr algn="l"/>
             <a:r>
-              <a:rPr sz="900" b="1" lang="en-GB">
-                <a:solidFill>
-                  <a:srgbClr val="1A1A1A"/>
+              <a:rPr sz="750" b="0" lang="en-GB">
+                <a:solidFill>
+                  <a:srgbClr val="6B6B6B"/>
                 </a:solidFill>
                 <a:latin typeface="Calibri"/>
               </a:rPr>
-              <a:t>DIRECTIONAL MARKERS  —  rotate the group to show body orientation</a:t>
+              <a:t>Flat edge = shoulders, curve = chest. One shape — rotate it to show open / closed body shape.</a:t>
+            </a:r>
+          </a:p>
+        </p:txBody>
+      </p:sp>
+      <p:sp>
+        <p:nvSpPr>
+          <p:cNvPr id="48" name="Rectangle 47"/>
+          <p:cNvSpPr/>
+          <p:nvPr/>
+        </p:nvSpPr>
+        <p:spPr>
+          <a:xfrm>
+            <a:off x="3017520" y="1600200"/>
+            <a:ext cx="36576" cy="146304"/>
+          </a:xfrm>
+          <a:prstGeom prst="rect">
+            <a:avLst/>
+          </a:prstGeom>
+          <a:solidFill>
+            <a:srgbClr val="0057B8"/>
+          </a:solidFill>
+          <a:ln>
+            <a:noFill/>
+          </a:ln>
+          <a:effectLst/>
+        </p:spPr>
+        <p:style>
+          <a:lnRef idx="1">
+            <a:schemeClr val="accent1"/>
+          </a:lnRef>
+          <a:fillRef idx="3">
+            <a:schemeClr val="accent1"/>
+          </a:fillRef>
+          <a:effectRef idx="2">
+            <a:schemeClr val="accent1"/>
+          </a:effectRef>
+          <a:fontRef idx="minor">
+            <a:schemeClr val="lt1"/>
+          </a:fontRef>
+        </p:style>
+        <p:txBody>
+          <a:bodyPr rtlCol="0" anchor="ctr"/>
+          <a:lstStyle/>
+          <a:p>
+            <a:pPr algn="ctr"/>
+          </a:p>
+        </p:txBody>
+      </p:sp>
+      <p:sp>
+        <p:nvSpPr>
+          <p:cNvPr id="49" name="TextBox 48"/>
+          <p:cNvSpPr txBox="1"/>
+          <p:nvPr/>
+        </p:nvSpPr>
+        <p:spPr>
+          <a:xfrm>
+            <a:off x="3090672" y="1572768"/>
+            <a:ext cx="2377440" cy="201168"/>
+          </a:xfrm>
+          <a:prstGeom prst="rect">
+            <a:avLst/>
+          </a:prstGeom>
+          <a:noFill/>
+          <a:effectLst/>
+        </p:spPr>
+        <p:txBody>
+          <a:bodyPr wrap="none" anchor="t" lIns="27432" rIns="27432" tIns="13716" bIns="13716">
+            <a:spAutoFit/>
+          </a:bodyPr>
+          <a:lstStyle/>
+          <a:p>
+            <a:pPr algn="l"/>
+            <a:r>
+              <a:rPr sz="900" b="1" lang="en-GB">
+                <a:solidFill>
+                  <a:srgbClr val="1A1A1A"/>
+                </a:solidFill>
+                <a:latin typeface="Calibri"/>
+              </a:rPr>
+              <a:t>VISION CONE  —  facing + field of view</a:t>
             </a:r>
           </a:p>
         </p:txBody>
       </p:sp>
       <p:grpSp>
         <p:nvGrpSpPr>
-          <p:cNvPr id="9005" name="dm_A"/>
+          <p:cNvPr id="9005" name="vm_A"/>
           <p:cNvGrpSpPr/>
           <p:nvPr/>
         </p:nvGrpSpPr>
         <p:grpSpPr>
           <a:xfrm>
-            <a:off x="429768" y="1819656"/>
-            <a:ext cx="128016" cy="208666"/>
-            <a:chOff x="429768" y="1819656"/>
-            <a:chExt cx="128016" cy="208666"/>
+            <a:off x="3086100" y="1796796"/>
+            <a:ext cx="448056" cy="448056"/>
+            <a:chOff x="3086100" y="1796796"/>
+            <a:chExt cx="448056" cy="448056"/>
           </a:xfrm>
         </p:grpSpPr>
         <p:sp>
           <p:nvSpPr>
-            <p:cNvPr id="39" name="Isosceles Triangle 38"/>
+            <p:cNvPr id="50" name="Pie 49"/>
             <p:cNvSpPr/>
             <p:nvPr/>
           </p:nvSpPr>
           <p:spPr>
             <a:xfrm>
-              <a:off x="448970" y="1819656"/>
-              <a:ext cx="89611" cy="70409"/>
+              <a:off x="3086100" y="1796796"/>
+              <a:ext cx="448056" cy="448056"/>
             </a:xfrm>
-            <a:prstGeom prst="triangle">
-              <a:avLst/>
+            <a:prstGeom prst="pie">
+              <a:avLst>
+                <a:gd name="adj1" fmla="val 14100000"/>
+                <a:gd name="adj2" fmla="val 18300000"/>
+              </a:avLst>
             </a:prstGeom>
             <a:solidFill>
-              <a:srgbClr val="0057B8"/>
+              <a:srgbClr val="0057B8">
+                <a:alpha val="20000"/>
+              </a:srgbClr>
             </a:solidFill>
             <a:ln>
               <a:noFill/>
@@ -25814,13 +26308,13 @@
         </p:sp>
         <p:sp>
           <p:nvSpPr>
-            <p:cNvPr id="40" name="Oval 39"/>
+            <p:cNvPr id="51" name="Oval 50"/>
             <p:cNvSpPr/>
             <p:nvPr/>
           </p:nvSpPr>
           <p:spPr>
             <a:xfrm>
-              <a:off x="429768" y="1900306"/>
+              <a:off x="3246120" y="1956816"/>
               <a:ext cx="128016" cy="128016"/>
             </a:xfrm>
             <a:prstGeom prst="ellipse">
@@ -25874,7 +26368,7 @@
         </p:nvSpPr>
         <p:spPr>
           <a:xfrm>
-            <a:off x="402336" y="2055754"/>
+            <a:off x="3108960" y="2121408"/>
             <a:ext cx="402336" cy="164592"/>
           </a:xfrm>
           <a:prstGeom prst="rect">
@@ -25884,7 +26378,7 @@
           <a:effectLst/>
         </p:spPr>
         <p:txBody>
-          <a:bodyPr wrap="square" anchor="t" lIns="27432" rIns="27432" tIns="13716" bIns="13716">
+          <a:bodyPr wrap="none" anchor="t" lIns="27432" rIns="27432" tIns="13716" bIns="13716">
             <a:spAutoFit/>
           </a:bodyPr>
           <a:lstStyle/>
@@ -25904,34 +26398,39 @@
       </p:sp>
       <p:grpSp>
         <p:nvGrpSpPr>
-          <p:cNvPr id="9006" name="dm_D"/>
+          <p:cNvPr id="9006" name="vm_D"/>
           <p:cNvGrpSpPr/>
           <p:nvPr/>
         </p:nvGrpSpPr>
         <p:grpSpPr>
           <a:xfrm>
-            <a:off x="960120" y="1819656"/>
-            <a:ext cx="128016" cy="208666"/>
-            <a:chOff x="960120" y="1819656"/>
-            <a:chExt cx="128016" cy="208666"/>
+            <a:off x="3653028" y="1796796"/>
+            <a:ext cx="448056" cy="448056"/>
+            <a:chOff x="3653028" y="1796796"/>
+            <a:chExt cx="448056" cy="448056"/>
           </a:xfrm>
         </p:grpSpPr>
         <p:sp>
           <p:nvSpPr>
-            <p:cNvPr id="9007" name="Isosceles Triangle 9006"/>
+            <p:cNvPr id="9007" name="Pie 9006"/>
             <p:cNvSpPr/>
             <p:nvPr/>
           </p:nvSpPr>
           <p:spPr>
             <a:xfrm>
-              <a:off x="979322" y="1819656"/>
-              <a:ext cx="89611" cy="70409"/>
+              <a:off x="3653028" y="1796796"/>
+              <a:ext cx="448056" cy="448056"/>
             </a:xfrm>
-            <a:prstGeom prst="triangle">
-              <a:avLst/>
+            <a:prstGeom prst="pie">
+              <a:avLst>
+                <a:gd name="adj1" fmla="val 14100000"/>
+                <a:gd name="adj2" fmla="val 18300000"/>
+              </a:avLst>
             </a:prstGeom>
             <a:solidFill>
-              <a:srgbClr val="6B6B6B"/>
+              <a:srgbClr val="6B6B6B">
+                <a:alpha val="20000"/>
+              </a:srgbClr>
             </a:solidFill>
             <a:ln>
               <a:noFill/>
@@ -25968,7 +26467,7 @@
           </p:nvSpPr>
           <p:spPr>
             <a:xfrm>
-              <a:off x="960120" y="1900306"/>
+              <a:off x="3813048" y="1956816"/>
               <a:ext cx="128016" cy="128016"/>
             </a:xfrm>
             <a:prstGeom prst="ellipse">
@@ -26024,7 +26523,7 @@
         </p:nvSpPr>
         <p:spPr>
           <a:xfrm>
-            <a:off x="932688" y="2055754"/>
+            <a:off x="3675888" y="2121408"/>
             <a:ext cx="402336" cy="164592"/>
           </a:xfrm>
           <a:prstGeom prst="rect">
@@ -26034,7 +26533,7 @@
           <a:effectLst/>
         </p:spPr>
         <p:txBody>
-          <a:bodyPr wrap="square" anchor="t" lIns="27432" rIns="27432" tIns="13716" bIns="13716">
+          <a:bodyPr wrap="none" anchor="t" lIns="27432" rIns="27432" tIns="13716" bIns="13716">
             <a:spAutoFit/>
           </a:bodyPr>
           <a:lstStyle/>
@@ -26054,34 +26553,39 @@
       </p:sp>
       <p:grpSp>
         <p:nvGrpSpPr>
-          <p:cNvPr id="9007" name="dm_G"/>
+          <p:cNvPr id="9007" name="vm_G"/>
           <p:cNvGrpSpPr/>
           <p:nvPr/>
         </p:nvGrpSpPr>
         <p:grpSpPr>
           <a:xfrm>
-            <a:off x="1490472" y="1819656"/>
-            <a:ext cx="128016" cy="208666"/>
-            <a:chOff x="1490472" y="1819656"/>
-            <a:chExt cx="128016" cy="208666"/>
+            <a:off x="4219956" y="1796796"/>
+            <a:ext cx="448056" cy="448056"/>
+            <a:chOff x="4219956" y="1796796"/>
+            <a:chExt cx="448056" cy="448056"/>
           </a:xfrm>
         </p:grpSpPr>
         <p:sp>
           <p:nvSpPr>
-            <p:cNvPr id="9010" name="Isosceles Triangle 9009"/>
+            <p:cNvPr id="9010" name="Pie 9009"/>
             <p:cNvSpPr/>
             <p:nvPr/>
           </p:nvSpPr>
           <p:spPr>
             <a:xfrm>
-              <a:off x="1509674" y="1819656"/>
-              <a:ext cx="89611" cy="70409"/>
+              <a:off x="4219956" y="1796796"/>
+              <a:ext cx="448056" cy="448056"/>
             </a:xfrm>
-            <a:prstGeom prst="triangle">
-              <a:avLst/>
+            <a:prstGeom prst="pie">
+              <a:avLst>
+                <a:gd name="adj1" fmla="val 14100000"/>
+                <a:gd name="adj2" fmla="val 18300000"/>
+              </a:avLst>
             </a:prstGeom>
             <a:solidFill>
-              <a:srgbClr val="1A1A1A"/>
+              <a:srgbClr val="1A1A1A">
+                <a:alpha val="20000"/>
+              </a:srgbClr>
             </a:solidFill>
             <a:ln>
               <a:noFill/>
@@ -26118,7 +26622,7 @@
           </p:nvSpPr>
           <p:spPr>
             <a:xfrm>
-              <a:off x="1490472" y="1900306"/>
+              <a:off x="4379976" y="1956816"/>
               <a:ext cx="128016" cy="128016"/>
             </a:xfrm>
             <a:prstGeom prst="ellipse">
@@ -26172,7 +26676,7 @@
         </p:nvSpPr>
         <p:spPr>
           <a:xfrm>
-            <a:off x="1463040" y="2055754"/>
+            <a:off x="4242816" y="2121408"/>
             <a:ext cx="402336" cy="164592"/>
           </a:xfrm>
           <a:prstGeom prst="rect">
@@ -26182,57 +26686,998 @@
           <a:effectLst/>
         </p:spPr>
         <p:txBody>
+          <a:bodyPr wrap="none" anchor="t" lIns="27432" rIns="27432" tIns="13716" bIns="13716">
+            <a:spAutoFit/>
+          </a:bodyPr>
+          <a:lstStyle/>
+          <a:p>
+            <a:pPr algn="ctr"/>
+            <a:r>
+              <a:rPr sz="650" b="0" lang="en-GB">
+                <a:solidFill>
+                  <a:srgbClr val="6B6B6B"/>
+                </a:solidFill>
+                <a:latin typeface="Calibri"/>
+              </a:rPr>
+              <a:t>GK</a:t>
+            </a:r>
+          </a:p>
+        </p:txBody>
+      </p:sp>
+      <p:sp>
+        <p:nvSpPr>
+          <p:cNvPr id="9013" name="TextBox 9012"/>
+          <p:cNvSpPr txBox="1"/>
+          <p:nvPr/>
+        </p:nvSpPr>
+        <p:spPr>
+          <a:xfrm>
+            <a:off x="3017520" y="2304288"/>
+            <a:ext cx="2606040" cy="274320"/>
+          </a:xfrm>
+          <a:prstGeom prst="rect">
+            <a:avLst/>
+          </a:prstGeom>
+          <a:noFill/>
+          <a:effectLst/>
+        </p:spPr>
+        <p:txBody>
           <a:bodyPr wrap="square" anchor="t" lIns="27432" rIns="27432" tIns="13716" bIns="13716">
             <a:spAutoFit/>
           </a:bodyPr>
           <a:lstStyle/>
           <a:p>
-            <a:pPr algn="ctr"/>
-            <a:r>
-              <a:rPr sz="650" b="0" lang="en-GB">
+            <a:pPr algn="l"/>
+            <a:r>
+              <a:rPr sz="750" b="0" lang="en-GB">
                 <a:solidFill>
                   <a:srgbClr val="6B6B6B"/>
                 </a:solidFill>
                 <a:latin typeface="Calibri"/>
               </a:rPr>
-              <a:t>GK</a:t>
+              <a:t>Rotate the group: cone shows where the player faces and what they see. On a defender it doubles as a cover shadow.</a:t>
+            </a:r>
+          </a:p>
+        </p:txBody>
+      </p:sp>
+      <p:sp>
+        <p:nvSpPr>
+          <p:cNvPr id="9014" name="Rectangle 9013"/>
+          <p:cNvSpPr/>
+          <p:nvPr/>
+        </p:nvSpPr>
+        <p:spPr>
+          <a:xfrm>
+            <a:off x="5989320" y="1792224"/>
+            <a:ext cx="3017520" cy="566928"/>
+          </a:xfrm>
+          <a:prstGeom prst="rect">
+            <a:avLst/>
+          </a:prstGeom>
+          <a:solidFill>
+            <a:srgbClr val="FAFAFA"/>
+          </a:solidFill>
+          <a:ln w="9525">
+            <a:solidFill>
+              <a:srgbClr val="D9D9D9"/>
+            </a:solidFill>
+          </a:ln>
+          <a:effectLst/>
+        </p:spPr>
+        <p:style>
+          <a:lnRef idx="1">
+            <a:schemeClr val="accent1"/>
+          </a:lnRef>
+          <a:fillRef idx="3">
+            <a:schemeClr val="accent1"/>
+          </a:fillRef>
+          <a:effectRef idx="2">
+            <a:schemeClr val="accent1"/>
+          </a:effectRef>
+          <a:fontRef idx="minor">
+            <a:schemeClr val="lt1"/>
+          </a:fontRef>
+        </p:style>
+        <p:txBody>
+          <a:bodyPr rtlCol="0" anchor="ctr" wrap="square" lIns="54864" rIns="54864" tIns="36576" bIns="36576"/>
+          <a:lstStyle/>
+          <a:p>
+            <a:pPr algn="ctr"/>
+            <a:r>
+              <a:rPr sz="750">
+                <a:solidFill>
+                  <a:srgbClr val="6B6B6B"/>
+                </a:solidFill>
+                <a:latin typeface="Calibri"/>
+              </a:rPr>
+              <a:t>ROTATION  ·  All orientation markers face UP by default. Select → drag the rotation handle, or Format Shape → Rotation and type the angle (0 = up, 90 = right, 180 = down, 270 = left).</a:t>
+            </a:r>
+          </a:p>
+        </p:txBody>
+      </p:sp>
+      <p:cxnSp>
+        <p:nvCxnSpPr>
+          <p:cNvPr id="9015" name="Connector 9014"/>
+          <p:cNvCxnSpPr/>
+          <p:nvPr/>
+        </p:nvCxnSpPr>
+        <p:spPr>
+          <a:xfrm>
+            <a:off x="137160" y="2670048"/>
+            <a:ext cx="11917375" cy="0"/>
+          </a:xfrm>
+          <a:prstGeom prst="line">
+            <a:avLst/>
+          </a:prstGeom>
+          <a:ln w="6350">
+            <a:solidFill>
+              <a:srgbClr val="D9D9D9"/>
+            </a:solidFill>
+          </a:ln>
+          <a:effectLst/>
+        </p:spPr>
+        <p:style>
+          <a:lnRef idx="2">
+            <a:schemeClr val="accent1"/>
+          </a:lnRef>
+          <a:fillRef idx="0">
+            <a:schemeClr val="accent1"/>
+          </a:fillRef>
+          <a:effectRef idx="1">
+            <a:schemeClr val="accent1"/>
+          </a:effectRef>
+          <a:fontRef idx="minor">
+            <a:schemeClr val="tx1"/>
+          </a:fontRef>
+        </p:style>
+      </p:cxnSp>
+      <p:sp>
+        <p:nvSpPr>
+          <p:cNvPr id="9016" name="TextBox 9015"/>
+          <p:cNvSpPr txBox="1"/>
+          <p:nvPr/>
+        </p:nvSpPr>
+        <p:spPr>
+          <a:xfrm>
+            <a:off x="365760" y="2724912"/>
+            <a:ext cx="2194560" cy="182880"/>
+          </a:xfrm>
+          <a:prstGeom prst="rect">
+            <a:avLst/>
+          </a:prstGeom>
+          <a:noFill/>
+          <a:effectLst/>
+        </p:spPr>
+        <p:txBody>
+          <a:bodyPr wrap="square" anchor="t" lIns="27432" rIns="27432" tIns="13716" bIns="13716">
+            <a:spAutoFit/>
+          </a:bodyPr>
+          <a:lstStyle/>
+          <a:p>
+            <a:pPr algn="l"/>
+            <a:r>
+              <a:rPr sz="800" b="1" lang="en-GB">
+                <a:solidFill>
+                  <a:srgbClr val="0057B8"/>
+                </a:solidFill>
+                <a:latin typeface="Calibri"/>
+              </a:rPr>
+              <a:t>TEAM A  </a:t>
+            </a:r>
+            <a:r>
+              <a:rPr sz="750" b="0" lang="en-GB">
+                <a:solidFill>
+                  <a:srgbClr val="6B6B6B"/>
+                </a:solidFill>
+                <a:latin typeface="Calibri"/>
+              </a:rPr>
+              <a:t>your team</a:t>
+            </a:r>
+          </a:p>
+        </p:txBody>
+      </p:sp>
+      <p:sp>
+        <p:nvSpPr>
+          <p:cNvPr id="9017" name="Chord 9016"/>
+          <p:cNvSpPr/>
+          <p:nvPr/>
+        </p:nvSpPr>
+        <p:spPr>
+          <a:xfrm>
+            <a:off x="411480" y="2944368"/>
+            <a:ext cx="128016" cy="128016"/>
+          </a:xfrm>
+          <a:prstGeom prst="chord">
+            <a:avLst>
+              <a:gd name="adj1" fmla="val 9000000"/>
+              <a:gd name="adj2" fmla="val 1800000"/>
+            </a:avLst>
+          </a:prstGeom>
+          <a:solidFill>
+            <a:srgbClr val="0057B8"/>
+          </a:solidFill>
+          <a:ln>
+            <a:noFill/>
+          </a:ln>
+          <a:effectLst/>
+        </p:spPr>
+        <p:style>
+          <a:lnRef idx="1">
+            <a:schemeClr val="accent1"/>
+          </a:lnRef>
+          <a:fillRef idx="3">
+            <a:schemeClr val="accent1"/>
+          </a:fillRef>
+          <a:effectRef idx="2">
+            <a:schemeClr val="accent1"/>
+          </a:effectRef>
+          <a:fontRef idx="minor">
+            <a:schemeClr val="lt1"/>
+          </a:fontRef>
+        </p:style>
+        <p:txBody>
+          <a:bodyPr rtlCol="0" anchor="ctr" wrap="none" lIns="0" rIns="0" tIns="0" bIns="27432"/>
+          <a:lstStyle/>
+          <a:p>
+            <a:pPr algn="ctr"/>
+            <a:r>
+              <a:rPr sz="700" b="1">
+                <a:solidFill>
+                  <a:srgbClr val="FFFFFF"/>
+                </a:solidFill>
+                <a:latin typeface="Calibri"/>
+              </a:rPr>
+              <a:t>1</a:t>
+            </a:r>
+          </a:p>
+        </p:txBody>
+      </p:sp>
+      <p:sp>
+        <p:nvSpPr>
+          <p:cNvPr id="9018" name="Chord 9017"/>
+          <p:cNvSpPr/>
+          <p:nvPr/>
+        </p:nvSpPr>
+        <p:spPr>
+          <a:xfrm>
+            <a:off x="758952" y="2944368"/>
+            <a:ext cx="128016" cy="128016"/>
+          </a:xfrm>
+          <a:prstGeom prst="chord">
+            <a:avLst>
+              <a:gd name="adj1" fmla="val 9000000"/>
+              <a:gd name="adj2" fmla="val 1800000"/>
+            </a:avLst>
+          </a:prstGeom>
+          <a:solidFill>
+            <a:srgbClr val="0057B8"/>
+          </a:solidFill>
+          <a:ln>
+            <a:noFill/>
+          </a:ln>
+          <a:effectLst/>
+        </p:spPr>
+        <p:style>
+          <a:lnRef idx="1">
+            <a:schemeClr val="accent1"/>
+          </a:lnRef>
+          <a:fillRef idx="3">
+            <a:schemeClr val="accent1"/>
+          </a:fillRef>
+          <a:effectRef idx="2">
+            <a:schemeClr val="accent1"/>
+          </a:effectRef>
+          <a:fontRef idx="minor">
+            <a:schemeClr val="lt1"/>
+          </a:fontRef>
+        </p:style>
+        <p:txBody>
+          <a:bodyPr rtlCol="0" anchor="ctr" wrap="none" lIns="0" rIns="0" tIns="0" bIns="27432"/>
+          <a:lstStyle/>
+          <a:p>
+            <a:pPr algn="ctr"/>
+            <a:r>
+              <a:rPr sz="700" b="1">
+                <a:solidFill>
+                  <a:srgbClr val="FFFFFF"/>
+                </a:solidFill>
+                <a:latin typeface="Calibri"/>
+              </a:rPr>
+              <a:t>2</a:t>
+            </a:r>
+          </a:p>
+        </p:txBody>
+      </p:sp>
+      <p:sp>
+        <p:nvSpPr>
+          <p:cNvPr id="9019" name="Chord 9018"/>
+          <p:cNvSpPr/>
+          <p:nvPr/>
+        </p:nvSpPr>
+        <p:spPr>
+          <a:xfrm>
+            <a:off x="1106424" y="2944368"/>
+            <a:ext cx="128016" cy="128016"/>
+          </a:xfrm>
+          <a:prstGeom prst="chord">
+            <a:avLst>
+              <a:gd name="adj1" fmla="val 9000000"/>
+              <a:gd name="adj2" fmla="val 1800000"/>
+            </a:avLst>
+          </a:prstGeom>
+          <a:solidFill>
+            <a:srgbClr val="0057B8"/>
+          </a:solidFill>
+          <a:ln>
+            <a:noFill/>
+          </a:ln>
+          <a:effectLst/>
+        </p:spPr>
+        <p:style>
+          <a:lnRef idx="1">
+            <a:schemeClr val="accent1"/>
+          </a:lnRef>
+          <a:fillRef idx="3">
+            <a:schemeClr val="accent1"/>
+          </a:fillRef>
+          <a:effectRef idx="2">
+            <a:schemeClr val="accent1"/>
+          </a:effectRef>
+          <a:fontRef idx="minor">
+            <a:schemeClr val="lt1"/>
+          </a:fontRef>
+        </p:style>
+        <p:txBody>
+          <a:bodyPr rtlCol="0" anchor="ctr" wrap="none" lIns="0" rIns="0" tIns="0" bIns="27432"/>
+          <a:lstStyle/>
+          <a:p>
+            <a:pPr algn="ctr"/>
+            <a:r>
+              <a:rPr sz="700" b="1">
+                <a:solidFill>
+                  <a:srgbClr val="FFFFFF"/>
+                </a:solidFill>
+                <a:latin typeface="Calibri"/>
+              </a:rPr>
+              <a:t>3</a:t>
+            </a:r>
+          </a:p>
+        </p:txBody>
+      </p:sp>
+      <p:sp>
+        <p:nvSpPr>
+          <p:cNvPr id="9020" name="Chord 9019"/>
+          <p:cNvSpPr/>
+          <p:nvPr/>
+        </p:nvSpPr>
+        <p:spPr>
+          <a:xfrm>
+            <a:off x="1453896" y="2944368"/>
+            <a:ext cx="128016" cy="128016"/>
+          </a:xfrm>
+          <a:prstGeom prst="chord">
+            <a:avLst>
+              <a:gd name="adj1" fmla="val 9000000"/>
+              <a:gd name="adj2" fmla="val 1800000"/>
+            </a:avLst>
+          </a:prstGeom>
+          <a:solidFill>
+            <a:srgbClr val="0057B8"/>
+          </a:solidFill>
+          <a:ln>
+            <a:noFill/>
+          </a:ln>
+          <a:effectLst/>
+        </p:spPr>
+        <p:style>
+          <a:lnRef idx="1">
+            <a:schemeClr val="accent1"/>
+          </a:lnRef>
+          <a:fillRef idx="3">
+            <a:schemeClr val="accent1"/>
+          </a:fillRef>
+          <a:effectRef idx="2">
+            <a:schemeClr val="accent1"/>
+          </a:effectRef>
+          <a:fontRef idx="minor">
+            <a:schemeClr val="lt1"/>
+          </a:fontRef>
+        </p:style>
+        <p:txBody>
+          <a:bodyPr rtlCol="0" anchor="ctr" wrap="none" lIns="0" rIns="0" tIns="0" bIns="27432"/>
+          <a:lstStyle/>
+          <a:p>
+            <a:pPr algn="ctr"/>
+            <a:r>
+              <a:rPr sz="700" b="1">
+                <a:solidFill>
+                  <a:srgbClr val="FFFFFF"/>
+                </a:solidFill>
+                <a:latin typeface="Calibri"/>
+              </a:rPr>
+              <a:t>4</a:t>
+            </a:r>
+          </a:p>
+        </p:txBody>
+      </p:sp>
+      <p:sp>
+        <p:nvSpPr>
+          <p:cNvPr id="9021" name="Chord 9020"/>
+          <p:cNvSpPr/>
+          <p:nvPr/>
+        </p:nvSpPr>
+        <p:spPr>
+          <a:xfrm>
+            <a:off x="1801368" y="2944368"/>
+            <a:ext cx="128016" cy="128016"/>
+          </a:xfrm>
+          <a:prstGeom prst="chord">
+            <a:avLst>
+              <a:gd name="adj1" fmla="val 9000000"/>
+              <a:gd name="adj2" fmla="val 1800000"/>
+            </a:avLst>
+          </a:prstGeom>
+          <a:solidFill>
+            <a:srgbClr val="0057B8"/>
+          </a:solidFill>
+          <a:ln>
+            <a:noFill/>
+          </a:ln>
+          <a:effectLst/>
+        </p:spPr>
+        <p:style>
+          <a:lnRef idx="1">
+            <a:schemeClr val="accent1"/>
+          </a:lnRef>
+          <a:fillRef idx="3">
+            <a:schemeClr val="accent1"/>
+          </a:fillRef>
+          <a:effectRef idx="2">
+            <a:schemeClr val="accent1"/>
+          </a:effectRef>
+          <a:fontRef idx="minor">
+            <a:schemeClr val="lt1"/>
+          </a:fontRef>
+        </p:style>
+        <p:txBody>
+          <a:bodyPr rtlCol="0" anchor="ctr" wrap="none" lIns="0" rIns="0" tIns="0" bIns="27432"/>
+          <a:lstStyle/>
+          <a:p>
+            <a:pPr algn="ctr"/>
+            <a:r>
+              <a:rPr sz="700" b="1">
+                <a:solidFill>
+                  <a:srgbClr val="FFFFFF"/>
+                </a:solidFill>
+                <a:latin typeface="Calibri"/>
+              </a:rPr>
+              <a:t>5</a:t>
+            </a:r>
+          </a:p>
+        </p:txBody>
+      </p:sp>
+      <p:sp>
+        <p:nvSpPr>
+          <p:cNvPr id="9022" name="TextBox 9021"/>
+          <p:cNvSpPr txBox="1"/>
+          <p:nvPr/>
+        </p:nvSpPr>
+        <p:spPr>
+          <a:xfrm>
+            <a:off x="2514600" y="2724912"/>
+            <a:ext cx="2743200" cy="182880"/>
+          </a:xfrm>
+          <a:prstGeom prst="rect">
+            <a:avLst/>
+          </a:prstGeom>
+          <a:noFill/>
+          <a:effectLst/>
+        </p:spPr>
+        <p:txBody>
+          <a:bodyPr wrap="square" anchor="t" lIns="27432" rIns="27432" tIns="13716" bIns="13716">
+            <a:spAutoFit/>
+          </a:bodyPr>
+          <a:lstStyle/>
+          <a:p>
+            <a:pPr algn="l"/>
+            <a:r>
+              <a:rPr sz="800" b="1" lang="en-GB">
+                <a:solidFill>
+                  <a:srgbClr val="1A1A1A"/>
+                </a:solidFill>
+                <a:latin typeface="Calibri"/>
+              </a:rPr>
+              <a:t>TEAM B  </a:t>
+            </a:r>
+            <a:r>
+              <a:rPr sz="750" b="0" lang="en-GB">
+                <a:solidFill>
+                  <a:srgbClr val="6B6B6B"/>
+                </a:solidFill>
+                <a:latin typeface="Calibri"/>
+              </a:rPr>
+              <a:t>opposition — change fill colour to match</a:t>
+            </a:r>
+          </a:p>
+        </p:txBody>
+      </p:sp>
+      <p:sp>
+        <p:nvSpPr>
+          <p:cNvPr id="9023" name="Chord 9022"/>
+          <p:cNvSpPr/>
+          <p:nvPr/>
+        </p:nvSpPr>
+        <p:spPr>
+          <a:xfrm>
+            <a:off x="2560320" y="2944368"/>
+            <a:ext cx="128016" cy="128016"/>
+          </a:xfrm>
+          <a:prstGeom prst="chord">
+            <a:avLst>
+              <a:gd name="adj1" fmla="val 9000000"/>
+              <a:gd name="adj2" fmla="val 1800000"/>
+            </a:avLst>
+          </a:prstGeom>
+          <a:solidFill>
+            <a:srgbClr val="1A1A1A"/>
+          </a:solidFill>
+          <a:ln>
+            <a:noFill/>
+          </a:ln>
+          <a:effectLst/>
+        </p:spPr>
+        <p:style>
+          <a:lnRef idx="1">
+            <a:schemeClr val="accent1"/>
+          </a:lnRef>
+          <a:fillRef idx="3">
+            <a:schemeClr val="accent1"/>
+          </a:fillRef>
+          <a:effectRef idx="2">
+            <a:schemeClr val="accent1"/>
+          </a:effectRef>
+          <a:fontRef idx="minor">
+            <a:schemeClr val="lt1"/>
+          </a:fontRef>
+        </p:style>
+        <p:txBody>
+          <a:bodyPr rtlCol="0" anchor="ctr" wrap="none" lIns="0" rIns="0" tIns="0" bIns="27432"/>
+          <a:lstStyle/>
+          <a:p>
+            <a:pPr algn="ctr"/>
+            <a:r>
+              <a:rPr sz="700" b="1">
+                <a:solidFill>
+                  <a:srgbClr val="FFFFFF"/>
+                </a:solidFill>
+                <a:latin typeface="Calibri"/>
+              </a:rPr>
+              <a:t>1</a:t>
+            </a:r>
+          </a:p>
+        </p:txBody>
+      </p:sp>
+      <p:sp>
+        <p:nvSpPr>
+          <p:cNvPr id="9024" name="Chord 9023"/>
+          <p:cNvSpPr/>
+          <p:nvPr/>
+        </p:nvSpPr>
+        <p:spPr>
+          <a:xfrm>
+            <a:off x="2907792" y="2944368"/>
+            <a:ext cx="128016" cy="128016"/>
+          </a:xfrm>
+          <a:prstGeom prst="chord">
+            <a:avLst>
+              <a:gd name="adj1" fmla="val 9000000"/>
+              <a:gd name="adj2" fmla="val 1800000"/>
+            </a:avLst>
+          </a:prstGeom>
+          <a:solidFill>
+            <a:srgbClr val="1A1A1A"/>
+          </a:solidFill>
+          <a:ln>
+            <a:noFill/>
+          </a:ln>
+          <a:effectLst/>
+        </p:spPr>
+        <p:style>
+          <a:lnRef idx="1">
+            <a:schemeClr val="accent1"/>
+          </a:lnRef>
+          <a:fillRef idx="3">
+            <a:schemeClr val="accent1"/>
+          </a:fillRef>
+          <a:effectRef idx="2">
+            <a:schemeClr val="accent1"/>
+          </a:effectRef>
+          <a:fontRef idx="minor">
+            <a:schemeClr val="lt1"/>
+          </a:fontRef>
+        </p:style>
+        <p:txBody>
+          <a:bodyPr rtlCol="0" anchor="ctr" wrap="none" lIns="0" rIns="0" tIns="0" bIns="27432"/>
+          <a:lstStyle/>
+          <a:p>
+            <a:pPr algn="ctr"/>
+            <a:r>
+              <a:rPr sz="700" b="1">
+                <a:solidFill>
+                  <a:srgbClr val="FFFFFF"/>
+                </a:solidFill>
+                <a:latin typeface="Calibri"/>
+              </a:rPr>
+              <a:t>2</a:t>
+            </a:r>
+          </a:p>
+        </p:txBody>
+      </p:sp>
+      <p:sp>
+        <p:nvSpPr>
+          <p:cNvPr id="9025" name="Chord 9024"/>
+          <p:cNvSpPr/>
+          <p:nvPr/>
+        </p:nvSpPr>
+        <p:spPr>
+          <a:xfrm>
+            <a:off x="3255264" y="2944368"/>
+            <a:ext cx="128016" cy="128016"/>
+          </a:xfrm>
+          <a:prstGeom prst="chord">
+            <a:avLst>
+              <a:gd name="adj1" fmla="val 9000000"/>
+              <a:gd name="adj2" fmla="val 1800000"/>
+            </a:avLst>
+          </a:prstGeom>
+          <a:solidFill>
+            <a:srgbClr val="1A1A1A"/>
+          </a:solidFill>
+          <a:ln>
+            <a:noFill/>
+          </a:ln>
+          <a:effectLst/>
+        </p:spPr>
+        <p:style>
+          <a:lnRef idx="1">
+            <a:schemeClr val="accent1"/>
+          </a:lnRef>
+          <a:fillRef idx="3">
+            <a:schemeClr val="accent1"/>
+          </a:fillRef>
+          <a:effectRef idx="2">
+            <a:schemeClr val="accent1"/>
+          </a:effectRef>
+          <a:fontRef idx="minor">
+            <a:schemeClr val="lt1"/>
+          </a:fontRef>
+        </p:style>
+        <p:txBody>
+          <a:bodyPr rtlCol="0" anchor="ctr" wrap="none" lIns="0" rIns="0" tIns="0" bIns="27432"/>
+          <a:lstStyle/>
+          <a:p>
+            <a:pPr algn="ctr"/>
+            <a:r>
+              <a:rPr sz="700" b="1">
+                <a:solidFill>
+                  <a:srgbClr val="FFFFFF"/>
+                </a:solidFill>
+                <a:latin typeface="Calibri"/>
+              </a:rPr>
+              <a:t>3</a:t>
+            </a:r>
+          </a:p>
+        </p:txBody>
+      </p:sp>
+      <p:sp>
+        <p:nvSpPr>
+          <p:cNvPr id="9026" name="Chord 9025"/>
+          <p:cNvSpPr/>
+          <p:nvPr/>
+        </p:nvSpPr>
+        <p:spPr>
+          <a:xfrm>
+            <a:off x="3602736" y="2944368"/>
+            <a:ext cx="128016" cy="128016"/>
+          </a:xfrm>
+          <a:prstGeom prst="chord">
+            <a:avLst>
+              <a:gd name="adj1" fmla="val 9000000"/>
+              <a:gd name="adj2" fmla="val 1800000"/>
+            </a:avLst>
+          </a:prstGeom>
+          <a:solidFill>
+            <a:srgbClr val="1A1A1A"/>
+          </a:solidFill>
+          <a:ln>
+            <a:noFill/>
+          </a:ln>
+          <a:effectLst/>
+        </p:spPr>
+        <p:style>
+          <a:lnRef idx="1">
+            <a:schemeClr val="accent1"/>
+          </a:lnRef>
+          <a:fillRef idx="3">
+            <a:schemeClr val="accent1"/>
+          </a:fillRef>
+          <a:effectRef idx="2">
+            <a:schemeClr val="accent1"/>
+          </a:effectRef>
+          <a:fontRef idx="minor">
+            <a:schemeClr val="lt1"/>
+          </a:fontRef>
+        </p:style>
+        <p:txBody>
+          <a:bodyPr rtlCol="0" anchor="ctr" wrap="none" lIns="0" rIns="0" tIns="0" bIns="27432"/>
+          <a:lstStyle/>
+          <a:p>
+            <a:pPr algn="ctr"/>
+            <a:r>
+              <a:rPr sz="700" b="1">
+                <a:solidFill>
+                  <a:srgbClr val="FFFFFF"/>
+                </a:solidFill>
+                <a:latin typeface="Calibri"/>
+              </a:rPr>
+              <a:t>4</a:t>
+            </a:r>
+          </a:p>
+        </p:txBody>
+      </p:sp>
+      <p:sp>
+        <p:nvSpPr>
+          <p:cNvPr id="9027" name="Chord 9026"/>
+          <p:cNvSpPr/>
+          <p:nvPr/>
+        </p:nvSpPr>
+        <p:spPr>
+          <a:xfrm>
+            <a:off x="3950208" y="2944368"/>
+            <a:ext cx="128016" cy="128016"/>
+          </a:xfrm>
+          <a:prstGeom prst="chord">
+            <a:avLst>
+              <a:gd name="adj1" fmla="val 9000000"/>
+              <a:gd name="adj2" fmla="val 1800000"/>
+            </a:avLst>
+          </a:prstGeom>
+          <a:solidFill>
+            <a:srgbClr val="1A1A1A"/>
+          </a:solidFill>
+          <a:ln>
+            <a:noFill/>
+          </a:ln>
+          <a:effectLst/>
+        </p:spPr>
+        <p:style>
+          <a:lnRef idx="1">
+            <a:schemeClr val="accent1"/>
+          </a:lnRef>
+          <a:fillRef idx="3">
+            <a:schemeClr val="accent1"/>
+          </a:fillRef>
+          <a:effectRef idx="2">
+            <a:schemeClr val="accent1"/>
+          </a:effectRef>
+          <a:fontRef idx="minor">
+            <a:schemeClr val="lt1"/>
+          </a:fontRef>
+        </p:style>
+        <p:txBody>
+          <a:bodyPr rtlCol="0" anchor="ctr" wrap="none" lIns="0" rIns="0" tIns="0" bIns="27432"/>
+          <a:lstStyle/>
+          <a:p>
+            <a:pPr algn="ctr"/>
+            <a:r>
+              <a:rPr sz="700" b="1">
+                <a:solidFill>
+                  <a:srgbClr val="FFFFFF"/>
+                </a:solidFill>
+                <a:latin typeface="Calibri"/>
+              </a:rPr>
+              <a:t>5</a:t>
+            </a:r>
+          </a:p>
+        </p:txBody>
+      </p:sp>
+      <p:sp>
+        <p:nvSpPr>
+          <p:cNvPr id="9028" name="TextBox 9027"/>
+          <p:cNvSpPr txBox="1"/>
+          <p:nvPr/>
+        </p:nvSpPr>
+        <p:spPr>
+          <a:xfrm>
+            <a:off x="5029200" y="2724912"/>
+            <a:ext cx="6858000" cy="502920"/>
+          </a:xfrm>
+          <a:prstGeom prst="rect">
+            <a:avLst/>
+          </a:prstGeom>
+          <a:noFill/>
+          <a:effectLst/>
+        </p:spPr>
+        <p:txBody>
+          <a:bodyPr wrap="square" anchor="t" lIns="27432" rIns="27432" tIns="13716" bIns="13716">
+            <a:spAutoFit/>
+          </a:bodyPr>
+          <a:lstStyle/>
+          <a:p>
+            <a:pPr algn="l"/>
+            <a:r>
+              <a:rPr sz="700" b="1" lang="en-GB">
+                <a:solidFill>
+                  <a:srgbClr val="6B6B6B"/>
+                </a:solidFill>
+                <a:latin typeface="Calibri"/>
+              </a:rPr>
+              <a:t>SCALE + COLOUR</a:t>
+            </a:r>
+          </a:p>
+          <a:p>
+            <a:pPr algn="l"/>
+            <a:r>
+              <a:rPr sz="800" b="0" lang="en-GB">
+                <a:solidFill>
+                  <a:srgbClr val="1A1A1A"/>
+                </a:solidFill>
+                <a:latin typeface="Calibri"/>
+              </a:rPr>
+              <a:t>Markers are at true court scale — copy straight onto a diagram. Team pucks carry body shape too: rotate any puck to angle the shoulders. To recolour Team B: select all 5 → Format Shape → Fill.</a:t>
+            </a:r>
+          </a:p>
+        </p:txBody>
+      </p:sp>
+      <p:cxnSp>
+        <p:nvCxnSpPr>
+          <p:cNvPr id="9029" name="Connector 9028"/>
+          <p:cNvCxnSpPr/>
+          <p:nvPr/>
+        </p:nvCxnSpPr>
+        <p:spPr>
+          <a:xfrm>
+            <a:off x="137160" y="3273552"/>
+            <a:ext cx="11917375" cy="0"/>
+          </a:xfrm>
+          <a:prstGeom prst="line">
+            <a:avLst/>
+          </a:prstGeom>
+          <a:ln w="6350">
+            <a:solidFill>
+              <a:srgbClr val="D9D9D9"/>
+            </a:solidFill>
+          </a:ln>
+          <a:effectLst/>
+        </p:spPr>
+        <p:style>
+          <a:lnRef idx="2">
+            <a:schemeClr val="accent1"/>
+          </a:lnRef>
+          <a:fillRef idx="0">
+            <a:schemeClr val="accent1"/>
+          </a:fillRef>
+          <a:effectRef idx="1">
+            <a:schemeClr val="accent1"/>
+          </a:effectRef>
+          <a:fontRef idx="minor">
+            <a:schemeClr val="tx1"/>
+          </a:fontRef>
+        </p:style>
+      </p:cxnSp>
+      <p:sp>
+        <p:nvSpPr>
+          <p:cNvPr id="9030" name="Rectangle 9029"/>
+          <p:cNvSpPr/>
+          <p:nvPr/>
+        </p:nvSpPr>
+        <p:spPr>
+          <a:xfrm>
+            <a:off x="365760" y="3364992"/>
+            <a:ext cx="36576" cy="146304"/>
+          </a:xfrm>
+          <a:prstGeom prst="rect">
+            <a:avLst/>
+          </a:prstGeom>
+          <a:solidFill>
+            <a:srgbClr val="0057B8"/>
+          </a:solidFill>
+          <a:ln>
+            <a:noFill/>
+          </a:ln>
+          <a:effectLst/>
+        </p:spPr>
+        <p:style>
+          <a:lnRef idx="1">
+            <a:schemeClr val="accent1"/>
+          </a:lnRef>
+          <a:fillRef idx="3">
+            <a:schemeClr val="accent1"/>
+          </a:fillRef>
+          <a:effectRef idx="2">
+            <a:schemeClr val="accent1"/>
+          </a:effectRef>
+          <a:fontRef idx="minor">
+            <a:schemeClr val="lt1"/>
+          </a:fontRef>
+        </p:style>
+        <p:txBody>
+          <a:bodyPr rtlCol="0" anchor="ctr"/>
+          <a:lstStyle/>
+          <a:p>
+            <a:pPr algn="ctr"/>
+          </a:p>
+        </p:txBody>
+      </p:sp>
+      <p:sp>
+        <p:nvSpPr>
+          <p:cNvPr id="9031" name="TextBox 9030"/>
+          <p:cNvSpPr txBox="1"/>
+          <p:nvPr/>
+        </p:nvSpPr>
+        <p:spPr>
+          <a:xfrm>
+            <a:off x="438912" y="3337560"/>
+            <a:ext cx="2377440" cy="201168"/>
+          </a:xfrm>
+          <a:prstGeom prst="rect">
+            <a:avLst/>
+          </a:prstGeom>
+          <a:noFill/>
+          <a:effectLst/>
+        </p:spPr>
+        <p:txBody>
+          <a:bodyPr wrap="none" anchor="t" lIns="27432" rIns="27432" tIns="13716" bIns="13716">
+            <a:spAutoFit/>
+          </a:bodyPr>
+          <a:lstStyle/>
+          <a:p>
+            <a:pPr algn="l"/>
+            <a:r>
+              <a:rPr sz="900" b="1" lang="en-GB">
+                <a:solidFill>
+                  <a:srgbClr val="1A1A1A"/>
+                </a:solidFill>
+                <a:latin typeface="Calibri"/>
+              </a:rPr>
+              <a:t>FULL COURT  (40m × 20m)</a:t>
             </a:r>
           </a:p>
         </p:txBody>
       </p:sp>
       <p:grpSp>
         <p:nvGrpSpPr>
-          <p:cNvPr id="9008" name="dm_N"/>
+          <p:cNvPr id="9008" name="Library full court"/>
           <p:cNvGrpSpPr/>
           <p:nvPr/>
         </p:nvGrpSpPr>
         <p:grpSpPr>
           <a:xfrm>
-            <a:off x="2020824" y="1819656"/>
-            <a:ext cx="128016" cy="208666"/>
-            <a:chOff x="2020824" y="1819656"/>
-            <a:chExt cx="128016" cy="208666"/>
+            <a:off x="438912" y="3630168"/>
+            <a:ext cx="4151376" cy="2011680"/>
+            <a:chOff x="438912" y="3630168"/>
+            <a:chExt cx="4151376" cy="2011680"/>
           </a:xfrm>
         </p:grpSpPr>
         <p:sp>
           <p:nvSpPr>
-            <p:cNvPr id="9013" name="Isosceles Triangle 9012"/>
+            <p:cNvPr id="9032" name="Rectangle 9031"/>
             <p:cNvSpPr/>
             <p:nvPr/>
           </p:nvSpPr>
           <p:spPr>
             <a:xfrm>
-              <a:off x="2040026" y="1819656"/>
-              <a:ext cx="89611" cy="70409"/>
+              <a:off x="502920" y="3630168"/>
+              <a:ext cx="4023360" cy="2011680"/>
             </a:xfrm>
-            <a:prstGeom prst="triangle">
+            <a:prstGeom prst="rect">
               <a:avLst/>
             </a:prstGeom>
-            <a:solidFill>
-              <a:srgbClr val="6B6B6B"/>
-            </a:solidFill>
-            <a:ln>
-              <a:noFill/>
+            <a:noFill/>
+            <a:ln w="12700">
+              <a:solidFill>
+                <a:srgbClr val="A9B1BB"/>
+              </a:solidFill>
             </a:ln>
             <a:effectLst/>
           </p:spPr>
@@ -26258,1097 +27703,61 @@
             </a:p>
           </p:txBody>
         </p:sp>
+        <p:cxnSp>
+          <p:nvCxnSpPr>
+            <p:cNvPr id="9033" name="Connector 9032"/>
+            <p:cNvCxnSpPr/>
+            <p:nvPr/>
+          </p:nvCxnSpPr>
+          <p:spPr>
+            <a:xfrm>
+              <a:off x="2514600" y="3630168"/>
+              <a:ext cx="0" cy="2011680"/>
+            </a:xfrm>
+            <a:prstGeom prst="line">
+              <a:avLst/>
+            </a:prstGeom>
+            <a:ln w="9525">
+              <a:solidFill>
+                <a:srgbClr val="A9B1BB"/>
+              </a:solidFill>
+            </a:ln>
+            <a:effectLst/>
+          </p:spPr>
+          <p:style>
+            <a:lnRef idx="2">
+              <a:schemeClr val="accent1"/>
+            </a:lnRef>
+            <a:fillRef idx="0">
+              <a:schemeClr val="accent1"/>
+            </a:fillRef>
+            <a:effectRef idx="1">
+              <a:schemeClr val="accent1"/>
+            </a:effectRef>
+            <a:fontRef idx="minor">
+              <a:schemeClr val="tx1"/>
+            </a:fontRef>
+          </p:style>
+        </p:cxnSp>
         <p:sp>
           <p:nvSpPr>
-            <p:cNvPr id="9014" name="Oval 9013"/>
+            <p:cNvPr id="9034" name="Oval 9033"/>
             <p:cNvSpPr/>
             <p:nvPr/>
           </p:nvSpPr>
           <p:spPr>
             <a:xfrm>
-              <a:off x="2020824" y="1900306"/>
-              <a:ext cx="128016" cy="128016"/>
+              <a:off x="2212848" y="4334256"/>
+              <a:ext cx="603504" cy="603504"/>
             </a:xfrm>
             <a:prstGeom prst="ellipse">
               <a:avLst/>
             </a:prstGeom>
-            <a:solidFill>
-              <a:srgbClr val="FFFFFF"/>
-            </a:solidFill>
-            <a:ln w="12700">
+            <a:noFill/>
+            <a:ln w="9525">
               <a:solidFill>
-                <a:srgbClr val="6B6B6B"/>
+                <a:srgbClr val="A9B1BB"/>
               </a:solidFill>
-              <a:prstDash val="dash"/>
-            </a:ln>
-            <a:effectLst/>
-          </p:spPr>
-          <p:style>
-            <a:lnRef idx="1">
-              <a:schemeClr val="accent1"/>
-            </a:lnRef>
-            <a:fillRef idx="3">
-              <a:schemeClr val="accent1"/>
-            </a:fillRef>
-            <a:effectRef idx="2">
-              <a:schemeClr val="accent1"/>
-            </a:effectRef>
-            <a:fontRef idx="minor">
-              <a:schemeClr val="lt1"/>
-            </a:fontRef>
-          </p:style>
-          <p:txBody>
-            <a:bodyPr rtlCol="0" anchor="ctr" wrap="none" lIns="0" rIns="0" tIns="0" bIns="0"/>
-            <a:lstStyle/>
-            <a:p>
-              <a:pPr algn="ctr"/>
-              <a:r>
-                <a:rPr sz="700" b="1">
-                  <a:solidFill>
-                    <a:srgbClr val="6B6B6B"/>
-                  </a:solidFill>
-                  <a:latin typeface="Calibri"/>
-                </a:rPr>
-                <a:t>N</a:t>
-              </a:r>
-            </a:p>
-          </p:txBody>
-        </p:sp>
-      </p:grpSp>
-      <p:sp>
-        <p:nvSpPr>
-          <p:cNvPr id="9015" name="TextBox 9014"/>
-          <p:cNvSpPr txBox="1"/>
-          <p:nvPr/>
-        </p:nvSpPr>
-        <p:spPr>
-          <a:xfrm>
-            <a:off x="1993392" y="2055754"/>
-            <a:ext cx="402336" cy="164592"/>
-          </a:xfrm>
-          <a:prstGeom prst="rect">
-            <a:avLst/>
-          </a:prstGeom>
-          <a:noFill/>
-          <a:effectLst/>
-        </p:spPr>
-        <p:txBody>
-          <a:bodyPr wrap="square" anchor="t" lIns="27432" rIns="27432" tIns="13716" bIns="13716">
-            <a:spAutoFit/>
-          </a:bodyPr>
-          <a:lstStyle/>
-          <a:p>
-            <a:pPr algn="ctr"/>
-            <a:r>
-              <a:rPr sz="650" b="0" lang="en-GB">
-                <a:solidFill>
-                  <a:srgbClr val="6B6B6B"/>
-                </a:solidFill>
-                <a:latin typeface="Calibri"/>
-              </a:rPr>
-              <a:t>Neutral</a:t>
-            </a:r>
-          </a:p>
-        </p:txBody>
-      </p:sp>
-      <p:sp>
-        <p:nvSpPr>
-          <p:cNvPr id="9016" name="Rectangle 9015"/>
-          <p:cNvSpPr/>
-          <p:nvPr/>
-        </p:nvSpPr>
-        <p:spPr>
-          <a:xfrm>
-            <a:off x="2788920" y="1773936"/>
-            <a:ext cx="4114800" cy="457200"/>
-          </a:xfrm>
-          <a:prstGeom prst="rect">
-            <a:avLst/>
-          </a:prstGeom>
-          <a:solidFill>
-            <a:srgbClr val="FAFAFA"/>
-          </a:solidFill>
-          <a:ln w="9525">
-            <a:solidFill>
-              <a:srgbClr val="D9D9D9"/>
-            </a:solidFill>
-          </a:ln>
-          <a:effectLst/>
-        </p:spPr>
-        <p:style>
-          <a:lnRef idx="1">
-            <a:schemeClr val="accent1"/>
-          </a:lnRef>
-          <a:fillRef idx="3">
-            <a:schemeClr val="accent1"/>
-          </a:fillRef>
-          <a:effectRef idx="2">
-            <a:schemeClr val="accent1"/>
-          </a:effectRef>
-          <a:fontRef idx="minor">
-            <a:schemeClr val="lt1"/>
-          </a:fontRef>
-        </p:style>
-        <p:txBody>
-          <a:bodyPr rtlCol="0" anchor="ctr" wrap="square" lIns="54864" rIns="54864" tIns="36576" bIns="36576"/>
-          <a:lstStyle/>
-          <a:p>
-            <a:pPr algn="ctr"/>
-            <a:r>
-              <a:rPr sz="750">
-                <a:solidFill>
-                  <a:srgbClr val="6B6B6B"/>
-                </a:solidFill>
-                <a:latin typeface="Calibri"/>
-              </a:rPr>
-              <a:t>HOW TO USE  ·  Select any directional marker → right-click → Format Shape → Rotation.  Or drag the circular rotation handle above the shape.  The triangle always points where the player faces.</a:t>
-            </a:r>
-          </a:p>
-        </p:txBody>
-      </p:sp>
-      <p:cxnSp>
-        <p:nvCxnSpPr>
-          <p:cNvPr id="9017" name="Connector 9016"/>
-          <p:cNvCxnSpPr/>
-          <p:nvPr/>
-        </p:nvCxnSpPr>
-        <p:spPr>
-          <a:xfrm>
-            <a:off x="137160" y="2359152"/>
-            <a:ext cx="11917375" cy="0"/>
-          </a:xfrm>
-          <a:prstGeom prst="line">
-            <a:avLst/>
-          </a:prstGeom>
-          <a:ln w="6350">
-            <a:solidFill>
-              <a:srgbClr val="D9D9D9"/>
-            </a:solidFill>
-          </a:ln>
-          <a:effectLst/>
-        </p:spPr>
-        <p:style>
-          <a:lnRef idx="2">
-            <a:schemeClr val="accent1"/>
-          </a:lnRef>
-          <a:fillRef idx="0">
-            <a:schemeClr val="accent1"/>
-          </a:fillRef>
-          <a:effectRef idx="1">
-            <a:schemeClr val="accent1"/>
-          </a:effectRef>
-          <a:fontRef idx="minor">
-            <a:schemeClr val="tx1"/>
-          </a:fontRef>
-        </p:style>
-      </p:cxnSp>
-      <p:sp>
-        <p:nvSpPr>
-          <p:cNvPr id="9018" name="TextBox 9017"/>
-          <p:cNvSpPr txBox="1"/>
-          <p:nvPr/>
-        </p:nvSpPr>
-        <p:spPr>
-          <a:xfrm>
-            <a:off x="365760" y="2423160"/>
-            <a:ext cx="2194560" cy="182880"/>
-          </a:xfrm>
-          <a:prstGeom prst="rect">
-            <a:avLst/>
-          </a:prstGeom>
-          <a:noFill/>
-          <a:effectLst/>
-        </p:spPr>
-        <p:txBody>
-          <a:bodyPr wrap="square" anchor="t" lIns="27432" rIns="27432" tIns="13716" bIns="13716">
-            <a:spAutoFit/>
-          </a:bodyPr>
-          <a:lstStyle/>
-          <a:p>
-            <a:pPr algn="l"/>
-            <a:r>
-              <a:rPr sz="800" b="1" lang="en-GB">
-                <a:solidFill>
-                  <a:srgbClr val="0057B8"/>
-                </a:solidFill>
-                <a:latin typeface="Calibri"/>
-              </a:rPr>
-              <a:t>TEAM A  </a:t>
-            </a:r>
-            <a:r>
-              <a:rPr sz="750" b="0" lang="en-GB">
-                <a:solidFill>
-                  <a:srgbClr val="6B6B6B"/>
-                </a:solidFill>
-                <a:latin typeface="Calibri"/>
-              </a:rPr>
-              <a:t>your team</a:t>
-            </a:r>
-          </a:p>
-        </p:txBody>
-      </p:sp>
-      <p:grpSp>
-        <p:nvGrpSpPr>
-          <p:cNvPr id="9009" name="dm_1"/>
-          <p:cNvGrpSpPr/>
-          <p:nvPr/>
-        </p:nvGrpSpPr>
-        <p:grpSpPr>
-          <a:xfrm>
-            <a:off x="365760" y="2642616"/>
-            <a:ext cx="128016" cy="208666"/>
-            <a:chOff x="365760" y="2642616"/>
-            <a:chExt cx="128016" cy="208666"/>
-          </a:xfrm>
-        </p:grpSpPr>
-        <p:sp>
-          <p:nvSpPr>
-            <p:cNvPr id="9019" name="Isosceles Triangle 9018"/>
-            <p:cNvSpPr/>
-            <p:nvPr/>
-          </p:nvSpPr>
-          <p:spPr>
-            <a:xfrm>
-              <a:off x="384962" y="2642616"/>
-              <a:ext cx="89611" cy="70409"/>
-            </a:xfrm>
-            <a:prstGeom prst="triangle">
-              <a:avLst/>
-            </a:prstGeom>
-            <a:solidFill>
-              <a:srgbClr val="0057B8"/>
-            </a:solidFill>
-            <a:ln>
-              <a:noFill/>
-            </a:ln>
-            <a:effectLst/>
-          </p:spPr>
-          <p:style>
-            <a:lnRef idx="1">
-              <a:schemeClr val="accent1"/>
-            </a:lnRef>
-            <a:fillRef idx="3">
-              <a:schemeClr val="accent1"/>
-            </a:fillRef>
-            <a:effectRef idx="2">
-              <a:schemeClr val="accent1"/>
-            </a:effectRef>
-            <a:fontRef idx="minor">
-              <a:schemeClr val="lt1"/>
-            </a:fontRef>
-          </p:style>
-          <p:txBody>
-            <a:bodyPr rtlCol="0" anchor="ctr"/>
-            <a:lstStyle/>
-            <a:p>
-              <a:pPr algn="ctr"/>
-            </a:p>
-          </p:txBody>
-        </p:sp>
-        <p:sp>
-          <p:nvSpPr>
-            <p:cNvPr id="9020" name="Oval 9019"/>
-            <p:cNvSpPr/>
-            <p:nvPr/>
-          </p:nvSpPr>
-          <p:spPr>
-            <a:xfrm>
-              <a:off x="365760" y="2723266"/>
-              <a:ext cx="128016" cy="128016"/>
-            </a:xfrm>
-            <a:prstGeom prst="ellipse">
-              <a:avLst/>
-            </a:prstGeom>
-            <a:solidFill>
-              <a:srgbClr val="0057B8"/>
-            </a:solidFill>
-            <a:ln>
-              <a:noFill/>
-            </a:ln>
-            <a:effectLst/>
-          </p:spPr>
-          <p:style>
-            <a:lnRef idx="1">
-              <a:schemeClr val="accent1"/>
-            </a:lnRef>
-            <a:fillRef idx="3">
-              <a:schemeClr val="accent1"/>
-            </a:fillRef>
-            <a:effectRef idx="2">
-              <a:schemeClr val="accent1"/>
-            </a:effectRef>
-            <a:fontRef idx="minor">
-              <a:schemeClr val="lt1"/>
-            </a:fontRef>
-          </p:style>
-          <p:txBody>
-            <a:bodyPr rtlCol="0" anchor="ctr" wrap="none" lIns="0" rIns="0" tIns="0" bIns="0"/>
-            <a:lstStyle/>
-            <a:p>
-              <a:pPr algn="ctr"/>
-              <a:r>
-                <a:rPr sz="700" b="1">
-                  <a:solidFill>
-                    <a:srgbClr val="FFFFFF"/>
-                  </a:solidFill>
-                  <a:latin typeface="Calibri"/>
-                </a:rPr>
-                <a:t>1</a:t>
-              </a:r>
-            </a:p>
-          </p:txBody>
-        </p:sp>
-      </p:grpSp>
-      <p:grpSp>
-        <p:nvGrpSpPr>
-          <p:cNvPr id="9010" name="dm_2"/>
-          <p:cNvGrpSpPr/>
-          <p:nvPr/>
-        </p:nvGrpSpPr>
-        <p:grpSpPr>
-          <a:xfrm>
-            <a:off x="768096" y="2642616"/>
-            <a:ext cx="128016" cy="208666"/>
-            <a:chOff x="768096" y="2642616"/>
-            <a:chExt cx="128016" cy="208666"/>
-          </a:xfrm>
-        </p:grpSpPr>
-        <p:sp>
-          <p:nvSpPr>
-            <p:cNvPr id="9021" name="Isosceles Triangle 9020"/>
-            <p:cNvSpPr/>
-            <p:nvPr/>
-          </p:nvSpPr>
-          <p:spPr>
-            <a:xfrm>
-              <a:off x="787298" y="2642616"/>
-              <a:ext cx="89611" cy="70409"/>
-            </a:xfrm>
-            <a:prstGeom prst="triangle">
-              <a:avLst/>
-            </a:prstGeom>
-            <a:solidFill>
-              <a:srgbClr val="0057B8"/>
-            </a:solidFill>
-            <a:ln>
-              <a:noFill/>
-            </a:ln>
-            <a:effectLst/>
-          </p:spPr>
-          <p:style>
-            <a:lnRef idx="1">
-              <a:schemeClr val="accent1"/>
-            </a:lnRef>
-            <a:fillRef idx="3">
-              <a:schemeClr val="accent1"/>
-            </a:fillRef>
-            <a:effectRef idx="2">
-              <a:schemeClr val="accent1"/>
-            </a:effectRef>
-            <a:fontRef idx="minor">
-              <a:schemeClr val="lt1"/>
-            </a:fontRef>
-          </p:style>
-          <p:txBody>
-            <a:bodyPr rtlCol="0" anchor="ctr"/>
-            <a:lstStyle/>
-            <a:p>
-              <a:pPr algn="ctr"/>
-            </a:p>
-          </p:txBody>
-        </p:sp>
-        <p:sp>
-          <p:nvSpPr>
-            <p:cNvPr id="9022" name="Oval 9021"/>
-            <p:cNvSpPr/>
-            <p:nvPr/>
-          </p:nvSpPr>
-          <p:spPr>
-            <a:xfrm>
-              <a:off x="768096" y="2723266"/>
-              <a:ext cx="128016" cy="128016"/>
-            </a:xfrm>
-            <a:prstGeom prst="ellipse">
-              <a:avLst/>
-            </a:prstGeom>
-            <a:solidFill>
-              <a:srgbClr val="0057B8"/>
-            </a:solidFill>
-            <a:ln>
-              <a:noFill/>
-            </a:ln>
-            <a:effectLst/>
-          </p:spPr>
-          <p:style>
-            <a:lnRef idx="1">
-              <a:schemeClr val="accent1"/>
-            </a:lnRef>
-            <a:fillRef idx="3">
-              <a:schemeClr val="accent1"/>
-            </a:fillRef>
-            <a:effectRef idx="2">
-              <a:schemeClr val="accent1"/>
-            </a:effectRef>
-            <a:fontRef idx="minor">
-              <a:schemeClr val="lt1"/>
-            </a:fontRef>
-          </p:style>
-          <p:txBody>
-            <a:bodyPr rtlCol="0" anchor="ctr" wrap="none" lIns="0" rIns="0" tIns="0" bIns="0"/>
-            <a:lstStyle/>
-            <a:p>
-              <a:pPr algn="ctr"/>
-              <a:r>
-                <a:rPr sz="700" b="1">
-                  <a:solidFill>
-                    <a:srgbClr val="FFFFFF"/>
-                  </a:solidFill>
-                  <a:latin typeface="Calibri"/>
-                </a:rPr>
-                <a:t>2</a:t>
-              </a:r>
-            </a:p>
-          </p:txBody>
-        </p:sp>
-      </p:grpSp>
-      <p:grpSp>
-        <p:nvGrpSpPr>
-          <p:cNvPr id="9011" name="dm_3"/>
-          <p:cNvGrpSpPr/>
-          <p:nvPr/>
-        </p:nvGrpSpPr>
-        <p:grpSpPr>
-          <a:xfrm>
-            <a:off x="1170432" y="2642616"/>
-            <a:ext cx="128016" cy="208666"/>
-            <a:chOff x="1170432" y="2642616"/>
-            <a:chExt cx="128016" cy="208666"/>
-          </a:xfrm>
-        </p:grpSpPr>
-        <p:sp>
-          <p:nvSpPr>
-            <p:cNvPr id="9023" name="Isosceles Triangle 9022"/>
-            <p:cNvSpPr/>
-            <p:nvPr/>
-          </p:nvSpPr>
-          <p:spPr>
-            <a:xfrm>
-              <a:off x="1189634" y="2642616"/>
-              <a:ext cx="89611" cy="70409"/>
-            </a:xfrm>
-            <a:prstGeom prst="triangle">
-              <a:avLst/>
-            </a:prstGeom>
-            <a:solidFill>
-              <a:srgbClr val="0057B8"/>
-            </a:solidFill>
-            <a:ln>
-              <a:noFill/>
-            </a:ln>
-            <a:effectLst/>
-          </p:spPr>
-          <p:style>
-            <a:lnRef idx="1">
-              <a:schemeClr val="accent1"/>
-            </a:lnRef>
-            <a:fillRef idx="3">
-              <a:schemeClr val="accent1"/>
-            </a:fillRef>
-            <a:effectRef idx="2">
-              <a:schemeClr val="accent1"/>
-            </a:effectRef>
-            <a:fontRef idx="minor">
-              <a:schemeClr val="lt1"/>
-            </a:fontRef>
-          </p:style>
-          <p:txBody>
-            <a:bodyPr rtlCol="0" anchor="ctr"/>
-            <a:lstStyle/>
-            <a:p>
-              <a:pPr algn="ctr"/>
-            </a:p>
-          </p:txBody>
-        </p:sp>
-        <p:sp>
-          <p:nvSpPr>
-            <p:cNvPr id="9024" name="Oval 9023"/>
-            <p:cNvSpPr/>
-            <p:nvPr/>
-          </p:nvSpPr>
-          <p:spPr>
-            <a:xfrm>
-              <a:off x="1170432" y="2723266"/>
-              <a:ext cx="128016" cy="128016"/>
-            </a:xfrm>
-            <a:prstGeom prst="ellipse">
-              <a:avLst/>
-            </a:prstGeom>
-            <a:solidFill>
-              <a:srgbClr val="0057B8"/>
-            </a:solidFill>
-            <a:ln>
-              <a:noFill/>
-            </a:ln>
-            <a:effectLst/>
-          </p:spPr>
-          <p:style>
-            <a:lnRef idx="1">
-              <a:schemeClr val="accent1"/>
-            </a:lnRef>
-            <a:fillRef idx="3">
-              <a:schemeClr val="accent1"/>
-            </a:fillRef>
-            <a:effectRef idx="2">
-              <a:schemeClr val="accent1"/>
-            </a:effectRef>
-            <a:fontRef idx="minor">
-              <a:schemeClr val="lt1"/>
-            </a:fontRef>
-          </p:style>
-          <p:txBody>
-            <a:bodyPr rtlCol="0" anchor="ctr" wrap="none" lIns="0" rIns="0" tIns="0" bIns="0"/>
-            <a:lstStyle/>
-            <a:p>
-              <a:pPr algn="ctr"/>
-              <a:r>
-                <a:rPr sz="700" b="1">
-                  <a:solidFill>
-                    <a:srgbClr val="FFFFFF"/>
-                  </a:solidFill>
-                  <a:latin typeface="Calibri"/>
-                </a:rPr>
-                <a:t>3</a:t>
-              </a:r>
-            </a:p>
-          </p:txBody>
-        </p:sp>
-      </p:grpSp>
-      <p:grpSp>
-        <p:nvGrpSpPr>
-          <p:cNvPr id="9012" name="dm_4"/>
-          <p:cNvGrpSpPr/>
-          <p:nvPr/>
-        </p:nvGrpSpPr>
-        <p:grpSpPr>
-          <a:xfrm>
-            <a:off x="1572768" y="2642616"/>
-            <a:ext cx="128016" cy="208666"/>
-            <a:chOff x="1572768" y="2642616"/>
-            <a:chExt cx="128016" cy="208666"/>
-          </a:xfrm>
-        </p:grpSpPr>
-        <p:sp>
-          <p:nvSpPr>
-            <p:cNvPr id="9025" name="Isosceles Triangle 9024"/>
-            <p:cNvSpPr/>
-            <p:nvPr/>
-          </p:nvSpPr>
-          <p:spPr>
-            <a:xfrm>
-              <a:off x="1591970" y="2642616"/>
-              <a:ext cx="89611" cy="70409"/>
-            </a:xfrm>
-            <a:prstGeom prst="triangle">
-              <a:avLst/>
-            </a:prstGeom>
-            <a:solidFill>
-              <a:srgbClr val="0057B8"/>
-            </a:solidFill>
-            <a:ln>
-              <a:noFill/>
-            </a:ln>
-            <a:effectLst/>
-          </p:spPr>
-          <p:style>
-            <a:lnRef idx="1">
-              <a:schemeClr val="accent1"/>
-            </a:lnRef>
-            <a:fillRef idx="3">
-              <a:schemeClr val="accent1"/>
-            </a:fillRef>
-            <a:effectRef idx="2">
-              <a:schemeClr val="accent1"/>
-            </a:effectRef>
-            <a:fontRef idx="minor">
-              <a:schemeClr val="lt1"/>
-            </a:fontRef>
-          </p:style>
-          <p:txBody>
-            <a:bodyPr rtlCol="0" anchor="ctr"/>
-            <a:lstStyle/>
-            <a:p>
-              <a:pPr algn="ctr"/>
-            </a:p>
-          </p:txBody>
-        </p:sp>
-        <p:sp>
-          <p:nvSpPr>
-            <p:cNvPr id="9026" name="Oval 9025"/>
-            <p:cNvSpPr/>
-            <p:nvPr/>
-          </p:nvSpPr>
-          <p:spPr>
-            <a:xfrm>
-              <a:off x="1572768" y="2723266"/>
-              <a:ext cx="128016" cy="128016"/>
-            </a:xfrm>
-            <a:prstGeom prst="ellipse">
-              <a:avLst/>
-            </a:prstGeom>
-            <a:solidFill>
-              <a:srgbClr val="0057B8"/>
-            </a:solidFill>
-            <a:ln>
-              <a:noFill/>
-            </a:ln>
-            <a:effectLst/>
-          </p:spPr>
-          <p:style>
-            <a:lnRef idx="1">
-              <a:schemeClr val="accent1"/>
-            </a:lnRef>
-            <a:fillRef idx="3">
-              <a:schemeClr val="accent1"/>
-            </a:fillRef>
-            <a:effectRef idx="2">
-              <a:schemeClr val="accent1"/>
-            </a:effectRef>
-            <a:fontRef idx="minor">
-              <a:schemeClr val="lt1"/>
-            </a:fontRef>
-          </p:style>
-          <p:txBody>
-            <a:bodyPr rtlCol="0" anchor="ctr" wrap="none" lIns="0" rIns="0" tIns="0" bIns="0"/>
-            <a:lstStyle/>
-            <a:p>
-              <a:pPr algn="ctr"/>
-              <a:r>
-                <a:rPr sz="700" b="1">
-                  <a:solidFill>
-                    <a:srgbClr val="FFFFFF"/>
-                  </a:solidFill>
-                  <a:latin typeface="Calibri"/>
-                </a:rPr>
-                <a:t>4</a:t>
-              </a:r>
-            </a:p>
-          </p:txBody>
-        </p:sp>
-      </p:grpSp>
-      <p:grpSp>
-        <p:nvGrpSpPr>
-          <p:cNvPr id="9013" name="dm_5"/>
-          <p:cNvGrpSpPr/>
-          <p:nvPr/>
-        </p:nvGrpSpPr>
-        <p:grpSpPr>
-          <a:xfrm>
-            <a:off x="1975104" y="2642616"/>
-            <a:ext cx="128016" cy="208666"/>
-            <a:chOff x="1975104" y="2642616"/>
-            <a:chExt cx="128016" cy="208666"/>
-          </a:xfrm>
-        </p:grpSpPr>
-        <p:sp>
-          <p:nvSpPr>
-            <p:cNvPr id="9027" name="Isosceles Triangle 9026"/>
-            <p:cNvSpPr/>
-            <p:nvPr/>
-          </p:nvSpPr>
-          <p:spPr>
-            <a:xfrm>
-              <a:off x="1994306" y="2642616"/>
-              <a:ext cx="89611" cy="70409"/>
-            </a:xfrm>
-            <a:prstGeom prst="triangle">
-              <a:avLst/>
-            </a:prstGeom>
-            <a:solidFill>
-              <a:srgbClr val="0057B8"/>
-            </a:solidFill>
-            <a:ln>
-              <a:noFill/>
-            </a:ln>
-            <a:effectLst/>
-          </p:spPr>
-          <p:style>
-            <a:lnRef idx="1">
-              <a:schemeClr val="accent1"/>
-            </a:lnRef>
-            <a:fillRef idx="3">
-              <a:schemeClr val="accent1"/>
-            </a:fillRef>
-            <a:effectRef idx="2">
-              <a:schemeClr val="accent1"/>
-            </a:effectRef>
-            <a:fontRef idx="minor">
-              <a:schemeClr val="lt1"/>
-            </a:fontRef>
-          </p:style>
-          <p:txBody>
-            <a:bodyPr rtlCol="0" anchor="ctr"/>
-            <a:lstStyle/>
-            <a:p>
-              <a:pPr algn="ctr"/>
-            </a:p>
-          </p:txBody>
-        </p:sp>
-        <p:sp>
-          <p:nvSpPr>
-            <p:cNvPr id="9028" name="Oval 9027"/>
-            <p:cNvSpPr/>
-            <p:nvPr/>
-          </p:nvSpPr>
-          <p:spPr>
-            <a:xfrm>
-              <a:off x="1975104" y="2723266"/>
-              <a:ext cx="128016" cy="128016"/>
-            </a:xfrm>
-            <a:prstGeom prst="ellipse">
-              <a:avLst/>
-            </a:prstGeom>
-            <a:solidFill>
-              <a:srgbClr val="0057B8"/>
-            </a:solidFill>
-            <a:ln>
-              <a:noFill/>
-            </a:ln>
-            <a:effectLst/>
-          </p:spPr>
-          <p:style>
-            <a:lnRef idx="1">
-              <a:schemeClr val="accent1"/>
-            </a:lnRef>
-            <a:fillRef idx="3">
-              <a:schemeClr val="accent1"/>
-            </a:fillRef>
-            <a:effectRef idx="2">
-              <a:schemeClr val="accent1"/>
-            </a:effectRef>
-            <a:fontRef idx="minor">
-              <a:schemeClr val="lt1"/>
-            </a:fontRef>
-          </p:style>
-          <p:txBody>
-            <a:bodyPr rtlCol="0" anchor="ctr" wrap="none" lIns="0" rIns="0" tIns="0" bIns="0"/>
-            <a:lstStyle/>
-            <a:p>
-              <a:pPr algn="ctr"/>
-              <a:r>
-                <a:rPr sz="700" b="1">
-                  <a:solidFill>
-                    <a:srgbClr val="FFFFFF"/>
-                  </a:solidFill>
-                  <a:latin typeface="Calibri"/>
-                </a:rPr>
-                <a:t>5</a:t>
-              </a:r>
-            </a:p>
-          </p:txBody>
-        </p:sp>
-      </p:grpSp>
-      <p:sp>
-        <p:nvSpPr>
-          <p:cNvPr id="9029" name="TextBox 9028"/>
-          <p:cNvSpPr txBox="1"/>
-          <p:nvPr/>
-        </p:nvSpPr>
-        <p:spPr>
-          <a:xfrm>
-            <a:off x="2514600" y="2423160"/>
-            <a:ext cx="2743200" cy="182880"/>
-          </a:xfrm>
-          <a:prstGeom prst="rect">
-            <a:avLst/>
-          </a:prstGeom>
-          <a:noFill/>
-          <a:effectLst/>
-        </p:spPr>
-        <p:txBody>
-          <a:bodyPr wrap="square" anchor="t" lIns="27432" rIns="27432" tIns="13716" bIns="13716">
-            <a:spAutoFit/>
-          </a:bodyPr>
-          <a:lstStyle/>
-          <a:p>
-            <a:pPr algn="l"/>
-            <a:r>
-              <a:rPr sz="800" b="1" lang="en-GB">
-                <a:solidFill>
-                  <a:srgbClr val="1A1A1A"/>
-                </a:solidFill>
-                <a:latin typeface="Calibri"/>
-              </a:rPr>
-              <a:t>TEAM B  </a:t>
-            </a:r>
-            <a:r>
-              <a:rPr sz="750" b="0" lang="en-GB">
-                <a:solidFill>
-                  <a:srgbClr val="6B6B6B"/>
-                </a:solidFill>
-                <a:latin typeface="Calibri"/>
-              </a:rPr>
-              <a:t>opposition — change fill colour to match</a:t>
-            </a:r>
-          </a:p>
-        </p:txBody>
-      </p:sp>
-      <p:grpSp>
-        <p:nvGrpSpPr>
-          <p:cNvPr id="9014" name="dm_1"/>
-          <p:cNvGrpSpPr/>
-          <p:nvPr/>
-        </p:nvGrpSpPr>
-        <p:grpSpPr>
-          <a:xfrm>
-            <a:off x="2514600" y="2642616"/>
-            <a:ext cx="128016" cy="208666"/>
-            <a:chOff x="2514600" y="2642616"/>
-            <a:chExt cx="128016" cy="208666"/>
-          </a:xfrm>
-        </p:grpSpPr>
-        <p:sp>
-          <p:nvSpPr>
-            <p:cNvPr id="9030" name="Isosceles Triangle 9029"/>
-            <p:cNvSpPr/>
-            <p:nvPr/>
-          </p:nvSpPr>
-          <p:spPr>
-            <a:xfrm>
-              <a:off x="2533802" y="2642616"/>
-              <a:ext cx="89611" cy="70409"/>
-            </a:xfrm>
-            <a:prstGeom prst="triangle">
-              <a:avLst/>
-            </a:prstGeom>
-            <a:solidFill>
-              <a:srgbClr val="1A1A1A"/>
-            </a:solidFill>
-            <a:ln>
-              <a:noFill/>
-            </a:ln>
-            <a:effectLst/>
-          </p:spPr>
-          <p:style>
-            <a:lnRef idx="1">
-              <a:schemeClr val="accent1"/>
-            </a:lnRef>
-            <a:fillRef idx="3">
-              <a:schemeClr val="accent1"/>
-            </a:fillRef>
-            <a:effectRef idx="2">
-              <a:schemeClr val="accent1"/>
-            </a:effectRef>
-            <a:fontRef idx="minor">
-              <a:schemeClr val="lt1"/>
-            </a:fontRef>
-          </p:style>
-          <p:txBody>
-            <a:bodyPr rtlCol="0" anchor="ctr"/>
-            <a:lstStyle/>
-            <a:p>
-              <a:pPr algn="ctr"/>
-            </a:p>
-          </p:txBody>
-        </p:sp>
-        <p:sp>
-          <p:nvSpPr>
-            <p:cNvPr id="9031" name="Oval 9030"/>
-            <p:cNvSpPr/>
-            <p:nvPr/>
-          </p:nvSpPr>
-          <p:spPr>
-            <a:xfrm>
-              <a:off x="2514600" y="2723266"/>
-              <a:ext cx="128016" cy="128016"/>
-            </a:xfrm>
-            <a:prstGeom prst="ellipse">
-              <a:avLst/>
-            </a:prstGeom>
-            <a:solidFill>
-              <a:srgbClr val="1A1A1A"/>
-            </a:solidFill>
-            <a:ln>
-              <a:noFill/>
-            </a:ln>
-            <a:effectLst/>
-          </p:spPr>
-          <p:style>
-            <a:lnRef idx="1">
-              <a:schemeClr val="accent1"/>
-            </a:lnRef>
-            <a:fillRef idx="3">
-              <a:schemeClr val="accent1"/>
-            </a:fillRef>
-            <a:effectRef idx="2">
-              <a:schemeClr val="accent1"/>
-            </a:effectRef>
-            <a:fontRef idx="minor">
-              <a:schemeClr val="lt1"/>
-            </a:fontRef>
-          </p:style>
-          <p:txBody>
-            <a:bodyPr rtlCol="0" anchor="ctr" wrap="none" lIns="0" rIns="0" tIns="0" bIns="0"/>
-            <a:lstStyle/>
-            <a:p>
-              <a:pPr algn="ctr"/>
-              <a:r>
-                <a:rPr sz="700" b="1">
-                  <a:solidFill>
-                    <a:srgbClr val="FFFFFF"/>
-                  </a:solidFill>
-                  <a:latin typeface="Calibri"/>
-                </a:rPr>
-                <a:t>1</a:t>
-              </a:r>
-            </a:p>
-          </p:txBody>
-        </p:sp>
-      </p:grpSp>
-      <p:grpSp>
-        <p:nvGrpSpPr>
-          <p:cNvPr id="9015" name="dm_2"/>
-          <p:cNvGrpSpPr/>
-          <p:nvPr/>
-        </p:nvGrpSpPr>
-        <p:grpSpPr>
-          <a:xfrm>
-            <a:off x="2916936" y="2642616"/>
-            <a:ext cx="128016" cy="208666"/>
-            <a:chOff x="2916936" y="2642616"/>
-            <a:chExt cx="128016" cy="208666"/>
-          </a:xfrm>
-        </p:grpSpPr>
-        <p:sp>
-          <p:nvSpPr>
-            <p:cNvPr id="9032" name="Isosceles Triangle 9031"/>
-            <p:cNvSpPr/>
-            <p:nvPr/>
-          </p:nvSpPr>
-          <p:spPr>
-            <a:xfrm>
-              <a:off x="2936138" y="2642616"/>
-              <a:ext cx="89611" cy="70409"/>
-            </a:xfrm>
-            <a:prstGeom prst="triangle">
-              <a:avLst/>
-            </a:prstGeom>
-            <a:solidFill>
-              <a:srgbClr val="1A1A1A"/>
-            </a:solidFill>
-            <a:ln>
-              <a:noFill/>
-            </a:ln>
-            <a:effectLst/>
-          </p:spPr>
-          <p:style>
-            <a:lnRef idx="1">
-              <a:schemeClr val="accent1"/>
-            </a:lnRef>
-            <a:fillRef idx="3">
-              <a:schemeClr val="accent1"/>
-            </a:fillRef>
-            <a:effectRef idx="2">
-              <a:schemeClr val="accent1"/>
-            </a:effectRef>
-            <a:fontRef idx="minor">
-              <a:schemeClr val="lt1"/>
-            </a:fontRef>
-          </p:style>
-          <p:txBody>
-            <a:bodyPr rtlCol="0" anchor="ctr"/>
-            <a:lstStyle/>
-            <a:p>
-              <a:pPr algn="ctr"/>
-            </a:p>
-          </p:txBody>
-        </p:sp>
-        <p:sp>
-          <p:nvSpPr>
-            <p:cNvPr id="9033" name="Oval 9032"/>
-            <p:cNvSpPr/>
-            <p:nvPr/>
-          </p:nvSpPr>
-          <p:spPr>
-            <a:xfrm>
-              <a:off x="2916936" y="2723266"/>
-              <a:ext cx="128016" cy="128016"/>
-            </a:xfrm>
-            <a:prstGeom prst="ellipse">
-              <a:avLst/>
-            </a:prstGeom>
-            <a:solidFill>
-              <a:srgbClr val="1A1A1A"/>
-            </a:solidFill>
-            <a:ln>
-              <a:noFill/>
-            </a:ln>
-            <a:effectLst/>
-          </p:spPr>
-          <p:style>
-            <a:lnRef idx="1">
-              <a:schemeClr val="accent1"/>
-            </a:lnRef>
-            <a:fillRef idx="3">
-              <a:schemeClr val="accent1"/>
-            </a:fillRef>
-            <a:effectRef idx="2">
-              <a:schemeClr val="accent1"/>
-            </a:effectRef>
-            <a:fontRef idx="minor">
-              <a:schemeClr val="lt1"/>
-            </a:fontRef>
-          </p:style>
-          <p:txBody>
-            <a:bodyPr rtlCol="0" anchor="ctr" wrap="none" lIns="0" rIns="0" tIns="0" bIns="0"/>
-            <a:lstStyle/>
-            <a:p>
-              <a:pPr algn="ctr"/>
-              <a:r>
-                <a:rPr sz="700" b="1">
-                  <a:solidFill>
-                    <a:srgbClr val="FFFFFF"/>
-                  </a:solidFill>
-                  <a:latin typeface="Calibri"/>
-                </a:rPr>
-                <a:t>2</a:t>
-              </a:r>
-            </a:p>
-          </p:txBody>
-        </p:sp>
-      </p:grpSp>
-      <p:grpSp>
-        <p:nvGrpSpPr>
-          <p:cNvPr id="9016" name="dm_3"/>
-          <p:cNvGrpSpPr/>
-          <p:nvPr/>
-        </p:nvGrpSpPr>
-        <p:grpSpPr>
-          <a:xfrm>
-            <a:off x="3319272" y="2642616"/>
-            <a:ext cx="128016" cy="208666"/>
-            <a:chOff x="3319272" y="2642616"/>
-            <a:chExt cx="128016" cy="208666"/>
-          </a:xfrm>
-        </p:grpSpPr>
-        <p:sp>
-          <p:nvSpPr>
-            <p:cNvPr id="9034" name="Isosceles Triangle 9033"/>
-            <p:cNvSpPr/>
-            <p:nvPr/>
-          </p:nvSpPr>
-          <p:spPr>
-            <a:xfrm>
-              <a:off x="3338474" y="2642616"/>
-              <a:ext cx="89611" cy="70409"/>
-            </a:xfrm>
-            <a:prstGeom prst="triangle">
-              <a:avLst/>
-            </a:prstGeom>
-            <a:solidFill>
-              <a:srgbClr val="1A1A1A"/>
-            </a:solidFill>
-            <a:ln>
-              <a:noFill/>
             </a:ln>
             <a:effectLst/>
           </p:spPr>
@@ -27382,586 +27791,6 @@
           </p:nvSpPr>
           <p:spPr>
             <a:xfrm>
-              <a:off x="3319272" y="2723266"/>
-              <a:ext cx="128016" cy="128016"/>
-            </a:xfrm>
-            <a:prstGeom prst="ellipse">
-              <a:avLst/>
-            </a:prstGeom>
-            <a:solidFill>
-              <a:srgbClr val="1A1A1A"/>
-            </a:solidFill>
-            <a:ln>
-              <a:noFill/>
-            </a:ln>
-            <a:effectLst/>
-          </p:spPr>
-          <p:style>
-            <a:lnRef idx="1">
-              <a:schemeClr val="accent1"/>
-            </a:lnRef>
-            <a:fillRef idx="3">
-              <a:schemeClr val="accent1"/>
-            </a:fillRef>
-            <a:effectRef idx="2">
-              <a:schemeClr val="accent1"/>
-            </a:effectRef>
-            <a:fontRef idx="minor">
-              <a:schemeClr val="lt1"/>
-            </a:fontRef>
-          </p:style>
-          <p:txBody>
-            <a:bodyPr rtlCol="0" anchor="ctr" wrap="none" lIns="0" rIns="0" tIns="0" bIns="0"/>
-            <a:lstStyle/>
-            <a:p>
-              <a:pPr algn="ctr"/>
-              <a:r>
-                <a:rPr sz="700" b="1">
-                  <a:solidFill>
-                    <a:srgbClr val="FFFFFF"/>
-                  </a:solidFill>
-                  <a:latin typeface="Calibri"/>
-                </a:rPr>
-                <a:t>3</a:t>
-              </a:r>
-            </a:p>
-          </p:txBody>
-        </p:sp>
-      </p:grpSp>
-      <p:grpSp>
-        <p:nvGrpSpPr>
-          <p:cNvPr id="9017" name="dm_4"/>
-          <p:cNvGrpSpPr/>
-          <p:nvPr/>
-        </p:nvGrpSpPr>
-        <p:grpSpPr>
-          <a:xfrm>
-            <a:off x="3721608" y="2642616"/>
-            <a:ext cx="128016" cy="208666"/>
-            <a:chOff x="3721608" y="2642616"/>
-            <a:chExt cx="128016" cy="208666"/>
-          </a:xfrm>
-        </p:grpSpPr>
-        <p:sp>
-          <p:nvSpPr>
-            <p:cNvPr id="9036" name="Isosceles Triangle 9035"/>
-            <p:cNvSpPr/>
-            <p:nvPr/>
-          </p:nvSpPr>
-          <p:spPr>
-            <a:xfrm>
-              <a:off x="3740810" y="2642616"/>
-              <a:ext cx="89611" cy="70409"/>
-            </a:xfrm>
-            <a:prstGeom prst="triangle">
-              <a:avLst/>
-            </a:prstGeom>
-            <a:solidFill>
-              <a:srgbClr val="1A1A1A"/>
-            </a:solidFill>
-            <a:ln>
-              <a:noFill/>
-            </a:ln>
-            <a:effectLst/>
-          </p:spPr>
-          <p:style>
-            <a:lnRef idx="1">
-              <a:schemeClr val="accent1"/>
-            </a:lnRef>
-            <a:fillRef idx="3">
-              <a:schemeClr val="accent1"/>
-            </a:fillRef>
-            <a:effectRef idx="2">
-              <a:schemeClr val="accent1"/>
-            </a:effectRef>
-            <a:fontRef idx="minor">
-              <a:schemeClr val="lt1"/>
-            </a:fontRef>
-          </p:style>
-          <p:txBody>
-            <a:bodyPr rtlCol="0" anchor="ctr"/>
-            <a:lstStyle/>
-            <a:p>
-              <a:pPr algn="ctr"/>
-            </a:p>
-          </p:txBody>
-        </p:sp>
-        <p:sp>
-          <p:nvSpPr>
-            <p:cNvPr id="9037" name="Oval 9036"/>
-            <p:cNvSpPr/>
-            <p:nvPr/>
-          </p:nvSpPr>
-          <p:spPr>
-            <a:xfrm>
-              <a:off x="3721608" y="2723266"/>
-              <a:ext cx="128016" cy="128016"/>
-            </a:xfrm>
-            <a:prstGeom prst="ellipse">
-              <a:avLst/>
-            </a:prstGeom>
-            <a:solidFill>
-              <a:srgbClr val="1A1A1A"/>
-            </a:solidFill>
-            <a:ln>
-              <a:noFill/>
-            </a:ln>
-            <a:effectLst/>
-          </p:spPr>
-          <p:style>
-            <a:lnRef idx="1">
-              <a:schemeClr val="accent1"/>
-            </a:lnRef>
-            <a:fillRef idx="3">
-              <a:schemeClr val="accent1"/>
-            </a:fillRef>
-            <a:effectRef idx="2">
-              <a:schemeClr val="accent1"/>
-            </a:effectRef>
-            <a:fontRef idx="minor">
-              <a:schemeClr val="lt1"/>
-            </a:fontRef>
-          </p:style>
-          <p:txBody>
-            <a:bodyPr rtlCol="0" anchor="ctr" wrap="none" lIns="0" rIns="0" tIns="0" bIns="0"/>
-            <a:lstStyle/>
-            <a:p>
-              <a:pPr algn="ctr"/>
-              <a:r>
-                <a:rPr sz="700" b="1">
-                  <a:solidFill>
-                    <a:srgbClr val="FFFFFF"/>
-                  </a:solidFill>
-                  <a:latin typeface="Calibri"/>
-                </a:rPr>
-                <a:t>4</a:t>
-              </a:r>
-            </a:p>
-          </p:txBody>
-        </p:sp>
-      </p:grpSp>
-      <p:grpSp>
-        <p:nvGrpSpPr>
-          <p:cNvPr id="9018" name="dm_5"/>
-          <p:cNvGrpSpPr/>
-          <p:nvPr/>
-        </p:nvGrpSpPr>
-        <p:grpSpPr>
-          <a:xfrm>
-            <a:off x="4123944" y="2642616"/>
-            <a:ext cx="128016" cy="208666"/>
-            <a:chOff x="4123944" y="2642616"/>
-            <a:chExt cx="128016" cy="208666"/>
-          </a:xfrm>
-        </p:grpSpPr>
-        <p:sp>
-          <p:nvSpPr>
-            <p:cNvPr id="9038" name="Isosceles Triangle 9037"/>
-            <p:cNvSpPr/>
-            <p:nvPr/>
-          </p:nvSpPr>
-          <p:spPr>
-            <a:xfrm>
-              <a:off x="4143146" y="2642616"/>
-              <a:ext cx="89611" cy="70409"/>
-            </a:xfrm>
-            <a:prstGeom prst="triangle">
-              <a:avLst/>
-            </a:prstGeom>
-            <a:solidFill>
-              <a:srgbClr val="1A1A1A"/>
-            </a:solidFill>
-            <a:ln>
-              <a:noFill/>
-            </a:ln>
-            <a:effectLst/>
-          </p:spPr>
-          <p:style>
-            <a:lnRef idx="1">
-              <a:schemeClr val="accent1"/>
-            </a:lnRef>
-            <a:fillRef idx="3">
-              <a:schemeClr val="accent1"/>
-            </a:fillRef>
-            <a:effectRef idx="2">
-              <a:schemeClr val="accent1"/>
-            </a:effectRef>
-            <a:fontRef idx="minor">
-              <a:schemeClr val="lt1"/>
-            </a:fontRef>
-          </p:style>
-          <p:txBody>
-            <a:bodyPr rtlCol="0" anchor="ctr"/>
-            <a:lstStyle/>
-            <a:p>
-              <a:pPr algn="ctr"/>
-            </a:p>
-          </p:txBody>
-        </p:sp>
-        <p:sp>
-          <p:nvSpPr>
-            <p:cNvPr id="9039" name="Oval 9038"/>
-            <p:cNvSpPr/>
-            <p:nvPr/>
-          </p:nvSpPr>
-          <p:spPr>
-            <a:xfrm>
-              <a:off x="4123944" y="2723266"/>
-              <a:ext cx="128016" cy="128016"/>
-            </a:xfrm>
-            <a:prstGeom prst="ellipse">
-              <a:avLst/>
-            </a:prstGeom>
-            <a:solidFill>
-              <a:srgbClr val="1A1A1A"/>
-            </a:solidFill>
-            <a:ln>
-              <a:noFill/>
-            </a:ln>
-            <a:effectLst/>
-          </p:spPr>
-          <p:style>
-            <a:lnRef idx="1">
-              <a:schemeClr val="accent1"/>
-            </a:lnRef>
-            <a:fillRef idx="3">
-              <a:schemeClr val="accent1"/>
-            </a:fillRef>
-            <a:effectRef idx="2">
-              <a:schemeClr val="accent1"/>
-            </a:effectRef>
-            <a:fontRef idx="minor">
-              <a:schemeClr val="lt1"/>
-            </a:fontRef>
-          </p:style>
-          <p:txBody>
-            <a:bodyPr rtlCol="0" anchor="ctr" wrap="none" lIns="0" rIns="0" tIns="0" bIns="0"/>
-            <a:lstStyle/>
-            <a:p>
-              <a:pPr algn="ctr"/>
-              <a:r>
-                <a:rPr sz="700" b="1">
-                  <a:solidFill>
-                    <a:srgbClr val="FFFFFF"/>
-                  </a:solidFill>
-                  <a:latin typeface="Calibri"/>
-                </a:rPr>
-                <a:t>5</a:t>
-              </a:r>
-            </a:p>
-          </p:txBody>
-        </p:sp>
-      </p:grpSp>
-      <p:sp>
-        <p:nvSpPr>
-          <p:cNvPr id="9040" name="TextBox 9039"/>
-          <p:cNvSpPr txBox="1"/>
-          <p:nvPr/>
-        </p:nvSpPr>
-        <p:spPr>
-          <a:xfrm>
-            <a:off x="4754880" y="2423160"/>
-            <a:ext cx="7132320" cy="640080"/>
-          </a:xfrm>
-          <a:prstGeom prst="rect">
-            <a:avLst/>
-          </a:prstGeom>
-          <a:noFill/>
-          <a:effectLst/>
-        </p:spPr>
-        <p:txBody>
-          <a:bodyPr wrap="square" anchor="t" lIns="27432" rIns="27432" tIns="13716" bIns="13716">
-            <a:spAutoFit/>
-          </a:bodyPr>
-          <a:lstStyle/>
-          <a:p>
-            <a:pPr algn="l"/>
-            <a:r>
-              <a:rPr sz="700" b="1" lang="en-GB">
-                <a:solidFill>
-                  <a:srgbClr val="6B6B6B"/>
-                </a:solidFill>
-                <a:latin typeface="Calibri"/>
-              </a:rPr>
-              <a:t>SCALE + COLOUR</a:t>
-            </a:r>
-          </a:p>
-          <a:p>
-            <a:pPr algn="l"/>
-            <a:r>
-              <a:rPr sz="800" b="0" lang="en-GB">
-                <a:solidFill>
-                  <a:srgbClr val="1A1A1A"/>
-                </a:solidFill>
-                <a:latin typeface="Calibri"/>
-              </a:rPr>
-              <a:t>Markers are shown at true court scale — copy directly onto a diagram and they will be proportionally correct.  To recolour Team B: select all 5 markers, right-click → Format Shape → Fill → choose your opponent colour.</a:t>
-            </a:r>
-          </a:p>
-        </p:txBody>
-      </p:sp>
-      <p:cxnSp>
-        <p:nvCxnSpPr>
-          <p:cNvPr id="9041" name="Connector 9040"/>
-          <p:cNvCxnSpPr/>
-          <p:nvPr/>
-        </p:nvCxnSpPr>
-        <p:spPr>
-          <a:xfrm>
-            <a:off x="137160" y="3273552"/>
-            <a:ext cx="11917375" cy="0"/>
-          </a:xfrm>
-          <a:prstGeom prst="line">
-            <a:avLst/>
-          </a:prstGeom>
-          <a:ln w="6350">
-            <a:solidFill>
-              <a:srgbClr val="D9D9D9"/>
-            </a:solidFill>
-          </a:ln>
-          <a:effectLst/>
-        </p:spPr>
-        <p:style>
-          <a:lnRef idx="2">
-            <a:schemeClr val="accent1"/>
-          </a:lnRef>
-          <a:fillRef idx="0">
-            <a:schemeClr val="accent1"/>
-          </a:fillRef>
-          <a:effectRef idx="1">
-            <a:schemeClr val="accent1"/>
-          </a:effectRef>
-          <a:fontRef idx="minor">
-            <a:schemeClr val="tx1"/>
-          </a:fontRef>
-        </p:style>
-      </p:cxnSp>
-      <p:sp>
-        <p:nvSpPr>
-          <p:cNvPr id="9042" name="Rectangle 9041"/>
-          <p:cNvSpPr/>
-          <p:nvPr/>
-        </p:nvSpPr>
-        <p:spPr>
-          <a:xfrm>
-            <a:off x="365760" y="3364992"/>
-            <a:ext cx="36576" cy="146304"/>
-          </a:xfrm>
-          <a:prstGeom prst="rect">
-            <a:avLst/>
-          </a:prstGeom>
-          <a:solidFill>
-            <a:srgbClr val="0057B8"/>
-          </a:solidFill>
-          <a:ln>
-            <a:noFill/>
-          </a:ln>
-          <a:effectLst/>
-        </p:spPr>
-        <p:style>
-          <a:lnRef idx="1">
-            <a:schemeClr val="accent1"/>
-          </a:lnRef>
-          <a:fillRef idx="3">
-            <a:schemeClr val="accent1"/>
-          </a:fillRef>
-          <a:effectRef idx="2">
-            <a:schemeClr val="accent1"/>
-          </a:effectRef>
-          <a:fontRef idx="minor">
-            <a:schemeClr val="lt1"/>
-          </a:fontRef>
-        </p:style>
-        <p:txBody>
-          <a:bodyPr rtlCol="0" anchor="ctr"/>
-          <a:lstStyle/>
-          <a:p>
-            <a:pPr algn="ctr"/>
-          </a:p>
-        </p:txBody>
-      </p:sp>
-      <p:sp>
-        <p:nvSpPr>
-          <p:cNvPr id="9043" name="TextBox 9042"/>
-          <p:cNvSpPr txBox="1"/>
-          <p:nvPr/>
-        </p:nvSpPr>
-        <p:spPr>
-          <a:xfrm>
-            <a:off x="438912" y="3337560"/>
-            <a:ext cx="2377440" cy="201168"/>
-          </a:xfrm>
-          <a:prstGeom prst="rect">
-            <a:avLst/>
-          </a:prstGeom>
-          <a:noFill/>
-          <a:effectLst/>
-        </p:spPr>
-        <p:txBody>
-          <a:bodyPr wrap="square" anchor="t" lIns="27432" rIns="27432" tIns="13716" bIns="13716">
-            <a:spAutoFit/>
-          </a:bodyPr>
-          <a:lstStyle/>
-          <a:p>
-            <a:pPr algn="l"/>
-            <a:r>
-              <a:rPr sz="900" b="1" lang="en-GB">
-                <a:solidFill>
-                  <a:srgbClr val="1A1A1A"/>
-                </a:solidFill>
-                <a:latin typeface="Calibri"/>
-              </a:rPr>
-              <a:t>FULL COURT  (40m × 20m)</a:t>
-            </a:r>
-          </a:p>
-        </p:txBody>
-      </p:sp>
-      <p:grpSp>
-        <p:nvGrpSpPr>
-          <p:cNvPr id="9019" name="Library full court"/>
-          <p:cNvGrpSpPr/>
-          <p:nvPr/>
-        </p:nvGrpSpPr>
-        <p:grpSpPr>
-          <a:xfrm>
-            <a:off x="438912" y="3630168"/>
-            <a:ext cx="4151376" cy="2011680"/>
-            <a:chOff x="438912" y="3630168"/>
-            <a:chExt cx="4151376" cy="2011680"/>
-          </a:xfrm>
-        </p:grpSpPr>
-        <p:sp>
-          <p:nvSpPr>
-            <p:cNvPr id="9044" name="Rectangle 9043"/>
-            <p:cNvSpPr/>
-            <p:nvPr/>
-          </p:nvSpPr>
-          <p:spPr>
-            <a:xfrm>
-              <a:off x="502920" y="3630168"/>
-              <a:ext cx="4023360" cy="2011680"/>
-            </a:xfrm>
-            <a:prstGeom prst="rect">
-              <a:avLst/>
-            </a:prstGeom>
-            <a:noFill/>
-            <a:ln w="12700">
-              <a:solidFill>
-                <a:srgbClr val="A9B1BB"/>
-              </a:solidFill>
-            </a:ln>
-            <a:effectLst/>
-          </p:spPr>
-          <p:style>
-            <a:lnRef idx="1">
-              <a:schemeClr val="accent1"/>
-            </a:lnRef>
-            <a:fillRef idx="3">
-              <a:schemeClr val="accent1"/>
-            </a:fillRef>
-            <a:effectRef idx="2">
-              <a:schemeClr val="accent1"/>
-            </a:effectRef>
-            <a:fontRef idx="minor">
-              <a:schemeClr val="lt1"/>
-            </a:fontRef>
-          </p:style>
-          <p:txBody>
-            <a:bodyPr rtlCol="0" anchor="ctr"/>
-            <a:lstStyle/>
-            <a:p>
-              <a:pPr algn="ctr"/>
-            </a:p>
-          </p:txBody>
-        </p:sp>
-        <p:cxnSp>
-          <p:nvCxnSpPr>
-            <p:cNvPr id="9045" name="Connector 9044"/>
-            <p:cNvCxnSpPr/>
-            <p:nvPr/>
-          </p:nvCxnSpPr>
-          <p:spPr>
-            <a:xfrm>
-              <a:off x="2514600" y="3630168"/>
-              <a:ext cx="0" cy="2011680"/>
-            </a:xfrm>
-            <a:prstGeom prst="line">
-              <a:avLst/>
-            </a:prstGeom>
-            <a:ln w="9525">
-              <a:solidFill>
-                <a:srgbClr val="A9B1BB"/>
-              </a:solidFill>
-            </a:ln>
-            <a:effectLst/>
-          </p:spPr>
-          <p:style>
-            <a:lnRef idx="2">
-              <a:schemeClr val="accent1"/>
-            </a:lnRef>
-            <a:fillRef idx="0">
-              <a:schemeClr val="accent1"/>
-            </a:fillRef>
-            <a:effectRef idx="1">
-              <a:schemeClr val="accent1"/>
-            </a:effectRef>
-            <a:fontRef idx="minor">
-              <a:schemeClr val="tx1"/>
-            </a:fontRef>
-          </p:style>
-        </p:cxnSp>
-        <p:sp>
-          <p:nvSpPr>
-            <p:cNvPr id="9046" name="Oval 9045"/>
-            <p:cNvSpPr/>
-            <p:nvPr/>
-          </p:nvSpPr>
-          <p:spPr>
-            <a:xfrm>
-              <a:off x="2212848" y="4334256"/>
-              <a:ext cx="603504" cy="603504"/>
-            </a:xfrm>
-            <a:prstGeom prst="ellipse">
-              <a:avLst/>
-            </a:prstGeom>
-            <a:noFill/>
-            <a:ln w="9525">
-              <a:solidFill>
-                <a:srgbClr val="A9B1BB"/>
-              </a:solidFill>
-            </a:ln>
-            <a:effectLst/>
-          </p:spPr>
-          <p:style>
-            <a:lnRef idx="1">
-              <a:schemeClr val="accent1"/>
-            </a:lnRef>
-            <a:fillRef idx="3">
-              <a:schemeClr val="accent1"/>
-            </a:fillRef>
-            <a:effectRef idx="2">
-              <a:schemeClr val="accent1"/>
-            </a:effectRef>
-            <a:fontRef idx="minor">
-              <a:schemeClr val="lt1"/>
-            </a:fontRef>
-          </p:style>
-          <p:txBody>
-            <a:bodyPr rtlCol="0" anchor="ctr"/>
-            <a:lstStyle/>
-            <a:p>
-              <a:pPr algn="ctr"/>
-            </a:p>
-          </p:txBody>
-        </p:sp>
-        <p:sp>
-          <p:nvSpPr>
-            <p:cNvPr id="9047" name="Oval 9046"/>
-            <p:cNvSpPr/>
-            <p:nvPr/>
-          </p:nvSpPr>
-          <p:spPr>
-            <a:xfrm>
               <a:off x="2498598" y="4620006"/>
               <a:ext cx="32004" cy="32004"/>
             </a:xfrm>
@@ -28000,7 +27829,7 @@
         </p:sp>
         <p:sp>
           <p:nvSpPr>
-            <p:cNvPr id="9048" name="Arc 9047"/>
+            <p:cNvPr id="9036" name="Arc 9035"/>
             <p:cNvSpPr/>
             <p:nvPr/>
           </p:nvSpPr>
@@ -28047,7 +27876,7 @@
         </p:sp>
         <p:sp>
           <p:nvSpPr>
-            <p:cNvPr id="9049" name="Arc 9048"/>
+            <p:cNvPr id="9037" name="Arc 9036"/>
             <p:cNvSpPr/>
             <p:nvPr/>
           </p:nvSpPr>
@@ -28094,7 +27923,7 @@
         </p:sp>
         <p:cxnSp>
           <p:nvCxnSpPr>
-            <p:cNvPr id="9050" name="Connector 9049"/>
+            <p:cNvPr id="9038" name="Connector 9037"/>
             <p:cNvCxnSpPr/>
             <p:nvPr/>
           </p:nvCxnSpPr>
@@ -28130,7 +27959,7 @@
         </p:cxnSp>
         <p:sp>
           <p:nvSpPr>
-            <p:cNvPr id="9051" name="Oval 9050"/>
+            <p:cNvPr id="9039" name="Oval 9038"/>
             <p:cNvSpPr/>
             <p:nvPr/>
           </p:nvSpPr>
@@ -28174,7 +28003,7 @@
         </p:sp>
         <p:sp>
           <p:nvSpPr>
-            <p:cNvPr id="9052" name="Oval 9051"/>
+            <p:cNvPr id="9040" name="Oval 9039"/>
             <p:cNvSpPr/>
             <p:nvPr/>
           </p:nvSpPr>
@@ -28218,7 +28047,7 @@
         </p:sp>
         <p:sp>
           <p:nvSpPr>
-            <p:cNvPr id="9053" name="Rectangle 9052"/>
+            <p:cNvPr id="9041" name="Rectangle 9040"/>
             <p:cNvSpPr/>
             <p:nvPr/>
           </p:nvSpPr>
@@ -28262,7 +28091,7 @@
         </p:sp>
         <p:sp>
           <p:nvSpPr>
-            <p:cNvPr id="9054" name="Arc 9053"/>
+            <p:cNvPr id="9042" name="Arc 9041"/>
             <p:cNvSpPr/>
             <p:nvPr/>
           </p:nvSpPr>
@@ -28309,7 +28138,7 @@
         </p:sp>
         <p:sp>
           <p:nvSpPr>
-            <p:cNvPr id="9055" name="Arc 9054"/>
+            <p:cNvPr id="9043" name="Arc 9042"/>
             <p:cNvSpPr/>
             <p:nvPr/>
           </p:nvSpPr>
@@ -28356,7 +28185,7 @@
         </p:sp>
         <p:cxnSp>
           <p:nvCxnSpPr>
-            <p:cNvPr id="9056" name="Connector 9055"/>
+            <p:cNvPr id="9044" name="Connector 9043"/>
             <p:cNvCxnSpPr/>
             <p:nvPr/>
           </p:nvCxnSpPr>
@@ -28392,7 +28221,7 @@
         </p:cxnSp>
         <p:sp>
           <p:nvSpPr>
-            <p:cNvPr id="9057" name="Oval 9056"/>
+            <p:cNvPr id="9045" name="Oval 9044"/>
             <p:cNvSpPr/>
             <p:nvPr/>
           </p:nvSpPr>
@@ -28436,7 +28265,7 @@
         </p:sp>
         <p:sp>
           <p:nvSpPr>
-            <p:cNvPr id="9058" name="Oval 9057"/>
+            <p:cNvPr id="9046" name="Oval 9045"/>
             <p:cNvSpPr/>
             <p:nvPr/>
           </p:nvSpPr>
@@ -28480,7 +28309,7 @@
         </p:sp>
         <p:sp>
           <p:nvSpPr>
-            <p:cNvPr id="9059" name="Rectangle 9058"/>
+            <p:cNvPr id="9047" name="Rectangle 9046"/>
             <p:cNvSpPr/>
             <p:nvPr/>
           </p:nvSpPr>
@@ -28525,7 +28354,7 @@
       </p:grpSp>
       <p:sp>
         <p:nvSpPr>
-          <p:cNvPr id="9060" name="Rectangle 9059"/>
+          <p:cNvPr id="9048" name="Rectangle 9047"/>
           <p:cNvSpPr/>
           <p:nvPr/>
         </p:nvSpPr>
@@ -28569,7 +28398,7 @@
       </p:sp>
       <p:sp>
         <p:nvSpPr>
-          <p:cNvPr id="9061" name="TextBox 9060"/>
+          <p:cNvPr id="9049" name="TextBox 9048"/>
           <p:cNvSpPr txBox="1"/>
           <p:nvPr/>
         </p:nvSpPr>
@@ -28585,7 +28414,7 @@
           <a:effectLst/>
         </p:spPr>
         <p:txBody>
-          <a:bodyPr wrap="square" anchor="t" lIns="27432" rIns="27432" tIns="13716" bIns="13716">
+          <a:bodyPr wrap="none" anchor="t" lIns="27432" rIns="27432" tIns="13716" bIns="13716">
             <a:spAutoFit/>
           </a:bodyPr>
           <a:lstStyle/>
@@ -28605,7 +28434,7 @@
       </p:sp>
       <p:grpSp>
         <p:nvGrpSpPr>
-          <p:cNvPr id="9020" name="Library half court"/>
+          <p:cNvPr id="9009" name="Library half court"/>
           <p:cNvGrpSpPr/>
           <p:nvPr/>
         </p:nvGrpSpPr>
@@ -28619,7 +28448,7 @@
         </p:grpSpPr>
         <p:sp>
           <p:nvSpPr>
-            <p:cNvPr id="9062" name="Rectangle 9061"/>
+            <p:cNvPr id="9050" name="Rectangle 9049"/>
             <p:cNvSpPr/>
             <p:nvPr/>
           </p:nvSpPr>
@@ -28663,7 +28492,7 @@
         </p:sp>
         <p:sp>
           <p:nvSpPr>
-            <p:cNvPr id="9063" name="Arc 9062"/>
+            <p:cNvPr id="9051" name="Arc 9050"/>
             <p:cNvSpPr/>
             <p:nvPr/>
           </p:nvSpPr>
@@ -28710,7 +28539,7 @@
         </p:sp>
         <p:sp>
           <p:nvSpPr>
-            <p:cNvPr id="9064" name="Oval 9063"/>
+            <p:cNvPr id="9052" name="Oval 9051"/>
             <p:cNvSpPr/>
             <p:nvPr/>
           </p:nvSpPr>
@@ -28754,7 +28583,7 @@
         </p:sp>
         <p:sp>
           <p:nvSpPr>
-            <p:cNvPr id="9065" name="Arc 9064"/>
+            <p:cNvPr id="9053" name="Arc 9052"/>
             <p:cNvSpPr/>
             <p:nvPr/>
           </p:nvSpPr>
@@ -28801,7 +28630,7 @@
         </p:sp>
         <p:sp>
           <p:nvSpPr>
-            <p:cNvPr id="9066" name="Arc 9065"/>
+            <p:cNvPr id="9054" name="Arc 9053"/>
             <p:cNvSpPr/>
             <p:nvPr/>
           </p:nvSpPr>
@@ -28848,7 +28677,7 @@
         </p:sp>
         <p:cxnSp>
           <p:nvCxnSpPr>
-            <p:cNvPr id="9067" name="Connector 9066"/>
+            <p:cNvPr id="9055" name="Connector 9054"/>
             <p:cNvCxnSpPr/>
             <p:nvPr/>
           </p:nvCxnSpPr>
@@ -28884,7 +28713,7 @@
         </p:cxnSp>
         <p:sp>
           <p:nvSpPr>
-            <p:cNvPr id="9068" name="Oval 9067"/>
+            <p:cNvPr id="9056" name="Oval 9055"/>
             <p:cNvSpPr/>
             <p:nvPr/>
           </p:nvSpPr>
@@ -28928,7 +28757,7 @@
         </p:sp>
         <p:sp>
           <p:nvSpPr>
-            <p:cNvPr id="9069" name="Oval 9068"/>
+            <p:cNvPr id="9057" name="Oval 9056"/>
             <p:cNvSpPr/>
             <p:nvPr/>
           </p:nvSpPr>
@@ -28972,7 +28801,7 @@
         </p:sp>
         <p:sp>
           <p:nvSpPr>
-            <p:cNvPr id="9070" name="Rectangle 9069"/>
+            <p:cNvPr id="9058" name="Rectangle 9057"/>
             <p:cNvSpPr/>
             <p:nvPr/>
           </p:nvSpPr>
@@ -29017,7 +28846,7 @@
       </p:grpSp>
       <p:sp>
         <p:nvSpPr>
-          <p:cNvPr id="9071" name="TextBox 9070"/>
+          <p:cNvPr id="9059" name="TextBox 9058"/>
           <p:cNvSpPr txBox="1"/>
           <p:nvPr/>
         </p:nvSpPr>
@@ -29113,7 +28942,7 @@
       </p:sp>
       <p:sp>
         <p:nvSpPr>
-          <p:cNvPr id="9072" name="TextBox 9071"/>
+          <p:cNvPr id="9060" name="TextBox 9059"/>
           <p:cNvSpPr txBox="1"/>
           <p:nvPr/>
         </p:nvSpPr>
@@ -29142,7 +28971,7 @@
                 </a:solidFill>
                 <a:latin typeface="Calibri"/>
               </a:rPr>
-              <a:t>COMPONENT LIBRARY  —  court-scale tactical symbols  ·  copy into any diagram zone  ·  directional markers: rotate to show body shape</a:t>
+              <a:t>COMPONENT LIBRARY  —  court-scale tactical symbols  ·  copy into any diagram zone  ·  pucks + vision cones: rotate to show body shape and field of view</a:t>
             </a:r>
           </a:p>
         </p:txBody>

</xml_diff>

<commit_message>
Add scanning awareness zone (180°, ≈5.5 m) and combined awareness group
New tactical symbols added to Component Library (Slide 4, Row 3):
- draw_scan_zone(): player circle + 180° upward PIE arc, dashed outline,
  10% opacity — represents full scanning sweep before receiving
- draw_combined_awareness(): all three layers in one grouped object
  (scan zone + vision cone + body-shape puck) for complete orientation
  picture; rotate the group to orient the player

Scan radius = MARKER_D × 3.2 = 0.448" ≈ 5.5 m at court scale,
deliberately larger than vision cone (1.75× = 0.245" ≈ 3 m).

https://claude.ai/code/session_018tafNEeKNQ7u7wPXfzwa7T
</commit_message>
<xml_diff>
--- a/futsal_session_template.pptx
+++ b/futsal_session_template.pptx
@@ -26831,16 +26831,136 @@
           </a:fontRef>
         </p:style>
       </p:cxnSp>
-      <p:sp>
-        <p:nvSpPr>
-          <p:cNvPr id="9016" name="TextBox 9015"/>
+      <p:grpSp>
+        <p:nvGrpSpPr>
+          <p:cNvPr id="9008" name="scan_A"/>
+          <p:cNvGrpSpPr/>
+          <p:nvPr/>
+        </p:nvGrpSpPr>
+        <p:grpSpPr>
+          <a:xfrm>
+            <a:off x="248717" y="2690165"/>
+            <a:ext cx="819302" cy="819302"/>
+            <a:chOff x="248717" y="2690165"/>
+            <a:chExt cx="819302" cy="819302"/>
+          </a:xfrm>
+        </p:grpSpPr>
+        <p:sp>
+          <p:nvSpPr>
+            <p:cNvPr id="9016" name="Pie 9015"/>
+            <p:cNvSpPr/>
+            <p:nvPr/>
+          </p:nvSpPr>
+          <p:spPr>
+            <a:xfrm>
+              <a:off x="248717" y="2690165"/>
+              <a:ext cx="819302" cy="819302"/>
+            </a:xfrm>
+            <a:prstGeom prst="pie">
+              <a:avLst>
+                <a:gd name="adj1" fmla="val 10800000"/>
+                <a:gd name="adj2" fmla="val 21600000"/>
+              </a:avLst>
+            </a:prstGeom>
+            <a:solidFill>
+              <a:srgbClr val="0057B8">
+                <a:alpha val="10000"/>
+              </a:srgbClr>
+            </a:solidFill>
+            <a:ln w="12700">
+              <a:solidFill>
+                <a:srgbClr val="0057B8"/>
+              </a:solidFill>
+              <a:prstDash val="dash"/>
+            </a:ln>
+            <a:effectLst/>
+          </p:spPr>
+          <p:style>
+            <a:lnRef idx="1">
+              <a:schemeClr val="accent1"/>
+            </a:lnRef>
+            <a:fillRef idx="3">
+              <a:schemeClr val="accent1"/>
+            </a:fillRef>
+            <a:effectRef idx="2">
+              <a:schemeClr val="accent1"/>
+            </a:effectRef>
+            <a:fontRef idx="minor">
+              <a:schemeClr val="lt1"/>
+            </a:fontRef>
+          </p:style>
+          <p:txBody>
+            <a:bodyPr rtlCol="0" anchor="ctr"/>
+            <a:lstStyle/>
+            <a:p>
+              <a:pPr algn="ctr"/>
+            </a:p>
+          </p:txBody>
+        </p:sp>
+        <p:sp>
+          <p:nvSpPr>
+            <p:cNvPr id="9017" name="Oval 9016"/>
+            <p:cNvSpPr/>
+            <p:nvPr/>
+          </p:nvSpPr>
+          <p:spPr>
+            <a:xfrm>
+              <a:off x="594360" y="3035808"/>
+              <a:ext cx="128016" cy="128016"/>
+            </a:xfrm>
+            <a:prstGeom prst="ellipse">
+              <a:avLst/>
+            </a:prstGeom>
+            <a:solidFill>
+              <a:srgbClr val="0057B8"/>
+            </a:solidFill>
+            <a:ln>
+              <a:noFill/>
+            </a:ln>
+            <a:effectLst/>
+          </p:spPr>
+          <p:style>
+            <a:lnRef idx="1">
+              <a:schemeClr val="accent1"/>
+            </a:lnRef>
+            <a:fillRef idx="3">
+              <a:schemeClr val="accent1"/>
+            </a:fillRef>
+            <a:effectRef idx="2">
+              <a:schemeClr val="accent1"/>
+            </a:effectRef>
+            <a:fontRef idx="minor">
+              <a:schemeClr val="lt1"/>
+            </a:fontRef>
+          </p:style>
+          <p:txBody>
+            <a:bodyPr rtlCol="0" anchor="ctr" wrap="none" lIns="0" rIns="0" tIns="0" bIns="0"/>
+            <a:lstStyle/>
+            <a:p>
+              <a:pPr algn="ctr"/>
+              <a:r>
+                <a:rPr sz="700" b="1">
+                  <a:solidFill>
+                    <a:srgbClr val="FFFFFF"/>
+                  </a:solidFill>
+                  <a:latin typeface="Calibri"/>
+                </a:rPr>
+                <a:t>A</a:t>
+              </a:r>
+            </a:p>
+          </p:txBody>
+        </p:sp>
+      </p:grpSp>
+      <p:sp>
+        <p:nvSpPr>
+          <p:cNvPr id="9018" name="TextBox 9017"/>
           <p:cNvSpPr txBox="1"/>
           <p:nvPr/>
         </p:nvSpPr>
         <p:spPr>
           <a:xfrm>
-            <a:off x="365760" y="2724912"/>
-            <a:ext cx="2194560" cy="182880"/>
+            <a:off x="521208" y="3218688"/>
+            <a:ext cx="457200" cy="164592"/>
           </a:xfrm>
           <a:prstGeom prst="rect">
             <a:avLst/>
@@ -26849,6 +26969,644 @@
           <a:effectLst/>
         </p:spPr>
         <p:txBody>
+          <a:bodyPr wrap="none" anchor="t" lIns="27432" rIns="27432" tIns="13716" bIns="13716">
+            <a:spAutoFit/>
+          </a:bodyPr>
+          <a:lstStyle/>
+          <a:p>
+            <a:pPr algn="ctr"/>
+            <a:r>
+              <a:rPr sz="650" b="0" lang="en-GB">
+                <a:solidFill>
+                  <a:srgbClr val="6B6B6B"/>
+                </a:solidFill>
+                <a:latin typeface="Calibri"/>
+              </a:rPr>
+              <a:t>Attacker</a:t>
+            </a:r>
+          </a:p>
+        </p:txBody>
+      </p:sp>
+      <p:grpSp>
+        <p:nvGrpSpPr>
+          <p:cNvPr id="9009" name="scan_D"/>
+          <p:cNvGrpSpPr/>
+          <p:nvPr/>
+        </p:nvGrpSpPr>
+        <p:grpSpPr>
+          <a:xfrm>
+            <a:off x="1254557" y="2690165"/>
+            <a:ext cx="819302" cy="819302"/>
+            <a:chOff x="1254557" y="2690165"/>
+            <a:chExt cx="819302" cy="819302"/>
+          </a:xfrm>
+        </p:grpSpPr>
+        <p:sp>
+          <p:nvSpPr>
+            <p:cNvPr id="9019" name="Pie 9018"/>
+            <p:cNvSpPr/>
+            <p:nvPr/>
+          </p:nvSpPr>
+          <p:spPr>
+            <a:xfrm>
+              <a:off x="1254557" y="2690165"/>
+              <a:ext cx="819302" cy="819302"/>
+            </a:xfrm>
+            <a:prstGeom prst="pie">
+              <a:avLst>
+                <a:gd name="adj1" fmla="val 10800000"/>
+                <a:gd name="adj2" fmla="val 21600000"/>
+              </a:avLst>
+            </a:prstGeom>
+            <a:solidFill>
+              <a:srgbClr val="6B6B6B">
+                <a:alpha val="10000"/>
+              </a:srgbClr>
+            </a:solidFill>
+            <a:ln w="12700">
+              <a:solidFill>
+                <a:srgbClr val="6B6B6B"/>
+              </a:solidFill>
+              <a:prstDash val="dash"/>
+            </a:ln>
+            <a:effectLst/>
+          </p:spPr>
+          <p:style>
+            <a:lnRef idx="1">
+              <a:schemeClr val="accent1"/>
+            </a:lnRef>
+            <a:fillRef idx="3">
+              <a:schemeClr val="accent1"/>
+            </a:fillRef>
+            <a:effectRef idx="2">
+              <a:schemeClr val="accent1"/>
+            </a:effectRef>
+            <a:fontRef idx="minor">
+              <a:schemeClr val="lt1"/>
+            </a:fontRef>
+          </p:style>
+          <p:txBody>
+            <a:bodyPr rtlCol="0" anchor="ctr"/>
+            <a:lstStyle/>
+            <a:p>
+              <a:pPr algn="ctr"/>
+            </a:p>
+          </p:txBody>
+        </p:sp>
+        <p:sp>
+          <p:nvSpPr>
+            <p:cNvPr id="9020" name="Oval 9019"/>
+            <p:cNvSpPr/>
+            <p:nvPr/>
+          </p:nvSpPr>
+          <p:spPr>
+            <a:xfrm>
+              <a:off x="1600200" y="3035808"/>
+              <a:ext cx="128016" cy="128016"/>
+            </a:xfrm>
+            <a:prstGeom prst="ellipse">
+              <a:avLst/>
+            </a:prstGeom>
+            <a:solidFill>
+              <a:srgbClr val="FFFFFF"/>
+            </a:solidFill>
+            <a:ln w="12700">
+              <a:solidFill>
+                <a:srgbClr val="6B6B6B"/>
+              </a:solidFill>
+            </a:ln>
+            <a:effectLst/>
+          </p:spPr>
+          <p:style>
+            <a:lnRef idx="1">
+              <a:schemeClr val="accent1"/>
+            </a:lnRef>
+            <a:fillRef idx="3">
+              <a:schemeClr val="accent1"/>
+            </a:fillRef>
+            <a:effectRef idx="2">
+              <a:schemeClr val="accent1"/>
+            </a:effectRef>
+            <a:fontRef idx="minor">
+              <a:schemeClr val="lt1"/>
+            </a:fontRef>
+          </p:style>
+          <p:txBody>
+            <a:bodyPr rtlCol="0" anchor="ctr" wrap="none" lIns="0" rIns="0" tIns="0" bIns="0"/>
+            <a:lstStyle/>
+            <a:p>
+              <a:pPr algn="ctr"/>
+              <a:r>
+                <a:rPr sz="700" b="1">
+                  <a:solidFill>
+                    <a:srgbClr val="6B6B6B"/>
+                  </a:solidFill>
+                  <a:latin typeface="Calibri"/>
+                </a:rPr>
+                <a:t>D</a:t>
+              </a:r>
+            </a:p>
+          </p:txBody>
+        </p:sp>
+      </p:grpSp>
+      <p:sp>
+        <p:nvSpPr>
+          <p:cNvPr id="9021" name="TextBox 9020"/>
+          <p:cNvSpPr txBox="1"/>
+          <p:nvPr/>
+        </p:nvSpPr>
+        <p:spPr>
+          <a:xfrm>
+            <a:off x="1527048" y="3218688"/>
+            <a:ext cx="457200" cy="164592"/>
+          </a:xfrm>
+          <a:prstGeom prst="rect">
+            <a:avLst/>
+          </a:prstGeom>
+          <a:noFill/>
+          <a:effectLst/>
+        </p:spPr>
+        <p:txBody>
+          <a:bodyPr wrap="none" anchor="t" lIns="27432" rIns="27432" tIns="13716" bIns="13716">
+            <a:spAutoFit/>
+          </a:bodyPr>
+          <a:lstStyle/>
+          <a:p>
+            <a:pPr algn="ctr"/>
+            <a:r>
+              <a:rPr sz="650" b="0" lang="en-GB">
+                <a:solidFill>
+                  <a:srgbClr val="6B6B6B"/>
+                </a:solidFill>
+                <a:latin typeface="Calibri"/>
+              </a:rPr>
+              <a:t>Defender</a:t>
+            </a:r>
+          </a:p>
+        </p:txBody>
+      </p:sp>
+      <p:grpSp>
+        <p:nvGrpSpPr>
+          <p:cNvPr id="9010" name="scan_G"/>
+          <p:cNvGrpSpPr/>
+          <p:nvPr/>
+        </p:nvGrpSpPr>
+        <p:grpSpPr>
+          <a:xfrm>
+            <a:off x="2260397" y="2690165"/>
+            <a:ext cx="819302" cy="819302"/>
+            <a:chOff x="2260397" y="2690165"/>
+            <a:chExt cx="819302" cy="819302"/>
+          </a:xfrm>
+        </p:grpSpPr>
+        <p:sp>
+          <p:nvSpPr>
+            <p:cNvPr id="9022" name="Pie 9021"/>
+            <p:cNvSpPr/>
+            <p:nvPr/>
+          </p:nvSpPr>
+          <p:spPr>
+            <a:xfrm>
+              <a:off x="2260397" y="2690165"/>
+              <a:ext cx="819302" cy="819302"/>
+            </a:xfrm>
+            <a:prstGeom prst="pie">
+              <a:avLst>
+                <a:gd name="adj1" fmla="val 10800000"/>
+                <a:gd name="adj2" fmla="val 21600000"/>
+              </a:avLst>
+            </a:prstGeom>
+            <a:solidFill>
+              <a:srgbClr val="1A1A1A">
+                <a:alpha val="10000"/>
+              </a:srgbClr>
+            </a:solidFill>
+            <a:ln w="12700">
+              <a:solidFill>
+                <a:srgbClr val="1A1A1A"/>
+              </a:solidFill>
+              <a:prstDash val="dash"/>
+            </a:ln>
+            <a:effectLst/>
+          </p:spPr>
+          <p:style>
+            <a:lnRef idx="1">
+              <a:schemeClr val="accent1"/>
+            </a:lnRef>
+            <a:fillRef idx="3">
+              <a:schemeClr val="accent1"/>
+            </a:fillRef>
+            <a:effectRef idx="2">
+              <a:schemeClr val="accent1"/>
+            </a:effectRef>
+            <a:fontRef idx="minor">
+              <a:schemeClr val="lt1"/>
+            </a:fontRef>
+          </p:style>
+          <p:txBody>
+            <a:bodyPr rtlCol="0" anchor="ctr"/>
+            <a:lstStyle/>
+            <a:p>
+              <a:pPr algn="ctr"/>
+            </a:p>
+          </p:txBody>
+        </p:sp>
+        <p:sp>
+          <p:nvSpPr>
+            <p:cNvPr id="9023" name="Oval 9022"/>
+            <p:cNvSpPr/>
+            <p:nvPr/>
+          </p:nvSpPr>
+          <p:spPr>
+            <a:xfrm>
+              <a:off x="2606040" y="3035808"/>
+              <a:ext cx="128016" cy="128016"/>
+            </a:xfrm>
+            <a:prstGeom prst="ellipse">
+              <a:avLst/>
+            </a:prstGeom>
+            <a:solidFill>
+              <a:srgbClr val="1A1A1A"/>
+            </a:solidFill>
+            <a:ln>
+              <a:noFill/>
+            </a:ln>
+            <a:effectLst/>
+          </p:spPr>
+          <p:style>
+            <a:lnRef idx="1">
+              <a:schemeClr val="accent1"/>
+            </a:lnRef>
+            <a:fillRef idx="3">
+              <a:schemeClr val="accent1"/>
+            </a:fillRef>
+            <a:effectRef idx="2">
+              <a:schemeClr val="accent1"/>
+            </a:effectRef>
+            <a:fontRef idx="minor">
+              <a:schemeClr val="lt1"/>
+            </a:fontRef>
+          </p:style>
+          <p:txBody>
+            <a:bodyPr rtlCol="0" anchor="ctr" wrap="none" lIns="0" rIns="0" tIns="0" bIns="0"/>
+            <a:lstStyle/>
+            <a:p>
+              <a:pPr algn="ctr"/>
+              <a:r>
+                <a:rPr sz="700" b="1">
+                  <a:solidFill>
+                    <a:srgbClr val="FFFFFF"/>
+                  </a:solidFill>
+                  <a:latin typeface="Calibri"/>
+                </a:rPr>
+                <a:t>G</a:t>
+              </a:r>
+            </a:p>
+          </p:txBody>
+        </p:sp>
+      </p:grpSp>
+      <p:sp>
+        <p:nvSpPr>
+          <p:cNvPr id="9024" name="TextBox 9023"/>
+          <p:cNvSpPr txBox="1"/>
+          <p:nvPr/>
+        </p:nvSpPr>
+        <p:spPr>
+          <a:xfrm>
+            <a:off x="2532888" y="3218688"/>
+            <a:ext cx="457200" cy="164592"/>
+          </a:xfrm>
+          <a:prstGeom prst="rect">
+            <a:avLst/>
+          </a:prstGeom>
+          <a:noFill/>
+          <a:effectLst/>
+        </p:spPr>
+        <p:txBody>
+          <a:bodyPr wrap="none" anchor="t" lIns="27432" rIns="27432" tIns="13716" bIns="13716">
+            <a:spAutoFit/>
+          </a:bodyPr>
+          <a:lstStyle/>
+          <a:p>
+            <a:pPr algn="ctr"/>
+            <a:r>
+              <a:rPr sz="650" b="0" lang="en-GB">
+                <a:solidFill>
+                  <a:srgbClr val="6B6B6B"/>
+                </a:solidFill>
+                <a:latin typeface="Calibri"/>
+              </a:rPr>
+              <a:t>GK</a:t>
+            </a:r>
+          </a:p>
+        </p:txBody>
+      </p:sp>
+      <p:grpSp>
+        <p:nvGrpSpPr>
+          <p:cNvPr id="9011" name="combined_A"/>
+          <p:cNvGrpSpPr/>
+          <p:nvPr/>
+        </p:nvGrpSpPr>
+        <p:grpSpPr>
+          <a:xfrm>
+            <a:off x="3385109" y="2690165"/>
+            <a:ext cx="819302" cy="819302"/>
+            <a:chOff x="3385109" y="2690165"/>
+            <a:chExt cx="819302" cy="819302"/>
+          </a:xfrm>
+        </p:grpSpPr>
+        <p:sp>
+          <p:nvSpPr>
+            <p:cNvPr id="9025" name="Pie 9024"/>
+            <p:cNvSpPr/>
+            <p:nvPr/>
+          </p:nvSpPr>
+          <p:spPr>
+            <a:xfrm>
+              <a:off x="3385109" y="2690165"/>
+              <a:ext cx="819302" cy="819302"/>
+            </a:xfrm>
+            <a:prstGeom prst="pie">
+              <a:avLst>
+                <a:gd name="adj1" fmla="val 10800000"/>
+                <a:gd name="adj2" fmla="val 21600000"/>
+              </a:avLst>
+            </a:prstGeom>
+            <a:solidFill>
+              <a:srgbClr val="0057B8">
+                <a:alpha val="10000"/>
+              </a:srgbClr>
+            </a:solidFill>
+            <a:ln w="12700">
+              <a:solidFill>
+                <a:srgbClr val="0057B8"/>
+              </a:solidFill>
+              <a:prstDash val="dash"/>
+            </a:ln>
+            <a:effectLst/>
+          </p:spPr>
+          <p:style>
+            <a:lnRef idx="1">
+              <a:schemeClr val="accent1"/>
+            </a:lnRef>
+            <a:fillRef idx="3">
+              <a:schemeClr val="accent1"/>
+            </a:fillRef>
+            <a:effectRef idx="2">
+              <a:schemeClr val="accent1"/>
+            </a:effectRef>
+            <a:fontRef idx="minor">
+              <a:schemeClr val="lt1"/>
+            </a:fontRef>
+          </p:style>
+          <p:txBody>
+            <a:bodyPr rtlCol="0" anchor="ctr"/>
+            <a:lstStyle/>
+            <a:p>
+              <a:pPr algn="ctr"/>
+            </a:p>
+          </p:txBody>
+        </p:sp>
+        <p:sp>
+          <p:nvSpPr>
+            <p:cNvPr id="9026" name="Pie 9025"/>
+            <p:cNvSpPr/>
+            <p:nvPr/>
+          </p:nvSpPr>
+          <p:spPr>
+            <a:xfrm>
+              <a:off x="3570732" y="2875788"/>
+              <a:ext cx="448056" cy="448056"/>
+            </a:xfrm>
+            <a:prstGeom prst="pie">
+              <a:avLst>
+                <a:gd name="adj1" fmla="val 14100000"/>
+                <a:gd name="adj2" fmla="val 18300000"/>
+              </a:avLst>
+            </a:prstGeom>
+            <a:solidFill>
+              <a:srgbClr val="0057B8">
+                <a:alpha val="22000"/>
+              </a:srgbClr>
+            </a:solidFill>
+            <a:ln>
+              <a:noFill/>
+            </a:ln>
+            <a:effectLst/>
+          </p:spPr>
+          <p:style>
+            <a:lnRef idx="1">
+              <a:schemeClr val="accent1"/>
+            </a:lnRef>
+            <a:fillRef idx="3">
+              <a:schemeClr val="accent1"/>
+            </a:fillRef>
+            <a:effectRef idx="2">
+              <a:schemeClr val="accent1"/>
+            </a:effectRef>
+            <a:fontRef idx="minor">
+              <a:schemeClr val="lt1"/>
+            </a:fontRef>
+          </p:style>
+          <p:txBody>
+            <a:bodyPr rtlCol="0" anchor="ctr"/>
+            <a:lstStyle/>
+            <a:p>
+              <a:pPr algn="ctr"/>
+            </a:p>
+          </p:txBody>
+        </p:sp>
+        <p:sp>
+          <p:nvSpPr>
+            <p:cNvPr id="9027" name="Chord 9026"/>
+            <p:cNvSpPr/>
+            <p:nvPr/>
+          </p:nvSpPr>
+          <p:spPr>
+            <a:xfrm>
+              <a:off x="3730752" y="3035808"/>
+              <a:ext cx="128016" cy="128016"/>
+            </a:xfrm>
+            <a:prstGeom prst="chord">
+              <a:avLst>
+                <a:gd name="adj1" fmla="val 9000000"/>
+                <a:gd name="adj2" fmla="val 1800000"/>
+              </a:avLst>
+            </a:prstGeom>
+            <a:solidFill>
+              <a:srgbClr val="0057B8"/>
+            </a:solidFill>
+            <a:ln>
+              <a:noFill/>
+            </a:ln>
+            <a:effectLst/>
+          </p:spPr>
+          <p:style>
+            <a:lnRef idx="1">
+              <a:schemeClr val="accent1"/>
+            </a:lnRef>
+            <a:fillRef idx="3">
+              <a:schemeClr val="accent1"/>
+            </a:fillRef>
+            <a:effectRef idx="2">
+              <a:schemeClr val="accent1"/>
+            </a:effectRef>
+            <a:fontRef idx="minor">
+              <a:schemeClr val="lt1"/>
+            </a:fontRef>
+          </p:style>
+          <p:txBody>
+            <a:bodyPr rtlCol="0" anchor="ctr" wrap="none" lIns="0" rIns="0" tIns="0" bIns="27432"/>
+            <a:lstStyle/>
+            <a:p>
+              <a:pPr algn="ctr"/>
+              <a:r>
+                <a:rPr sz="700" b="1">
+                  <a:solidFill>
+                    <a:srgbClr val="FFFFFF"/>
+                  </a:solidFill>
+                  <a:latin typeface="Calibri"/>
+                </a:rPr>
+                <a:t>A</a:t>
+              </a:r>
+            </a:p>
+          </p:txBody>
+        </p:sp>
+      </p:grpSp>
+      <p:sp>
+        <p:nvSpPr>
+          <p:cNvPr id="9028" name="TextBox 9027"/>
+          <p:cNvSpPr txBox="1"/>
+          <p:nvPr/>
+        </p:nvSpPr>
+        <p:spPr>
+          <a:xfrm>
+            <a:off x="3602736" y="3218688"/>
+            <a:ext cx="530352" cy="164592"/>
+          </a:xfrm>
+          <a:prstGeom prst="rect">
+            <a:avLst/>
+          </a:prstGeom>
+          <a:noFill/>
+          <a:effectLst/>
+        </p:spPr>
+        <p:txBody>
+          <a:bodyPr wrap="none" anchor="t" lIns="27432" rIns="27432" tIns="13716" bIns="13716">
+            <a:spAutoFit/>
+          </a:bodyPr>
+          <a:lstStyle/>
+          <a:p>
+            <a:pPr algn="ctr"/>
+            <a:r>
+              <a:rPr sz="650" b="0" lang="en-GB">
+                <a:solidFill>
+                  <a:srgbClr val="6B6B6B"/>
+                </a:solidFill>
+                <a:latin typeface="Calibri"/>
+              </a:rPr>
+              <a:t>Combined</a:t>
+            </a:r>
+          </a:p>
+        </p:txBody>
+      </p:sp>
+      <p:sp>
+        <p:nvSpPr>
+          <p:cNvPr id="9029" name="Rectangle 9028"/>
+          <p:cNvSpPr/>
+          <p:nvPr/>
+        </p:nvSpPr>
+        <p:spPr>
+          <a:xfrm>
+            <a:off x="365760" y="2743200"/>
+            <a:ext cx="36576" cy="146304"/>
+          </a:xfrm>
+          <a:prstGeom prst="rect">
+            <a:avLst/>
+          </a:prstGeom>
+          <a:solidFill>
+            <a:srgbClr val="0057B8"/>
+          </a:solidFill>
+          <a:ln>
+            <a:noFill/>
+          </a:ln>
+          <a:effectLst/>
+        </p:spPr>
+        <p:style>
+          <a:lnRef idx="1">
+            <a:schemeClr val="accent1"/>
+          </a:lnRef>
+          <a:fillRef idx="3">
+            <a:schemeClr val="accent1"/>
+          </a:fillRef>
+          <a:effectRef idx="2">
+            <a:schemeClr val="accent1"/>
+          </a:effectRef>
+          <a:fontRef idx="minor">
+            <a:schemeClr val="lt1"/>
+          </a:fontRef>
+        </p:style>
+        <p:txBody>
+          <a:bodyPr rtlCol="0" anchor="ctr"/>
+          <a:lstStyle/>
+          <a:p>
+            <a:pPr algn="ctr"/>
+          </a:p>
+        </p:txBody>
+      </p:sp>
+      <p:sp>
+        <p:nvSpPr>
+          <p:cNvPr id="9030" name="TextBox 9029"/>
+          <p:cNvSpPr txBox="1"/>
+          <p:nvPr/>
+        </p:nvSpPr>
+        <p:spPr>
+          <a:xfrm>
+            <a:off x="438912" y="2715768"/>
+            <a:ext cx="2377440" cy="201168"/>
+          </a:xfrm>
+          <a:prstGeom prst="rect">
+            <a:avLst/>
+          </a:prstGeom>
+          <a:noFill/>
+          <a:effectLst/>
+        </p:spPr>
+        <p:txBody>
+          <a:bodyPr wrap="none" anchor="t" lIns="27432" rIns="27432" tIns="13716" bIns="13716">
+            <a:spAutoFit/>
+          </a:bodyPr>
+          <a:lstStyle/>
+          <a:p>
+            <a:pPr algn="l"/>
+            <a:r>
+              <a:rPr sz="900" b="1" lang="en-GB">
+                <a:solidFill>
+                  <a:srgbClr val="1A1A1A"/>
+                </a:solidFill>
+                <a:latin typeface="Calibri"/>
+              </a:rPr>
+              <a:t>SCANNING AWARENESS ZONE  (180°, ≈5.5 m at court scale)</a:t>
+            </a:r>
+          </a:p>
+        </p:txBody>
+      </p:sp>
+      <p:sp>
+        <p:nvSpPr>
+          <p:cNvPr id="9031" name="TextBox 9030"/>
+          <p:cNvSpPr txBox="1"/>
+          <p:nvPr/>
+        </p:nvSpPr>
+        <p:spPr>
+          <a:xfrm>
+            <a:off x="4617720" y="2761488"/>
+            <a:ext cx="7223760" cy="914400"/>
+          </a:xfrm>
+          <a:prstGeom prst="rect">
+            <a:avLst/>
+          </a:prstGeom>
+          <a:noFill/>
+          <a:effectLst/>
+        </p:spPr>
+        <p:txBody>
           <a:bodyPr wrap="square" anchor="t" lIns="27432" rIns="27432" tIns="13716" bIns="13716">
             <a:spAutoFit/>
           </a:bodyPr>
@@ -26856,6 +27614,138 @@
           <a:p>
             <a:pPr algn="l"/>
             <a:r>
+              <a:rPr sz="850" b="1" lang="en-GB">
+                <a:solidFill>
+                  <a:srgbClr val="1A1A1A"/>
+                </a:solidFill>
+                <a:latin typeface="Calibri"/>
+              </a:rPr>
+              <a:t>SCANNING AWARENESS  ·  VISION CONE  ·  BODY SHAPE</a:t>
+            </a:r>
+          </a:p>
+          <a:p>
+            <a:pPr algn="l"/>
+            <a:r>
+              <a:rPr sz="800" b="0" lang="en-GB">
+                <a:solidFill>
+                  <a:srgbClr val="6B6B6B"/>
+                </a:solidFill>
+                <a:latin typeface="Calibri"/>
+              </a:rPr>
+              <a:t>Scan zone (180°, dashed, very light) = the full area a player actively sweeps before receiving — peripheral awareness, not just facing direction.</a:t>
+            </a:r>
+          </a:p>
+          <a:p>
+            <a:pPr algn="l"/>
+            <a:r>
+              <a:rPr sz="300" b="0" lang="en-GB">
+                <a:solidFill>
+                  <a:srgbClr val="1A1A1A"/>
+                </a:solidFill>
+                <a:latin typeface="Calibri"/>
+              </a:rPr>
+              <a:t/>
+            </a:r>
+          </a:p>
+          <a:p>
+            <a:pPr algn="l"/>
+            <a:r>
+              <a:rPr sz="800" b="0" lang="en-GB">
+                <a:solidFill>
+                  <a:srgbClr val="6B6B6B"/>
+                </a:solidFill>
+                <a:latin typeface="Calibri"/>
+              </a:rPr>
+              <a:t>Vision cone (70°, solid) = immediate focus and field of view. Scan zone + vision cone together show the difference between what a player checks and what they commit to.</a:t>
+            </a:r>
+          </a:p>
+          <a:p>
+            <a:pPr algn="l"/>
+            <a:r>
+              <a:rPr sz="300" b="0" lang="en-GB">
+                <a:solidFill>
+                  <a:srgbClr val="1A1A1A"/>
+                </a:solidFill>
+                <a:latin typeface="Calibri"/>
+              </a:rPr>
+              <a:t/>
+            </a:r>
+          </a:p>
+          <a:p>
+            <a:pPr algn="l"/>
+            <a:r>
+              <a:rPr sz="800" b="0" lang="en-GB">
+                <a:solidFill>
+                  <a:srgbClr val="1A1A1A"/>
+                </a:solidFill>
+                <a:latin typeface="Calibri"/>
+              </a:rPr>
+              <a:t>COMBINED example (left): all three layers in one group. Rotate the whole group to orient the player. Use standalone or combined — each is a separate object.</a:t>
+            </a:r>
+          </a:p>
+        </p:txBody>
+      </p:sp>
+      <p:cxnSp>
+        <p:nvCxnSpPr>
+          <p:cNvPr id="9032" name="Connector 9031"/>
+          <p:cNvCxnSpPr/>
+          <p:nvPr/>
+        </p:nvCxnSpPr>
+        <p:spPr>
+          <a:xfrm>
+            <a:off x="137160" y="3794760"/>
+            <a:ext cx="11917375" cy="0"/>
+          </a:xfrm>
+          <a:prstGeom prst="line">
+            <a:avLst/>
+          </a:prstGeom>
+          <a:ln w="6350">
+            <a:solidFill>
+              <a:srgbClr val="D9D9D9"/>
+            </a:solidFill>
+          </a:ln>
+          <a:effectLst/>
+        </p:spPr>
+        <p:style>
+          <a:lnRef idx="2">
+            <a:schemeClr val="accent1"/>
+          </a:lnRef>
+          <a:fillRef idx="0">
+            <a:schemeClr val="accent1"/>
+          </a:fillRef>
+          <a:effectRef idx="1">
+            <a:schemeClr val="accent1"/>
+          </a:effectRef>
+          <a:fontRef idx="minor">
+            <a:schemeClr val="tx1"/>
+          </a:fontRef>
+        </p:style>
+      </p:cxnSp>
+      <p:sp>
+        <p:nvSpPr>
+          <p:cNvPr id="9033" name="TextBox 9032"/>
+          <p:cNvSpPr txBox="1"/>
+          <p:nvPr/>
+        </p:nvSpPr>
+        <p:spPr>
+          <a:xfrm>
+            <a:off x="365760" y="3849624"/>
+            <a:ext cx="2194560" cy="182880"/>
+          </a:xfrm>
+          <a:prstGeom prst="rect">
+            <a:avLst/>
+          </a:prstGeom>
+          <a:noFill/>
+          <a:effectLst/>
+        </p:spPr>
+        <p:txBody>
+          <a:bodyPr wrap="square" anchor="t" lIns="27432" rIns="27432" tIns="13716" bIns="13716">
+            <a:spAutoFit/>
+          </a:bodyPr>
+          <a:lstStyle/>
+          <a:p>
+            <a:pPr algn="l"/>
+            <a:r>
               <a:rPr sz="800" b="1" lang="en-GB">
                 <a:solidFill>
                   <a:srgbClr val="0057B8"/>
@@ -26878,13 +27768,13 @@
       </p:sp>
       <p:sp>
         <p:nvSpPr>
-          <p:cNvPr id="9017" name="Chord 9016"/>
+          <p:cNvPr id="9034" name="Chord 9033"/>
           <p:cNvSpPr/>
           <p:nvPr/>
         </p:nvSpPr>
         <p:spPr>
           <a:xfrm>
-            <a:off x="411480" y="2944368"/>
+            <a:off x="411480" y="4069080"/>
             <a:ext cx="128016" cy="128016"/>
           </a:xfrm>
           <a:prstGeom prst="chord">
@@ -26934,13 +27824,13 @@
       </p:sp>
       <p:sp>
         <p:nvSpPr>
-          <p:cNvPr id="9018" name="Chord 9017"/>
+          <p:cNvPr id="9035" name="Chord 9034"/>
           <p:cNvSpPr/>
           <p:nvPr/>
         </p:nvSpPr>
         <p:spPr>
           <a:xfrm>
-            <a:off x="758952" y="2944368"/>
+            <a:off x="758952" y="4069080"/>
             <a:ext cx="128016" cy="128016"/>
           </a:xfrm>
           <a:prstGeom prst="chord">
@@ -26990,13 +27880,13 @@
       </p:sp>
       <p:sp>
         <p:nvSpPr>
-          <p:cNvPr id="9019" name="Chord 9018"/>
+          <p:cNvPr id="9036" name="Chord 9035"/>
           <p:cNvSpPr/>
           <p:nvPr/>
         </p:nvSpPr>
         <p:spPr>
           <a:xfrm>
-            <a:off x="1106424" y="2944368"/>
+            <a:off x="1106424" y="4069080"/>
             <a:ext cx="128016" cy="128016"/>
           </a:xfrm>
           <a:prstGeom prst="chord">
@@ -27046,13 +27936,13 @@
       </p:sp>
       <p:sp>
         <p:nvSpPr>
-          <p:cNvPr id="9020" name="Chord 9019"/>
+          <p:cNvPr id="9037" name="Chord 9036"/>
           <p:cNvSpPr/>
           <p:nvPr/>
         </p:nvSpPr>
         <p:spPr>
           <a:xfrm>
-            <a:off x="1453896" y="2944368"/>
+            <a:off x="1453896" y="4069080"/>
             <a:ext cx="128016" cy="128016"/>
           </a:xfrm>
           <a:prstGeom prst="chord">
@@ -27102,13 +27992,13 @@
       </p:sp>
       <p:sp>
         <p:nvSpPr>
-          <p:cNvPr id="9021" name="Chord 9020"/>
+          <p:cNvPr id="9038" name="Chord 9037"/>
           <p:cNvSpPr/>
           <p:nvPr/>
         </p:nvSpPr>
         <p:spPr>
           <a:xfrm>
-            <a:off x="1801368" y="2944368"/>
+            <a:off x="1801368" y="4069080"/>
             <a:ext cx="128016" cy="128016"/>
           </a:xfrm>
           <a:prstGeom prst="chord">
@@ -27158,13 +28048,13 @@
       </p:sp>
       <p:sp>
         <p:nvSpPr>
-          <p:cNvPr id="9022" name="TextBox 9021"/>
+          <p:cNvPr id="9039" name="TextBox 9038"/>
           <p:cNvSpPr txBox="1"/>
           <p:nvPr/>
         </p:nvSpPr>
         <p:spPr>
           <a:xfrm>
-            <a:off x="2514600" y="2724912"/>
+            <a:off x="2514600" y="3849624"/>
             <a:ext cx="2743200" cy="182880"/>
           </a:xfrm>
           <a:prstGeom prst="rect">
@@ -27203,13 +28093,13 @@
       </p:sp>
       <p:sp>
         <p:nvSpPr>
-          <p:cNvPr id="9023" name="Chord 9022"/>
+          <p:cNvPr id="9040" name="Chord 9039"/>
           <p:cNvSpPr/>
           <p:nvPr/>
         </p:nvSpPr>
         <p:spPr>
           <a:xfrm>
-            <a:off x="2560320" y="2944368"/>
+            <a:off x="2560320" y="4069080"/>
             <a:ext cx="128016" cy="128016"/>
           </a:xfrm>
           <a:prstGeom prst="chord">
@@ -27259,13 +28149,13 @@
       </p:sp>
       <p:sp>
         <p:nvSpPr>
-          <p:cNvPr id="9024" name="Chord 9023"/>
+          <p:cNvPr id="9041" name="Chord 9040"/>
           <p:cNvSpPr/>
           <p:nvPr/>
         </p:nvSpPr>
         <p:spPr>
           <a:xfrm>
-            <a:off x="2907792" y="2944368"/>
+            <a:off x="2907792" y="4069080"/>
             <a:ext cx="128016" cy="128016"/>
           </a:xfrm>
           <a:prstGeom prst="chord">
@@ -27315,13 +28205,13 @@
       </p:sp>
       <p:sp>
         <p:nvSpPr>
-          <p:cNvPr id="9025" name="Chord 9024"/>
+          <p:cNvPr id="9042" name="Chord 9041"/>
           <p:cNvSpPr/>
           <p:nvPr/>
         </p:nvSpPr>
         <p:spPr>
           <a:xfrm>
-            <a:off x="3255264" y="2944368"/>
+            <a:off x="3255264" y="4069080"/>
             <a:ext cx="128016" cy="128016"/>
           </a:xfrm>
           <a:prstGeom prst="chord">
@@ -27371,13 +28261,13 @@
       </p:sp>
       <p:sp>
         <p:nvSpPr>
-          <p:cNvPr id="9026" name="Chord 9025"/>
+          <p:cNvPr id="9043" name="Chord 9042"/>
           <p:cNvSpPr/>
           <p:nvPr/>
         </p:nvSpPr>
         <p:spPr>
           <a:xfrm>
-            <a:off x="3602736" y="2944368"/>
+            <a:off x="3602736" y="4069080"/>
             <a:ext cx="128016" cy="128016"/>
           </a:xfrm>
           <a:prstGeom prst="chord">
@@ -27427,13 +28317,13 @@
       </p:sp>
       <p:sp>
         <p:nvSpPr>
-          <p:cNvPr id="9027" name="Chord 9026"/>
+          <p:cNvPr id="9044" name="Chord 9043"/>
           <p:cNvSpPr/>
           <p:nvPr/>
         </p:nvSpPr>
         <p:spPr>
           <a:xfrm>
-            <a:off x="3950208" y="2944368"/>
+            <a:off x="3950208" y="4069080"/>
             <a:ext cx="128016" cy="128016"/>
           </a:xfrm>
           <a:prstGeom prst="chord">
@@ -27483,13 +28373,13 @@
       </p:sp>
       <p:sp>
         <p:nvSpPr>
-          <p:cNvPr id="9028" name="TextBox 9027"/>
+          <p:cNvPr id="9045" name="TextBox 9044"/>
           <p:cNvSpPr txBox="1"/>
           <p:nvPr/>
         </p:nvSpPr>
         <p:spPr>
           <a:xfrm>
-            <a:off x="5029200" y="2724912"/>
+            <a:off x="5029200" y="3849624"/>
             <a:ext cx="6858000" cy="502920"/>
           </a:xfrm>
           <a:prstGeom prst="rect">
@@ -27524,20 +28414,20 @@
                 </a:solidFill>
                 <a:latin typeface="Calibri"/>
               </a:rPr>
-              <a:t>Markers are at true court scale — copy straight onto a diagram. Team pucks carry body shape too: rotate any puck to angle the shoulders. To recolour Team B: select all 5 → Format Shape → Fill.</a:t>
+              <a:t>Markers are at true court scale. Team pucks carry body shape: rotate any puck to angle the shoulders. To recolour Team B: select all 5 → Format Shape → Fill.</a:t>
             </a:r>
           </a:p>
         </p:txBody>
       </p:sp>
       <p:cxnSp>
         <p:nvCxnSpPr>
-          <p:cNvPr id="9029" name="Connector 9028"/>
+          <p:cNvPr id="9046" name="Connector 9045"/>
           <p:cNvCxnSpPr/>
           <p:nvPr/>
         </p:nvCxnSpPr>
         <p:spPr>
           <a:xfrm>
-            <a:off x="137160" y="3273552"/>
+            <a:off x="137160" y="4434840"/>
             <a:ext cx="11917375" cy="0"/>
           </a:xfrm>
           <a:prstGeom prst="line">
@@ -27567,13 +28457,13 @@
       </p:cxnSp>
       <p:sp>
         <p:nvSpPr>
-          <p:cNvPr id="9030" name="Rectangle 9029"/>
+          <p:cNvPr id="9047" name="Rectangle 9046"/>
           <p:cNvSpPr/>
           <p:nvPr/>
         </p:nvSpPr>
         <p:spPr>
           <a:xfrm>
-            <a:off x="365760" y="3364992"/>
+            <a:off x="365760" y="4526280"/>
             <a:ext cx="36576" cy="146304"/>
           </a:xfrm>
           <a:prstGeom prst="rect">
@@ -27611,13 +28501,13 @@
       </p:sp>
       <p:sp>
         <p:nvSpPr>
-          <p:cNvPr id="9031" name="TextBox 9030"/>
+          <p:cNvPr id="9048" name="TextBox 9047"/>
           <p:cNvSpPr txBox="1"/>
           <p:nvPr/>
         </p:nvSpPr>
         <p:spPr>
           <a:xfrm>
-            <a:off x="438912" y="3337560"/>
+            <a:off x="438912" y="4498848"/>
             <a:ext cx="2377440" cy="201168"/>
           </a:xfrm>
           <a:prstGeom prst="rect">
@@ -27647,28 +28537,28 @@
       </p:sp>
       <p:grpSp>
         <p:nvGrpSpPr>
-          <p:cNvPr id="9008" name="Library full court"/>
+          <p:cNvPr id="9012" name="Library full court"/>
           <p:cNvGrpSpPr/>
           <p:nvPr/>
         </p:nvGrpSpPr>
         <p:grpSpPr>
           <a:xfrm>
-            <a:off x="438912" y="3630168"/>
-            <a:ext cx="4151376" cy="2011680"/>
-            <a:chOff x="438912" y="3630168"/>
-            <a:chExt cx="4151376" cy="2011680"/>
+            <a:off x="438912" y="4754880"/>
+            <a:ext cx="3602736" cy="1737360"/>
+            <a:chOff x="438912" y="4754880"/>
+            <a:chExt cx="3602736" cy="1737360"/>
           </a:xfrm>
         </p:grpSpPr>
         <p:sp>
           <p:nvSpPr>
-            <p:cNvPr id="9032" name="Rectangle 9031"/>
+            <p:cNvPr id="9049" name="Rectangle 9048"/>
             <p:cNvSpPr/>
             <p:nvPr/>
           </p:nvSpPr>
           <p:spPr>
             <a:xfrm>
-              <a:off x="502920" y="3630168"/>
-              <a:ext cx="4023360" cy="2011680"/>
+              <a:off x="502920" y="4754880"/>
+              <a:ext cx="3474720" cy="1737360"/>
             </a:xfrm>
             <a:prstGeom prst="rect">
               <a:avLst/>
@@ -27705,14 +28595,14 @@
         </p:sp>
         <p:cxnSp>
           <p:nvCxnSpPr>
-            <p:cNvPr id="9033" name="Connector 9032"/>
+            <p:cNvPr id="9050" name="Connector 9049"/>
             <p:cNvCxnSpPr/>
             <p:nvPr/>
           </p:nvCxnSpPr>
           <p:spPr>
             <a:xfrm>
-              <a:off x="2514600" y="3630168"/>
-              <a:ext cx="0" cy="2011680"/>
+              <a:off x="2240280" y="4754880"/>
+              <a:ext cx="0" cy="1737360"/>
             </a:xfrm>
             <a:prstGeom prst="line">
               <a:avLst/>
@@ -27741,771 +28631,17 @@
         </p:cxnSp>
         <p:sp>
           <p:nvSpPr>
-            <p:cNvPr id="9034" name="Oval 9033"/>
+            <p:cNvPr id="9051" name="Oval 9050"/>
             <p:cNvSpPr/>
             <p:nvPr/>
           </p:nvSpPr>
           <p:spPr>
             <a:xfrm>
-              <a:off x="2212848" y="4334256"/>
-              <a:ext cx="603504" cy="603504"/>
+              <a:off x="1979676" y="5362956"/>
+              <a:ext cx="521208" cy="521208"/>
             </a:xfrm>
             <a:prstGeom prst="ellipse">
               <a:avLst/>
-            </a:prstGeom>
-            <a:noFill/>
-            <a:ln w="9525">
-              <a:solidFill>
-                <a:srgbClr val="A9B1BB"/>
-              </a:solidFill>
-            </a:ln>
-            <a:effectLst/>
-          </p:spPr>
-          <p:style>
-            <a:lnRef idx="1">
-              <a:schemeClr val="accent1"/>
-            </a:lnRef>
-            <a:fillRef idx="3">
-              <a:schemeClr val="accent1"/>
-            </a:fillRef>
-            <a:effectRef idx="2">
-              <a:schemeClr val="accent1"/>
-            </a:effectRef>
-            <a:fontRef idx="minor">
-              <a:schemeClr val="lt1"/>
-            </a:fontRef>
-          </p:style>
-          <p:txBody>
-            <a:bodyPr rtlCol="0" anchor="ctr"/>
-            <a:lstStyle/>
-            <a:p>
-              <a:pPr algn="ctr"/>
-            </a:p>
-          </p:txBody>
-        </p:sp>
-        <p:sp>
-          <p:nvSpPr>
-            <p:cNvPr id="9035" name="Oval 9034"/>
-            <p:cNvSpPr/>
-            <p:nvPr/>
-          </p:nvSpPr>
-          <p:spPr>
-            <a:xfrm>
-              <a:off x="2498598" y="4620006"/>
-              <a:ext cx="32004" cy="32004"/>
-            </a:xfrm>
-            <a:prstGeom prst="ellipse">
-              <a:avLst/>
-            </a:prstGeom>
-            <a:solidFill>
-              <a:srgbClr val="A9B1BB"/>
-            </a:solidFill>
-            <a:ln>
-              <a:noFill/>
-            </a:ln>
-            <a:effectLst/>
-          </p:spPr>
-          <p:style>
-            <a:lnRef idx="1">
-              <a:schemeClr val="accent1"/>
-            </a:lnRef>
-            <a:fillRef idx="3">
-              <a:schemeClr val="accent1"/>
-            </a:fillRef>
-            <a:effectRef idx="2">
-              <a:schemeClr val="accent1"/>
-            </a:effectRef>
-            <a:fontRef idx="minor">
-              <a:schemeClr val="lt1"/>
-            </a:fontRef>
-          </p:style>
-          <p:txBody>
-            <a:bodyPr rtlCol="0" anchor="ctr"/>
-            <a:lstStyle/>
-            <a:p>
-              <a:pPr algn="ctr"/>
-            </a:p>
-          </p:txBody>
-        </p:sp>
-        <p:sp>
-          <p:nvSpPr>
-            <p:cNvPr id="9036" name="Arc 9035"/>
-            <p:cNvSpPr/>
-            <p:nvPr/>
-          </p:nvSpPr>
-          <p:spPr>
-            <a:xfrm>
-              <a:off x="-100584" y="3881628"/>
-              <a:ext cx="1207008" cy="1207008"/>
-            </a:xfrm>
-            <a:prstGeom prst="arc">
-              <a:avLst>
-                <a:gd name="adj1" fmla="val 16200000"/>
-                <a:gd name="adj2" fmla="val 21600000"/>
-              </a:avLst>
-            </a:prstGeom>
-            <a:noFill/>
-            <a:ln w="9525">
-              <a:solidFill>
-                <a:srgbClr val="A9B1BB"/>
-              </a:solidFill>
-            </a:ln>
-            <a:effectLst/>
-          </p:spPr>
-          <p:style>
-            <a:lnRef idx="1">
-              <a:schemeClr val="accent1"/>
-            </a:lnRef>
-            <a:fillRef idx="3">
-              <a:schemeClr val="accent1"/>
-            </a:fillRef>
-            <a:effectRef idx="2">
-              <a:schemeClr val="accent1"/>
-            </a:effectRef>
-            <a:fontRef idx="minor">
-              <a:schemeClr val="lt1"/>
-            </a:fontRef>
-          </p:style>
-          <p:txBody>
-            <a:bodyPr rtlCol="0" anchor="ctr"/>
-            <a:lstStyle/>
-            <a:p>
-              <a:pPr algn="ctr"/>
-            </a:p>
-          </p:txBody>
-        </p:sp>
-        <p:sp>
-          <p:nvSpPr>
-            <p:cNvPr id="9037" name="Arc 9036"/>
-            <p:cNvSpPr/>
-            <p:nvPr/>
-          </p:nvSpPr>
-          <p:spPr>
-            <a:xfrm>
-              <a:off x="-100584" y="4183380"/>
-              <a:ext cx="1207008" cy="1207008"/>
-            </a:xfrm>
-            <a:prstGeom prst="arc">
-              <a:avLst>
-                <a:gd name="adj1" fmla="val 0"/>
-                <a:gd name="adj2" fmla="val 5400000"/>
-              </a:avLst>
-            </a:prstGeom>
-            <a:noFill/>
-            <a:ln w="9525">
-              <a:solidFill>
-                <a:srgbClr val="A9B1BB"/>
-              </a:solidFill>
-            </a:ln>
-            <a:effectLst/>
-          </p:spPr>
-          <p:style>
-            <a:lnRef idx="1">
-              <a:schemeClr val="accent1"/>
-            </a:lnRef>
-            <a:fillRef idx="3">
-              <a:schemeClr val="accent1"/>
-            </a:fillRef>
-            <a:effectRef idx="2">
-              <a:schemeClr val="accent1"/>
-            </a:effectRef>
-            <a:fontRef idx="minor">
-              <a:schemeClr val="lt1"/>
-            </a:fontRef>
-          </p:style>
-          <p:txBody>
-            <a:bodyPr rtlCol="0" anchor="ctr"/>
-            <a:lstStyle/>
-            <a:p>
-              <a:pPr algn="ctr"/>
-            </a:p>
-          </p:txBody>
-        </p:sp>
-        <p:cxnSp>
-          <p:nvCxnSpPr>
-            <p:cNvPr id="9038" name="Connector 9037"/>
-            <p:cNvCxnSpPr/>
-            <p:nvPr/>
-          </p:nvCxnSpPr>
-          <p:spPr>
-            <a:xfrm>
-              <a:off x="1106424" y="4485132"/>
-              <a:ext cx="0" cy="301752"/>
-            </a:xfrm>
-            <a:prstGeom prst="line">
-              <a:avLst/>
-            </a:prstGeom>
-            <a:ln w="9525">
-              <a:solidFill>
-                <a:srgbClr val="A9B1BB"/>
-              </a:solidFill>
-            </a:ln>
-            <a:effectLst/>
-          </p:spPr>
-          <p:style>
-            <a:lnRef idx="2">
-              <a:schemeClr val="accent1"/>
-            </a:lnRef>
-            <a:fillRef idx="0">
-              <a:schemeClr val="accent1"/>
-            </a:fillRef>
-            <a:effectRef idx="1">
-              <a:schemeClr val="accent1"/>
-            </a:effectRef>
-            <a:fontRef idx="minor">
-              <a:schemeClr val="tx1"/>
-            </a:fontRef>
-          </p:style>
-        </p:cxnSp>
-        <p:sp>
-          <p:nvSpPr>
-            <p:cNvPr id="9039" name="Oval 9038"/>
-            <p:cNvSpPr/>
-            <p:nvPr/>
-          </p:nvSpPr>
-          <p:spPr>
-            <a:xfrm>
-              <a:off x="1090422" y="4620006"/>
-              <a:ext cx="32004" cy="32004"/>
-            </a:xfrm>
-            <a:prstGeom prst="ellipse">
-              <a:avLst/>
-            </a:prstGeom>
-            <a:solidFill>
-              <a:srgbClr val="A9B1BB"/>
-            </a:solidFill>
-            <a:ln>
-              <a:noFill/>
-            </a:ln>
-            <a:effectLst/>
-          </p:spPr>
-          <p:style>
-            <a:lnRef idx="1">
-              <a:schemeClr val="accent1"/>
-            </a:lnRef>
-            <a:fillRef idx="3">
-              <a:schemeClr val="accent1"/>
-            </a:fillRef>
-            <a:effectRef idx="2">
-              <a:schemeClr val="accent1"/>
-            </a:effectRef>
-            <a:fontRef idx="minor">
-              <a:schemeClr val="lt1"/>
-            </a:fontRef>
-          </p:style>
-          <p:txBody>
-            <a:bodyPr rtlCol="0" anchor="ctr"/>
-            <a:lstStyle/>
-            <a:p>
-              <a:pPr algn="ctr"/>
-            </a:p>
-          </p:txBody>
-        </p:sp>
-        <p:sp>
-          <p:nvSpPr>
-            <p:cNvPr id="9040" name="Oval 9039"/>
-            <p:cNvSpPr/>
-            <p:nvPr/>
-          </p:nvSpPr>
-          <p:spPr>
-            <a:xfrm>
-              <a:off x="1492758" y="4620006"/>
-              <a:ext cx="32004" cy="32004"/>
-            </a:xfrm>
-            <a:prstGeom prst="ellipse">
-              <a:avLst/>
-            </a:prstGeom>
-            <a:solidFill>
-              <a:srgbClr val="A9B1BB"/>
-            </a:solidFill>
-            <a:ln>
-              <a:noFill/>
-            </a:ln>
-            <a:effectLst/>
-          </p:spPr>
-          <p:style>
-            <a:lnRef idx="1">
-              <a:schemeClr val="accent1"/>
-            </a:lnRef>
-            <a:fillRef idx="3">
-              <a:schemeClr val="accent1"/>
-            </a:fillRef>
-            <a:effectRef idx="2">
-              <a:schemeClr val="accent1"/>
-            </a:effectRef>
-            <a:fontRef idx="minor">
-              <a:schemeClr val="lt1"/>
-            </a:fontRef>
-          </p:style>
-          <p:txBody>
-            <a:bodyPr rtlCol="0" anchor="ctr"/>
-            <a:lstStyle/>
-            <a:p>
-              <a:pPr algn="ctr"/>
-            </a:p>
-          </p:txBody>
-        </p:sp>
-        <p:sp>
-          <p:nvSpPr>
-            <p:cNvPr id="9041" name="Rectangle 9040"/>
-            <p:cNvSpPr/>
-            <p:nvPr/>
-          </p:nvSpPr>
-          <p:spPr>
-            <a:xfrm>
-              <a:off x="438912" y="4485132"/>
-              <a:ext cx="64008" cy="301752"/>
-            </a:xfrm>
-            <a:prstGeom prst="rect">
-              <a:avLst/>
-            </a:prstGeom>
-            <a:noFill/>
-            <a:ln w="12700">
-              <a:solidFill>
-                <a:srgbClr val="A9B1BB"/>
-              </a:solidFill>
-            </a:ln>
-            <a:effectLst/>
-          </p:spPr>
-          <p:style>
-            <a:lnRef idx="1">
-              <a:schemeClr val="accent1"/>
-            </a:lnRef>
-            <a:fillRef idx="3">
-              <a:schemeClr val="accent1"/>
-            </a:fillRef>
-            <a:effectRef idx="2">
-              <a:schemeClr val="accent1"/>
-            </a:effectRef>
-            <a:fontRef idx="minor">
-              <a:schemeClr val="lt1"/>
-            </a:fontRef>
-          </p:style>
-          <p:txBody>
-            <a:bodyPr rtlCol="0" anchor="ctr"/>
-            <a:lstStyle/>
-            <a:p>
-              <a:pPr algn="ctr"/>
-            </a:p>
-          </p:txBody>
-        </p:sp>
-        <p:sp>
-          <p:nvSpPr>
-            <p:cNvPr id="9042" name="Arc 9041"/>
-            <p:cNvSpPr/>
-            <p:nvPr/>
-          </p:nvSpPr>
-          <p:spPr>
-            <a:xfrm>
-              <a:off x="3922776" y="3881628"/>
-              <a:ext cx="1207008" cy="1207008"/>
-            </a:xfrm>
-            <a:prstGeom prst="arc">
-              <a:avLst>
-                <a:gd name="adj1" fmla="val 10800000"/>
-                <a:gd name="adj2" fmla="val 16200000"/>
-              </a:avLst>
-            </a:prstGeom>
-            <a:noFill/>
-            <a:ln w="9525">
-              <a:solidFill>
-                <a:srgbClr val="A9B1BB"/>
-              </a:solidFill>
-            </a:ln>
-            <a:effectLst/>
-          </p:spPr>
-          <p:style>
-            <a:lnRef idx="1">
-              <a:schemeClr val="accent1"/>
-            </a:lnRef>
-            <a:fillRef idx="3">
-              <a:schemeClr val="accent1"/>
-            </a:fillRef>
-            <a:effectRef idx="2">
-              <a:schemeClr val="accent1"/>
-            </a:effectRef>
-            <a:fontRef idx="minor">
-              <a:schemeClr val="lt1"/>
-            </a:fontRef>
-          </p:style>
-          <p:txBody>
-            <a:bodyPr rtlCol="0" anchor="ctr"/>
-            <a:lstStyle/>
-            <a:p>
-              <a:pPr algn="ctr"/>
-            </a:p>
-          </p:txBody>
-        </p:sp>
-        <p:sp>
-          <p:nvSpPr>
-            <p:cNvPr id="9043" name="Arc 9042"/>
-            <p:cNvSpPr/>
-            <p:nvPr/>
-          </p:nvSpPr>
-          <p:spPr>
-            <a:xfrm>
-              <a:off x="3922776" y="4183380"/>
-              <a:ext cx="1207008" cy="1207008"/>
-            </a:xfrm>
-            <a:prstGeom prst="arc">
-              <a:avLst>
-                <a:gd name="adj1" fmla="val 5400000"/>
-                <a:gd name="adj2" fmla="val 10800000"/>
-              </a:avLst>
-            </a:prstGeom>
-            <a:noFill/>
-            <a:ln w="9525">
-              <a:solidFill>
-                <a:srgbClr val="A9B1BB"/>
-              </a:solidFill>
-            </a:ln>
-            <a:effectLst/>
-          </p:spPr>
-          <p:style>
-            <a:lnRef idx="1">
-              <a:schemeClr val="accent1"/>
-            </a:lnRef>
-            <a:fillRef idx="3">
-              <a:schemeClr val="accent1"/>
-            </a:fillRef>
-            <a:effectRef idx="2">
-              <a:schemeClr val="accent1"/>
-            </a:effectRef>
-            <a:fontRef idx="minor">
-              <a:schemeClr val="lt1"/>
-            </a:fontRef>
-          </p:style>
-          <p:txBody>
-            <a:bodyPr rtlCol="0" anchor="ctr"/>
-            <a:lstStyle/>
-            <a:p>
-              <a:pPr algn="ctr"/>
-            </a:p>
-          </p:txBody>
-        </p:sp>
-        <p:cxnSp>
-          <p:nvCxnSpPr>
-            <p:cNvPr id="9044" name="Connector 9043"/>
-            <p:cNvCxnSpPr/>
-            <p:nvPr/>
-          </p:nvCxnSpPr>
-          <p:spPr>
-            <a:xfrm>
-              <a:off x="3922776" y="4485132"/>
-              <a:ext cx="0" cy="301752"/>
-            </a:xfrm>
-            <a:prstGeom prst="line">
-              <a:avLst/>
-            </a:prstGeom>
-            <a:ln w="9525">
-              <a:solidFill>
-                <a:srgbClr val="A9B1BB"/>
-              </a:solidFill>
-            </a:ln>
-            <a:effectLst/>
-          </p:spPr>
-          <p:style>
-            <a:lnRef idx="2">
-              <a:schemeClr val="accent1"/>
-            </a:lnRef>
-            <a:fillRef idx="0">
-              <a:schemeClr val="accent1"/>
-            </a:fillRef>
-            <a:effectRef idx="1">
-              <a:schemeClr val="accent1"/>
-            </a:effectRef>
-            <a:fontRef idx="minor">
-              <a:schemeClr val="tx1"/>
-            </a:fontRef>
-          </p:style>
-        </p:cxnSp>
-        <p:sp>
-          <p:nvSpPr>
-            <p:cNvPr id="9045" name="Oval 9044"/>
-            <p:cNvSpPr/>
-            <p:nvPr/>
-          </p:nvSpPr>
-          <p:spPr>
-            <a:xfrm>
-              <a:off x="3906774" y="4620006"/>
-              <a:ext cx="32004" cy="32004"/>
-            </a:xfrm>
-            <a:prstGeom prst="ellipse">
-              <a:avLst/>
-            </a:prstGeom>
-            <a:solidFill>
-              <a:srgbClr val="A9B1BB"/>
-            </a:solidFill>
-            <a:ln>
-              <a:noFill/>
-            </a:ln>
-            <a:effectLst/>
-          </p:spPr>
-          <p:style>
-            <a:lnRef idx="1">
-              <a:schemeClr val="accent1"/>
-            </a:lnRef>
-            <a:fillRef idx="3">
-              <a:schemeClr val="accent1"/>
-            </a:fillRef>
-            <a:effectRef idx="2">
-              <a:schemeClr val="accent1"/>
-            </a:effectRef>
-            <a:fontRef idx="minor">
-              <a:schemeClr val="lt1"/>
-            </a:fontRef>
-          </p:style>
-          <p:txBody>
-            <a:bodyPr rtlCol="0" anchor="ctr"/>
-            <a:lstStyle/>
-            <a:p>
-              <a:pPr algn="ctr"/>
-            </a:p>
-          </p:txBody>
-        </p:sp>
-        <p:sp>
-          <p:nvSpPr>
-            <p:cNvPr id="9046" name="Oval 9045"/>
-            <p:cNvSpPr/>
-            <p:nvPr/>
-          </p:nvSpPr>
-          <p:spPr>
-            <a:xfrm>
-              <a:off x="3504438" y="4620006"/>
-              <a:ext cx="32004" cy="32004"/>
-            </a:xfrm>
-            <a:prstGeom prst="ellipse">
-              <a:avLst/>
-            </a:prstGeom>
-            <a:solidFill>
-              <a:srgbClr val="A9B1BB"/>
-            </a:solidFill>
-            <a:ln>
-              <a:noFill/>
-            </a:ln>
-            <a:effectLst/>
-          </p:spPr>
-          <p:style>
-            <a:lnRef idx="1">
-              <a:schemeClr val="accent1"/>
-            </a:lnRef>
-            <a:fillRef idx="3">
-              <a:schemeClr val="accent1"/>
-            </a:fillRef>
-            <a:effectRef idx="2">
-              <a:schemeClr val="accent1"/>
-            </a:effectRef>
-            <a:fontRef idx="minor">
-              <a:schemeClr val="lt1"/>
-            </a:fontRef>
-          </p:style>
-          <p:txBody>
-            <a:bodyPr rtlCol="0" anchor="ctr"/>
-            <a:lstStyle/>
-            <a:p>
-              <a:pPr algn="ctr"/>
-            </a:p>
-          </p:txBody>
-        </p:sp>
-        <p:sp>
-          <p:nvSpPr>
-            <p:cNvPr id="9047" name="Rectangle 9046"/>
-            <p:cNvSpPr/>
-            <p:nvPr/>
-          </p:nvSpPr>
-          <p:spPr>
-            <a:xfrm>
-              <a:off x="4526280" y="4485132"/>
-              <a:ext cx="64008" cy="301752"/>
-            </a:xfrm>
-            <a:prstGeom prst="rect">
-              <a:avLst/>
-            </a:prstGeom>
-            <a:noFill/>
-            <a:ln w="12700">
-              <a:solidFill>
-                <a:srgbClr val="A9B1BB"/>
-              </a:solidFill>
-            </a:ln>
-            <a:effectLst/>
-          </p:spPr>
-          <p:style>
-            <a:lnRef idx="1">
-              <a:schemeClr val="accent1"/>
-            </a:lnRef>
-            <a:fillRef idx="3">
-              <a:schemeClr val="accent1"/>
-            </a:fillRef>
-            <a:effectRef idx="2">
-              <a:schemeClr val="accent1"/>
-            </a:effectRef>
-            <a:fontRef idx="minor">
-              <a:schemeClr val="lt1"/>
-            </a:fontRef>
-          </p:style>
-          <p:txBody>
-            <a:bodyPr rtlCol="0" anchor="ctr"/>
-            <a:lstStyle/>
-            <a:p>
-              <a:pPr algn="ctr"/>
-            </a:p>
-          </p:txBody>
-        </p:sp>
-      </p:grpSp>
-      <p:sp>
-        <p:nvSpPr>
-          <p:cNvPr id="9048" name="Rectangle 9047"/>
-          <p:cNvSpPr/>
-          <p:nvPr/>
-        </p:nvSpPr>
-        <p:spPr>
-          <a:xfrm>
-            <a:off x="5669280" y="3364992"/>
-            <a:ext cx="36576" cy="146304"/>
-          </a:xfrm>
-          <a:prstGeom prst="rect">
-            <a:avLst/>
-          </a:prstGeom>
-          <a:solidFill>
-            <a:srgbClr val="0057B8"/>
-          </a:solidFill>
-          <a:ln>
-            <a:noFill/>
-          </a:ln>
-          <a:effectLst/>
-        </p:spPr>
-        <p:style>
-          <a:lnRef idx="1">
-            <a:schemeClr val="accent1"/>
-          </a:lnRef>
-          <a:fillRef idx="3">
-            <a:schemeClr val="accent1"/>
-          </a:fillRef>
-          <a:effectRef idx="2">
-            <a:schemeClr val="accent1"/>
-          </a:effectRef>
-          <a:fontRef idx="minor">
-            <a:schemeClr val="lt1"/>
-          </a:fontRef>
-        </p:style>
-        <p:txBody>
-          <a:bodyPr rtlCol="0" anchor="ctr"/>
-          <a:lstStyle/>
-          <a:p>
-            <a:pPr algn="ctr"/>
-          </a:p>
-        </p:txBody>
-      </p:sp>
-      <p:sp>
-        <p:nvSpPr>
-          <p:cNvPr id="9049" name="TextBox 9048"/>
-          <p:cNvSpPr txBox="1"/>
-          <p:nvPr/>
-        </p:nvSpPr>
-        <p:spPr>
-          <a:xfrm>
-            <a:off x="5742432" y="3337560"/>
-            <a:ext cx="2377440" cy="201168"/>
-          </a:xfrm>
-          <a:prstGeom prst="rect">
-            <a:avLst/>
-          </a:prstGeom>
-          <a:noFill/>
-          <a:effectLst/>
-        </p:spPr>
-        <p:txBody>
-          <a:bodyPr wrap="none" anchor="t" lIns="27432" rIns="27432" tIns="13716" bIns="13716">
-            <a:spAutoFit/>
-          </a:bodyPr>
-          <a:lstStyle/>
-          <a:p>
-            <a:pPr algn="l"/>
-            <a:r>
-              <a:rPr sz="900" b="1" lang="en-GB">
-                <a:solidFill>
-                  <a:srgbClr val="1A1A1A"/>
-                </a:solidFill>
-                <a:latin typeface="Calibri"/>
-              </a:rPr>
-              <a:t>HALF COURT  (20m × 20m)</a:t>
-            </a:r>
-          </a:p>
-        </p:txBody>
-      </p:sp>
-      <p:grpSp>
-        <p:nvGrpSpPr>
-          <p:cNvPr id="9009" name="Library half court"/>
-          <p:cNvGrpSpPr/>
-          <p:nvPr/>
-        </p:nvGrpSpPr>
-        <p:grpSpPr>
-          <a:xfrm>
-            <a:off x="5742432" y="3630168"/>
-            <a:ext cx="2075688" cy="2011680"/>
-            <a:chOff x="5742432" y="3630168"/>
-            <a:chExt cx="2075688" cy="2011680"/>
-          </a:xfrm>
-        </p:grpSpPr>
-        <p:sp>
-          <p:nvSpPr>
-            <p:cNvPr id="9050" name="Rectangle 9049"/>
-            <p:cNvSpPr/>
-            <p:nvPr/>
-          </p:nvSpPr>
-          <p:spPr>
-            <a:xfrm>
-              <a:off x="5806440" y="3630168"/>
-              <a:ext cx="2011680" cy="2011680"/>
-            </a:xfrm>
-            <a:prstGeom prst="rect">
-              <a:avLst/>
-            </a:prstGeom>
-            <a:noFill/>
-            <a:ln w="12700">
-              <a:solidFill>
-                <a:srgbClr val="A9B1BB"/>
-              </a:solidFill>
-            </a:ln>
-            <a:effectLst/>
-          </p:spPr>
-          <p:style>
-            <a:lnRef idx="1">
-              <a:schemeClr val="accent1"/>
-            </a:lnRef>
-            <a:fillRef idx="3">
-              <a:schemeClr val="accent1"/>
-            </a:fillRef>
-            <a:effectRef idx="2">
-              <a:schemeClr val="accent1"/>
-            </a:effectRef>
-            <a:fontRef idx="minor">
-              <a:schemeClr val="lt1"/>
-            </a:fontRef>
-          </p:style>
-          <p:txBody>
-            <a:bodyPr rtlCol="0" anchor="ctr"/>
-            <a:lstStyle/>
-            <a:p>
-              <a:pPr algn="ctr"/>
-            </a:p>
-          </p:txBody>
-        </p:sp>
-        <p:sp>
-          <p:nvSpPr>
-            <p:cNvPr id="9051" name="Arc 9050"/>
-            <p:cNvSpPr/>
-            <p:nvPr/>
-          </p:nvSpPr>
-          <p:spPr>
-            <a:xfrm>
-              <a:off x="7516368" y="4334256"/>
-              <a:ext cx="603504" cy="603504"/>
-            </a:xfrm>
-            <a:prstGeom prst="arc">
-              <a:avLst>
-                <a:gd name="adj1" fmla="val 5400000"/>
-                <a:gd name="adj2" fmla="val 16200000"/>
-              </a:avLst>
             </a:prstGeom>
             <a:noFill/>
             <a:ln w="9525">
@@ -28545,7 +28681,7 @@
           </p:nvSpPr>
           <p:spPr>
             <a:xfrm>
-              <a:off x="7802118" y="4620006"/>
+              <a:off x="2224278" y="5607558"/>
               <a:ext cx="32004" cy="32004"/>
             </a:xfrm>
             <a:prstGeom prst="ellipse">
@@ -28589,8 +28725,8 @@
           </p:nvSpPr>
           <p:spPr>
             <a:xfrm>
-              <a:off x="5202936" y="3881628"/>
-              <a:ext cx="1207008" cy="1207008"/>
+              <a:off x="-18288" y="4972050"/>
+              <a:ext cx="1042416" cy="1042416"/>
             </a:xfrm>
             <a:prstGeom prst="arc">
               <a:avLst>
@@ -28636,8 +28772,8 @@
           </p:nvSpPr>
           <p:spPr>
             <a:xfrm>
-              <a:off x="5202936" y="4183380"/>
-              <a:ext cx="1207008" cy="1207008"/>
+              <a:off x="-18288" y="5232654"/>
+              <a:ext cx="1042416" cy="1042416"/>
             </a:xfrm>
             <a:prstGeom prst="arc">
               <a:avLst>
@@ -28683,8 +28819,8 @@
           </p:nvCxnSpPr>
           <p:spPr>
             <a:xfrm>
-              <a:off x="6409944" y="4485132"/>
-              <a:ext cx="0" cy="301752"/>
+              <a:off x="1024128" y="5493258"/>
+              <a:ext cx="0" cy="260604"/>
             </a:xfrm>
             <a:prstGeom prst="line">
               <a:avLst/>
@@ -28719,7 +28855,7 @@
           </p:nvSpPr>
           <p:spPr>
             <a:xfrm>
-              <a:off x="6393942" y="4620006"/>
+              <a:off x="1008126" y="5607558"/>
               <a:ext cx="32004" cy="32004"/>
             </a:xfrm>
             <a:prstGeom prst="ellipse">
@@ -28763,7 +28899,7 @@
           </p:nvSpPr>
           <p:spPr>
             <a:xfrm>
-              <a:off x="6796278" y="4620006"/>
+              <a:off x="1355598" y="5607558"/>
               <a:ext cx="32004" cy="32004"/>
             </a:xfrm>
             <a:prstGeom prst="ellipse">
@@ -28807,8 +28943,8 @@
           </p:nvSpPr>
           <p:spPr>
             <a:xfrm>
-              <a:off x="5742432" y="4485132"/>
-              <a:ext cx="64008" cy="301752"/>
+              <a:off x="438912" y="5493258"/>
+              <a:ext cx="64008" cy="260604"/>
             </a:xfrm>
             <a:prstGeom prst="rect">
               <a:avLst/>
@@ -28843,17 +28979,323 @@
             </a:p>
           </p:txBody>
         </p:sp>
+        <p:sp>
+          <p:nvSpPr>
+            <p:cNvPr id="9059" name="Arc 9058"/>
+            <p:cNvSpPr/>
+            <p:nvPr/>
+          </p:nvSpPr>
+          <p:spPr>
+            <a:xfrm>
+              <a:off x="3456432" y="4972050"/>
+              <a:ext cx="1042416" cy="1042416"/>
+            </a:xfrm>
+            <a:prstGeom prst="arc">
+              <a:avLst>
+                <a:gd name="adj1" fmla="val 10800000"/>
+                <a:gd name="adj2" fmla="val 16200000"/>
+              </a:avLst>
+            </a:prstGeom>
+            <a:noFill/>
+            <a:ln w="9525">
+              <a:solidFill>
+                <a:srgbClr val="A9B1BB"/>
+              </a:solidFill>
+            </a:ln>
+            <a:effectLst/>
+          </p:spPr>
+          <p:style>
+            <a:lnRef idx="1">
+              <a:schemeClr val="accent1"/>
+            </a:lnRef>
+            <a:fillRef idx="3">
+              <a:schemeClr val="accent1"/>
+            </a:fillRef>
+            <a:effectRef idx="2">
+              <a:schemeClr val="accent1"/>
+            </a:effectRef>
+            <a:fontRef idx="minor">
+              <a:schemeClr val="lt1"/>
+            </a:fontRef>
+          </p:style>
+          <p:txBody>
+            <a:bodyPr rtlCol="0" anchor="ctr"/>
+            <a:lstStyle/>
+            <a:p>
+              <a:pPr algn="ctr"/>
+            </a:p>
+          </p:txBody>
+        </p:sp>
+        <p:sp>
+          <p:nvSpPr>
+            <p:cNvPr id="9060" name="Arc 9059"/>
+            <p:cNvSpPr/>
+            <p:nvPr/>
+          </p:nvSpPr>
+          <p:spPr>
+            <a:xfrm>
+              <a:off x="3456432" y="5232654"/>
+              <a:ext cx="1042416" cy="1042416"/>
+            </a:xfrm>
+            <a:prstGeom prst="arc">
+              <a:avLst>
+                <a:gd name="adj1" fmla="val 5400000"/>
+                <a:gd name="adj2" fmla="val 10800000"/>
+              </a:avLst>
+            </a:prstGeom>
+            <a:noFill/>
+            <a:ln w="9525">
+              <a:solidFill>
+                <a:srgbClr val="A9B1BB"/>
+              </a:solidFill>
+            </a:ln>
+            <a:effectLst/>
+          </p:spPr>
+          <p:style>
+            <a:lnRef idx="1">
+              <a:schemeClr val="accent1"/>
+            </a:lnRef>
+            <a:fillRef idx="3">
+              <a:schemeClr val="accent1"/>
+            </a:fillRef>
+            <a:effectRef idx="2">
+              <a:schemeClr val="accent1"/>
+            </a:effectRef>
+            <a:fontRef idx="minor">
+              <a:schemeClr val="lt1"/>
+            </a:fontRef>
+          </p:style>
+          <p:txBody>
+            <a:bodyPr rtlCol="0" anchor="ctr"/>
+            <a:lstStyle/>
+            <a:p>
+              <a:pPr algn="ctr"/>
+            </a:p>
+          </p:txBody>
+        </p:sp>
+        <p:cxnSp>
+          <p:nvCxnSpPr>
+            <p:cNvPr id="9061" name="Connector 9060"/>
+            <p:cNvCxnSpPr/>
+            <p:nvPr/>
+          </p:nvCxnSpPr>
+          <p:spPr>
+            <a:xfrm>
+              <a:off x="3456432" y="5493258"/>
+              <a:ext cx="0" cy="260604"/>
+            </a:xfrm>
+            <a:prstGeom prst="line">
+              <a:avLst/>
+            </a:prstGeom>
+            <a:ln w="9525">
+              <a:solidFill>
+                <a:srgbClr val="A9B1BB"/>
+              </a:solidFill>
+            </a:ln>
+            <a:effectLst/>
+          </p:spPr>
+          <p:style>
+            <a:lnRef idx="2">
+              <a:schemeClr val="accent1"/>
+            </a:lnRef>
+            <a:fillRef idx="0">
+              <a:schemeClr val="accent1"/>
+            </a:fillRef>
+            <a:effectRef idx="1">
+              <a:schemeClr val="accent1"/>
+            </a:effectRef>
+            <a:fontRef idx="minor">
+              <a:schemeClr val="tx1"/>
+            </a:fontRef>
+          </p:style>
+        </p:cxnSp>
+        <p:sp>
+          <p:nvSpPr>
+            <p:cNvPr id="9062" name="Oval 9061"/>
+            <p:cNvSpPr/>
+            <p:nvPr/>
+          </p:nvSpPr>
+          <p:spPr>
+            <a:xfrm>
+              <a:off x="3440430" y="5607558"/>
+              <a:ext cx="32004" cy="32004"/>
+            </a:xfrm>
+            <a:prstGeom prst="ellipse">
+              <a:avLst/>
+            </a:prstGeom>
+            <a:solidFill>
+              <a:srgbClr val="A9B1BB"/>
+            </a:solidFill>
+            <a:ln>
+              <a:noFill/>
+            </a:ln>
+            <a:effectLst/>
+          </p:spPr>
+          <p:style>
+            <a:lnRef idx="1">
+              <a:schemeClr val="accent1"/>
+            </a:lnRef>
+            <a:fillRef idx="3">
+              <a:schemeClr val="accent1"/>
+            </a:fillRef>
+            <a:effectRef idx="2">
+              <a:schemeClr val="accent1"/>
+            </a:effectRef>
+            <a:fontRef idx="minor">
+              <a:schemeClr val="lt1"/>
+            </a:fontRef>
+          </p:style>
+          <p:txBody>
+            <a:bodyPr rtlCol="0" anchor="ctr"/>
+            <a:lstStyle/>
+            <a:p>
+              <a:pPr algn="ctr"/>
+            </a:p>
+          </p:txBody>
+        </p:sp>
+        <p:sp>
+          <p:nvSpPr>
+            <p:cNvPr id="9063" name="Oval 9062"/>
+            <p:cNvSpPr/>
+            <p:nvPr/>
+          </p:nvSpPr>
+          <p:spPr>
+            <a:xfrm>
+              <a:off x="3092958" y="5607558"/>
+              <a:ext cx="32004" cy="32004"/>
+            </a:xfrm>
+            <a:prstGeom prst="ellipse">
+              <a:avLst/>
+            </a:prstGeom>
+            <a:solidFill>
+              <a:srgbClr val="A9B1BB"/>
+            </a:solidFill>
+            <a:ln>
+              <a:noFill/>
+            </a:ln>
+            <a:effectLst/>
+          </p:spPr>
+          <p:style>
+            <a:lnRef idx="1">
+              <a:schemeClr val="accent1"/>
+            </a:lnRef>
+            <a:fillRef idx="3">
+              <a:schemeClr val="accent1"/>
+            </a:fillRef>
+            <a:effectRef idx="2">
+              <a:schemeClr val="accent1"/>
+            </a:effectRef>
+            <a:fontRef idx="minor">
+              <a:schemeClr val="lt1"/>
+            </a:fontRef>
+          </p:style>
+          <p:txBody>
+            <a:bodyPr rtlCol="0" anchor="ctr"/>
+            <a:lstStyle/>
+            <a:p>
+              <a:pPr algn="ctr"/>
+            </a:p>
+          </p:txBody>
+        </p:sp>
+        <p:sp>
+          <p:nvSpPr>
+            <p:cNvPr id="9064" name="Rectangle 9063"/>
+            <p:cNvSpPr/>
+            <p:nvPr/>
+          </p:nvSpPr>
+          <p:spPr>
+            <a:xfrm>
+              <a:off x="3977640" y="5493258"/>
+              <a:ext cx="64008" cy="260604"/>
+            </a:xfrm>
+            <a:prstGeom prst="rect">
+              <a:avLst/>
+            </a:prstGeom>
+            <a:noFill/>
+            <a:ln w="12700">
+              <a:solidFill>
+                <a:srgbClr val="A9B1BB"/>
+              </a:solidFill>
+            </a:ln>
+            <a:effectLst/>
+          </p:spPr>
+          <p:style>
+            <a:lnRef idx="1">
+              <a:schemeClr val="accent1"/>
+            </a:lnRef>
+            <a:fillRef idx="3">
+              <a:schemeClr val="accent1"/>
+            </a:fillRef>
+            <a:effectRef idx="2">
+              <a:schemeClr val="accent1"/>
+            </a:effectRef>
+            <a:fontRef idx="minor">
+              <a:schemeClr val="lt1"/>
+            </a:fontRef>
+          </p:style>
+          <p:txBody>
+            <a:bodyPr rtlCol="0" anchor="ctr"/>
+            <a:lstStyle/>
+            <a:p>
+              <a:pPr algn="ctr"/>
+            </a:p>
+          </p:txBody>
+        </p:sp>
       </p:grpSp>
       <p:sp>
         <p:nvSpPr>
-          <p:cNvPr id="9059" name="TextBox 9058"/>
+          <p:cNvPr id="9065" name="Rectangle 9064"/>
+          <p:cNvSpPr/>
+          <p:nvPr/>
+        </p:nvSpPr>
+        <p:spPr>
+          <a:xfrm>
+            <a:off x="5120640" y="4526280"/>
+            <a:ext cx="36576" cy="146304"/>
+          </a:xfrm>
+          <a:prstGeom prst="rect">
+            <a:avLst/>
+          </a:prstGeom>
+          <a:solidFill>
+            <a:srgbClr val="0057B8"/>
+          </a:solidFill>
+          <a:ln>
+            <a:noFill/>
+          </a:ln>
+          <a:effectLst/>
+        </p:spPr>
+        <p:style>
+          <a:lnRef idx="1">
+            <a:schemeClr val="accent1"/>
+          </a:lnRef>
+          <a:fillRef idx="3">
+            <a:schemeClr val="accent1"/>
+          </a:fillRef>
+          <a:effectRef idx="2">
+            <a:schemeClr val="accent1"/>
+          </a:effectRef>
+          <a:fontRef idx="minor">
+            <a:schemeClr val="lt1"/>
+          </a:fontRef>
+        </p:style>
+        <p:txBody>
+          <a:bodyPr rtlCol="0" anchor="ctr"/>
+          <a:lstStyle/>
+          <a:p>
+            <a:pPr algn="ctr"/>
+          </a:p>
+        </p:txBody>
+      </p:sp>
+      <p:sp>
+        <p:nvSpPr>
+          <p:cNvPr id="9066" name="TextBox 9065"/>
           <p:cNvSpPr txBox="1"/>
           <p:nvPr/>
         </p:nvSpPr>
         <p:spPr>
           <a:xfrm>
-            <a:off x="8823960" y="3630168"/>
-            <a:ext cx="3017520" cy="2926080"/>
+            <a:off x="5193792" y="4498848"/>
+            <a:ext cx="2377440" cy="201168"/>
           </a:xfrm>
           <a:prstGeom prst="rect">
             <a:avLst/>
@@ -28862,94 +29304,446 @@
           <a:effectLst/>
         </p:spPr>
         <p:txBody>
-          <a:bodyPr wrap="square" anchor="t" lIns="27432" rIns="27432" tIns="13716" bIns="13716">
+          <a:bodyPr wrap="none" anchor="t" lIns="27432" rIns="27432" tIns="13716" bIns="13716">
             <a:spAutoFit/>
           </a:bodyPr>
           <a:lstStyle/>
           <a:p>
             <a:pPr algn="l"/>
             <a:r>
-              <a:rPr sz="700" b="1" lang="en-GB">
-                <a:solidFill>
-                  <a:srgbClr val="6B6B6B"/>
+              <a:rPr sz="900" b="1" lang="en-GB">
+                <a:solidFill>
+                  <a:srgbClr val="1A1A1A"/>
                 </a:solidFill>
                 <a:latin typeface="Calibri"/>
               </a:rPr>
-              <a:t>USAGE</a:t>
-            </a:r>
-          </a:p>
-          <a:p>
-            <a:pPr algn="l"/>
-            <a:r>
-              <a:rPr sz="800" b="0" lang="en-GB">
-                <a:solidFill>
-                  <a:srgbClr val="1A1A1A"/>
-                </a:solidFill>
-                <a:latin typeface="Calibri"/>
-              </a:rPr>
-              <a:t>Courts are grouped — one click selects the whole court. Copy and paste onto any diagram, then resize to fit. Ungroup (Ctrl+Shift+G) to edit individual markings.</a:t>
-            </a:r>
-          </a:p>
-          <a:p>
-            <a:pPr algn="l"/>
-            <a:r>
-              <a:rPr sz="400" b="0" lang="en-GB">
-                <a:solidFill>
-                  <a:srgbClr val="1A1A1A"/>
-                </a:solidFill>
-                <a:latin typeface="Calibri"/>
-              </a:rPr>
-              <a:t/>
-            </a:r>
-          </a:p>
-          <a:p>
-            <a:pPr algn="l"/>
-            <a:r>
-              <a:rPr sz="800" b="0" lang="en-GB">
-                <a:solidFill>
-                  <a:srgbClr val="1A1A1A"/>
-                </a:solidFill>
-                <a:latin typeface="Calibri"/>
-              </a:rPr>
-              <a:t>To change the accent colour on a slide: select all blue shapes (click one, then Edit → Select All Same Fill Colour) and choose Format Shape → Fill.</a:t>
-            </a:r>
-          </a:p>
-          <a:p>
-            <a:pPr algn="l"/>
-            <a:r>
-              <a:rPr sz="400" b="0" lang="en-GB">
-                <a:solidFill>
-                  <a:srgbClr val="1A1A1A"/>
-                </a:solidFill>
-                <a:latin typeface="Calibri"/>
-              </a:rPr>
-              <a:t/>
-            </a:r>
-          </a:p>
-          <a:p>
-            <a:pPr algn="l"/>
-            <a:r>
-              <a:rPr sz="800" b="0" lang="en-GB">
-                <a:solidFill>
-                  <a:srgbClr val="1A1A1A"/>
-                </a:solidFill>
-                <a:latin typeface="Calibri"/>
-              </a:rPr>
-              <a:t>All shapes are unlocked. Numbers inside markers are editable text — double-click to change.</a:t>
-            </a:r>
-          </a:p>
-        </p:txBody>
-      </p:sp>
-      <p:sp>
-        <p:nvSpPr>
-          <p:cNvPr id="9060" name="TextBox 9059"/>
+              <a:t>HALF COURT  (20m × 20m)</a:t>
+            </a:r>
+          </a:p>
+        </p:txBody>
+      </p:sp>
+      <p:grpSp>
+        <p:nvGrpSpPr>
+          <p:cNvPr id="9013" name="Library half court"/>
+          <p:cNvGrpSpPr/>
+          <p:nvPr/>
+        </p:nvGrpSpPr>
+        <p:grpSpPr>
+          <a:xfrm>
+            <a:off x="5193792" y="4754880"/>
+            <a:ext cx="1801368" cy="1737360"/>
+            <a:chOff x="5193792" y="4754880"/>
+            <a:chExt cx="1801368" cy="1737360"/>
+          </a:xfrm>
+        </p:grpSpPr>
+        <p:sp>
+          <p:nvSpPr>
+            <p:cNvPr id="9067" name="Rectangle 9066"/>
+            <p:cNvSpPr/>
+            <p:nvPr/>
+          </p:nvSpPr>
+          <p:spPr>
+            <a:xfrm>
+              <a:off x="5257800" y="4754880"/>
+              <a:ext cx="1737360" cy="1737360"/>
+            </a:xfrm>
+            <a:prstGeom prst="rect">
+              <a:avLst/>
+            </a:prstGeom>
+            <a:noFill/>
+            <a:ln w="12700">
+              <a:solidFill>
+                <a:srgbClr val="A9B1BB"/>
+              </a:solidFill>
+            </a:ln>
+            <a:effectLst/>
+          </p:spPr>
+          <p:style>
+            <a:lnRef idx="1">
+              <a:schemeClr val="accent1"/>
+            </a:lnRef>
+            <a:fillRef idx="3">
+              <a:schemeClr val="accent1"/>
+            </a:fillRef>
+            <a:effectRef idx="2">
+              <a:schemeClr val="accent1"/>
+            </a:effectRef>
+            <a:fontRef idx="minor">
+              <a:schemeClr val="lt1"/>
+            </a:fontRef>
+          </p:style>
+          <p:txBody>
+            <a:bodyPr rtlCol="0" anchor="ctr"/>
+            <a:lstStyle/>
+            <a:p>
+              <a:pPr algn="ctr"/>
+            </a:p>
+          </p:txBody>
+        </p:sp>
+        <p:sp>
+          <p:nvSpPr>
+            <p:cNvPr id="9068" name="Arc 9067"/>
+            <p:cNvSpPr/>
+            <p:nvPr/>
+          </p:nvSpPr>
+          <p:spPr>
+            <a:xfrm>
+              <a:off x="6734556" y="5362956"/>
+              <a:ext cx="521208" cy="521208"/>
+            </a:xfrm>
+            <a:prstGeom prst="arc">
+              <a:avLst>
+                <a:gd name="adj1" fmla="val 5400000"/>
+                <a:gd name="adj2" fmla="val 16200000"/>
+              </a:avLst>
+            </a:prstGeom>
+            <a:noFill/>
+            <a:ln w="9525">
+              <a:solidFill>
+                <a:srgbClr val="A9B1BB"/>
+              </a:solidFill>
+            </a:ln>
+            <a:effectLst/>
+          </p:spPr>
+          <p:style>
+            <a:lnRef idx="1">
+              <a:schemeClr val="accent1"/>
+            </a:lnRef>
+            <a:fillRef idx="3">
+              <a:schemeClr val="accent1"/>
+            </a:fillRef>
+            <a:effectRef idx="2">
+              <a:schemeClr val="accent1"/>
+            </a:effectRef>
+            <a:fontRef idx="minor">
+              <a:schemeClr val="lt1"/>
+            </a:fontRef>
+          </p:style>
+          <p:txBody>
+            <a:bodyPr rtlCol="0" anchor="ctr"/>
+            <a:lstStyle/>
+            <a:p>
+              <a:pPr algn="ctr"/>
+            </a:p>
+          </p:txBody>
+        </p:sp>
+        <p:sp>
+          <p:nvSpPr>
+            <p:cNvPr id="9069" name="Oval 9068"/>
+            <p:cNvSpPr/>
+            <p:nvPr/>
+          </p:nvSpPr>
+          <p:spPr>
+            <a:xfrm>
+              <a:off x="6979158" y="5607558"/>
+              <a:ext cx="32004" cy="32004"/>
+            </a:xfrm>
+            <a:prstGeom prst="ellipse">
+              <a:avLst/>
+            </a:prstGeom>
+            <a:solidFill>
+              <a:srgbClr val="A9B1BB"/>
+            </a:solidFill>
+            <a:ln>
+              <a:noFill/>
+            </a:ln>
+            <a:effectLst/>
+          </p:spPr>
+          <p:style>
+            <a:lnRef idx="1">
+              <a:schemeClr val="accent1"/>
+            </a:lnRef>
+            <a:fillRef idx="3">
+              <a:schemeClr val="accent1"/>
+            </a:fillRef>
+            <a:effectRef idx="2">
+              <a:schemeClr val="accent1"/>
+            </a:effectRef>
+            <a:fontRef idx="minor">
+              <a:schemeClr val="lt1"/>
+            </a:fontRef>
+          </p:style>
+          <p:txBody>
+            <a:bodyPr rtlCol="0" anchor="ctr"/>
+            <a:lstStyle/>
+            <a:p>
+              <a:pPr algn="ctr"/>
+            </a:p>
+          </p:txBody>
+        </p:sp>
+        <p:sp>
+          <p:nvSpPr>
+            <p:cNvPr id="9070" name="Arc 9069"/>
+            <p:cNvSpPr/>
+            <p:nvPr/>
+          </p:nvSpPr>
+          <p:spPr>
+            <a:xfrm>
+              <a:off x="4736592" y="4972050"/>
+              <a:ext cx="1042416" cy="1042416"/>
+            </a:xfrm>
+            <a:prstGeom prst="arc">
+              <a:avLst>
+                <a:gd name="adj1" fmla="val 16200000"/>
+                <a:gd name="adj2" fmla="val 21600000"/>
+              </a:avLst>
+            </a:prstGeom>
+            <a:noFill/>
+            <a:ln w="9525">
+              <a:solidFill>
+                <a:srgbClr val="A9B1BB"/>
+              </a:solidFill>
+            </a:ln>
+            <a:effectLst/>
+          </p:spPr>
+          <p:style>
+            <a:lnRef idx="1">
+              <a:schemeClr val="accent1"/>
+            </a:lnRef>
+            <a:fillRef idx="3">
+              <a:schemeClr val="accent1"/>
+            </a:fillRef>
+            <a:effectRef idx="2">
+              <a:schemeClr val="accent1"/>
+            </a:effectRef>
+            <a:fontRef idx="minor">
+              <a:schemeClr val="lt1"/>
+            </a:fontRef>
+          </p:style>
+          <p:txBody>
+            <a:bodyPr rtlCol="0" anchor="ctr"/>
+            <a:lstStyle/>
+            <a:p>
+              <a:pPr algn="ctr"/>
+            </a:p>
+          </p:txBody>
+        </p:sp>
+        <p:sp>
+          <p:nvSpPr>
+            <p:cNvPr id="9071" name="Arc 9070"/>
+            <p:cNvSpPr/>
+            <p:nvPr/>
+          </p:nvSpPr>
+          <p:spPr>
+            <a:xfrm>
+              <a:off x="4736592" y="5232654"/>
+              <a:ext cx="1042416" cy="1042416"/>
+            </a:xfrm>
+            <a:prstGeom prst="arc">
+              <a:avLst>
+                <a:gd name="adj1" fmla="val 0"/>
+                <a:gd name="adj2" fmla="val 5400000"/>
+              </a:avLst>
+            </a:prstGeom>
+            <a:noFill/>
+            <a:ln w="9525">
+              <a:solidFill>
+                <a:srgbClr val="A9B1BB"/>
+              </a:solidFill>
+            </a:ln>
+            <a:effectLst/>
+          </p:spPr>
+          <p:style>
+            <a:lnRef idx="1">
+              <a:schemeClr val="accent1"/>
+            </a:lnRef>
+            <a:fillRef idx="3">
+              <a:schemeClr val="accent1"/>
+            </a:fillRef>
+            <a:effectRef idx="2">
+              <a:schemeClr val="accent1"/>
+            </a:effectRef>
+            <a:fontRef idx="minor">
+              <a:schemeClr val="lt1"/>
+            </a:fontRef>
+          </p:style>
+          <p:txBody>
+            <a:bodyPr rtlCol="0" anchor="ctr"/>
+            <a:lstStyle/>
+            <a:p>
+              <a:pPr algn="ctr"/>
+            </a:p>
+          </p:txBody>
+        </p:sp>
+        <p:cxnSp>
+          <p:nvCxnSpPr>
+            <p:cNvPr id="9072" name="Connector 9071"/>
+            <p:cNvCxnSpPr/>
+            <p:nvPr/>
+          </p:nvCxnSpPr>
+          <p:spPr>
+            <a:xfrm>
+              <a:off x="5779008" y="5493258"/>
+              <a:ext cx="0" cy="260604"/>
+            </a:xfrm>
+            <a:prstGeom prst="line">
+              <a:avLst/>
+            </a:prstGeom>
+            <a:ln w="9525">
+              <a:solidFill>
+                <a:srgbClr val="A9B1BB"/>
+              </a:solidFill>
+            </a:ln>
+            <a:effectLst/>
+          </p:spPr>
+          <p:style>
+            <a:lnRef idx="2">
+              <a:schemeClr val="accent1"/>
+            </a:lnRef>
+            <a:fillRef idx="0">
+              <a:schemeClr val="accent1"/>
+            </a:fillRef>
+            <a:effectRef idx="1">
+              <a:schemeClr val="accent1"/>
+            </a:effectRef>
+            <a:fontRef idx="minor">
+              <a:schemeClr val="tx1"/>
+            </a:fontRef>
+          </p:style>
+        </p:cxnSp>
+        <p:sp>
+          <p:nvSpPr>
+            <p:cNvPr id="9073" name="Oval 9072"/>
+            <p:cNvSpPr/>
+            <p:nvPr/>
+          </p:nvSpPr>
+          <p:spPr>
+            <a:xfrm>
+              <a:off x="5763006" y="5607558"/>
+              <a:ext cx="32004" cy="32004"/>
+            </a:xfrm>
+            <a:prstGeom prst="ellipse">
+              <a:avLst/>
+            </a:prstGeom>
+            <a:solidFill>
+              <a:srgbClr val="A9B1BB"/>
+            </a:solidFill>
+            <a:ln>
+              <a:noFill/>
+            </a:ln>
+            <a:effectLst/>
+          </p:spPr>
+          <p:style>
+            <a:lnRef idx="1">
+              <a:schemeClr val="accent1"/>
+            </a:lnRef>
+            <a:fillRef idx="3">
+              <a:schemeClr val="accent1"/>
+            </a:fillRef>
+            <a:effectRef idx="2">
+              <a:schemeClr val="accent1"/>
+            </a:effectRef>
+            <a:fontRef idx="minor">
+              <a:schemeClr val="lt1"/>
+            </a:fontRef>
+          </p:style>
+          <p:txBody>
+            <a:bodyPr rtlCol="0" anchor="ctr"/>
+            <a:lstStyle/>
+            <a:p>
+              <a:pPr algn="ctr"/>
+            </a:p>
+          </p:txBody>
+        </p:sp>
+        <p:sp>
+          <p:nvSpPr>
+            <p:cNvPr id="9074" name="Oval 9073"/>
+            <p:cNvSpPr/>
+            <p:nvPr/>
+          </p:nvSpPr>
+          <p:spPr>
+            <a:xfrm>
+              <a:off x="6110478" y="5607558"/>
+              <a:ext cx="32004" cy="32004"/>
+            </a:xfrm>
+            <a:prstGeom prst="ellipse">
+              <a:avLst/>
+            </a:prstGeom>
+            <a:solidFill>
+              <a:srgbClr val="A9B1BB"/>
+            </a:solidFill>
+            <a:ln>
+              <a:noFill/>
+            </a:ln>
+            <a:effectLst/>
+          </p:spPr>
+          <p:style>
+            <a:lnRef idx="1">
+              <a:schemeClr val="accent1"/>
+            </a:lnRef>
+            <a:fillRef idx="3">
+              <a:schemeClr val="accent1"/>
+            </a:fillRef>
+            <a:effectRef idx="2">
+              <a:schemeClr val="accent1"/>
+            </a:effectRef>
+            <a:fontRef idx="minor">
+              <a:schemeClr val="lt1"/>
+            </a:fontRef>
+          </p:style>
+          <p:txBody>
+            <a:bodyPr rtlCol="0" anchor="ctr"/>
+            <a:lstStyle/>
+            <a:p>
+              <a:pPr algn="ctr"/>
+            </a:p>
+          </p:txBody>
+        </p:sp>
+        <p:sp>
+          <p:nvSpPr>
+            <p:cNvPr id="9075" name="Rectangle 9074"/>
+            <p:cNvSpPr/>
+            <p:nvPr/>
+          </p:nvSpPr>
+          <p:spPr>
+            <a:xfrm>
+              <a:off x="5193792" y="5493258"/>
+              <a:ext cx="64008" cy="260604"/>
+            </a:xfrm>
+            <a:prstGeom prst="rect">
+              <a:avLst/>
+            </a:prstGeom>
+            <a:noFill/>
+            <a:ln w="12700">
+              <a:solidFill>
+                <a:srgbClr val="A9B1BB"/>
+              </a:solidFill>
+            </a:ln>
+            <a:effectLst/>
+          </p:spPr>
+          <p:style>
+            <a:lnRef idx="1">
+              <a:schemeClr val="accent1"/>
+            </a:lnRef>
+            <a:fillRef idx="3">
+              <a:schemeClr val="accent1"/>
+            </a:fillRef>
+            <a:effectRef idx="2">
+              <a:schemeClr val="accent1"/>
+            </a:effectRef>
+            <a:fontRef idx="minor">
+              <a:schemeClr val="lt1"/>
+            </a:fontRef>
+          </p:style>
+          <p:txBody>
+            <a:bodyPr rtlCol="0" anchor="ctr"/>
+            <a:lstStyle/>
+            <a:p>
+              <a:pPr algn="ctr"/>
+            </a:p>
+          </p:txBody>
+        </p:sp>
+      </p:grpSp>
+      <p:sp>
+        <p:nvSpPr>
+          <p:cNvPr id="9076" name="TextBox 9075"/>
           <p:cNvSpPr txBox="1"/>
           <p:nvPr/>
         </p:nvSpPr>
         <p:spPr>
           <a:xfrm>
-            <a:off x="137160" y="6725412"/>
-            <a:ext cx="11917375" cy="123444"/>
+            <a:off x="7406640" y="4754880"/>
+            <a:ext cx="4434840" cy="1828800"/>
           </a:xfrm>
           <a:prstGeom prst="rect">
             <a:avLst/>
@@ -28965,13 +29759,85 @@
           <a:p>
             <a:pPr algn="l"/>
             <a:r>
-              <a:rPr sz="650" b="0" lang="en-GB">
+              <a:rPr sz="700" b="1" lang="en-GB">
                 <a:solidFill>
                   <a:srgbClr val="6B6B6B"/>
                 </a:solidFill>
                 <a:latin typeface="Calibri"/>
               </a:rPr>
-              <a:t>COMPONENT LIBRARY  —  court-scale tactical symbols  ·  copy into any diagram zone  ·  pucks + vision cones: rotate to show body shape and field of view</a:t>
+              <a:t>USAGE</a:t>
+            </a:r>
+          </a:p>
+          <a:p>
+            <a:pPr algn="l"/>
+            <a:r>
+              <a:rPr sz="800" b="0" lang="en-GB">
+                <a:solidFill>
+                  <a:srgbClr val="1A1A1A"/>
+                </a:solidFill>
+                <a:latin typeface="Calibri"/>
+              </a:rPr>
+              <a:t>Courts are grouped — one click selects the whole court. Copy and paste into any diagram zone, resize to fit. Ungroup (Ctrl+Shift+G) to edit individual markings.</a:t>
+            </a:r>
+          </a:p>
+          <a:p>
+            <a:pPr algn="l"/>
+            <a:r>
+              <a:rPr sz="300" b="0" lang="en-GB">
+                <a:solidFill>
+                  <a:srgbClr val="1A1A1A"/>
+                </a:solidFill>
+                <a:latin typeface="Calibri"/>
+              </a:rPr>
+              <a:t/>
+            </a:r>
+          </a:p>
+          <a:p>
+            <a:pPr algn="l"/>
+            <a:r>
+              <a:rPr sz="800" b="0" lang="en-GB">
+                <a:solidFill>
+                  <a:srgbClr val="1A1A1A"/>
+                </a:solidFill>
+                <a:latin typeface="Calibri"/>
+              </a:rPr>
+              <a:t>All shapes are unlocked. Numbers inside markers are editable — double-click to change. To recolour: select shapes → Format Shape → Fill.</a:t>
+            </a:r>
+          </a:p>
+        </p:txBody>
+      </p:sp>
+      <p:sp>
+        <p:nvSpPr>
+          <p:cNvPr id="9077" name="TextBox 9076"/>
+          <p:cNvSpPr txBox="1"/>
+          <p:nvPr/>
+        </p:nvSpPr>
+        <p:spPr>
+          <a:xfrm>
+            <a:off x="137160" y="6725412"/>
+            <a:ext cx="11917375" cy="123444"/>
+          </a:xfrm>
+          <a:prstGeom prst="rect">
+            <a:avLst/>
+          </a:prstGeom>
+          <a:noFill/>
+          <a:effectLst/>
+        </p:spPr>
+        <p:txBody>
+          <a:bodyPr wrap="square" anchor="t" lIns="27432" rIns="27432" tIns="13716" bIns="13716">
+            <a:spAutoFit/>
+          </a:bodyPr>
+          <a:lstStyle/>
+          <a:p>
+            <a:pPr algn="l"/>
+            <a:r>
+              <a:rPr sz="650" b="0" lang="en-GB">
+                <a:solidFill>
+                  <a:srgbClr val="6B6B6B"/>
+                </a:solidFill>
+                <a:latin typeface="Calibri"/>
+              </a:rPr>
+              <a:t>COMPONENT LIBRARY  —  court-scale tactical symbols  ·  scan zone (180°, 5.5 m) · vision cone (70°, 3 m) · body puck · rotate to orient · combined group available</a:t>
             </a:r>
           </a:p>
         </p:txBody>

</xml_diff>

<commit_message>
Add standalone long vision cones (≈8 m) to component library
draw_long_cone(): a single 70° PIE wedge with no player attached —
apex sits at the player's position, default facing up. At ≈8 m court
scale it reads as a true sight line (vs the 3 m attached cone).
Drop under any existing marker, rotate to aim, drag a corner handle
to lengthen or shorten. Provided in Attacker / Defender / GK colours
in Row 2 of the Component Library.

https://claude.ai/code/session_018tafNEeKNQ7u7wPXfzwa7T
</commit_message>
<xml_diff>
--- a/futsal_session_template.pptx
+++ b/futsal_session_template.pptx
@@ -26795,9 +26795,386 @@
           </a:p>
         </p:txBody>
       </p:sp>
+      <p:sp>
+        <p:nvSpPr>
+          <p:cNvPr id="9015" name="TextBox 9014"/>
+          <p:cNvSpPr txBox="1"/>
+          <p:nvPr/>
+        </p:nvSpPr>
+        <p:spPr>
+          <a:xfrm>
+            <a:off x="5989320" y="2395728"/>
+            <a:ext cx="3017520" cy="274320"/>
+          </a:xfrm>
+          <a:prstGeom prst="rect">
+            <a:avLst/>
+          </a:prstGeom>
+          <a:noFill/>
+          <a:effectLst/>
+        </p:spPr>
+        <p:txBody>
+          <a:bodyPr wrap="square" anchor="t" lIns="27432" rIns="27432" tIns="13716" bIns="13716">
+            <a:spAutoFit/>
+          </a:bodyPr>
+          <a:lstStyle/>
+          <a:p>
+            <a:pPr algn="l"/>
+            <a:r>
+              <a:rPr sz="750" b="0" lang="en-GB">
+                <a:solidFill>
+                  <a:srgbClr val="6B6B6B"/>
+                </a:solidFill>
+                <a:latin typeface="Calibri"/>
+              </a:rPr>
+              <a:t>LONG CONES (right) are separate — no player attached. Drop one under any marker, rotate to aim, drag a corner handle to lengthen.</a:t>
+            </a:r>
+          </a:p>
+        </p:txBody>
+      </p:sp>
+      <p:sp>
+        <p:nvSpPr>
+          <p:cNvPr id="9016" name="Long cone Attacker"/>
+          <p:cNvSpPr/>
+          <p:nvPr/>
+        </p:nvSpPr>
+        <p:spPr>
+          <a:xfrm>
+            <a:off x="9050365" y="1844893"/>
+            <a:ext cx="1193109" cy="1193109"/>
+          </a:xfrm>
+          <a:prstGeom prst="pie">
+            <a:avLst>
+              <a:gd name="adj1" fmla="val 14100000"/>
+              <a:gd name="adj2" fmla="val 18300000"/>
+            </a:avLst>
+          </a:prstGeom>
+          <a:solidFill>
+            <a:srgbClr val="0057B8">
+              <a:alpha val="20000"/>
+            </a:srgbClr>
+          </a:solidFill>
+          <a:ln w="9525">
+            <a:solidFill>
+              <a:srgbClr val="0057B8"/>
+            </a:solidFill>
+          </a:ln>
+          <a:effectLst/>
+        </p:spPr>
+        <p:style>
+          <a:lnRef idx="1">
+            <a:schemeClr val="accent1"/>
+          </a:lnRef>
+          <a:fillRef idx="3">
+            <a:schemeClr val="accent1"/>
+          </a:fillRef>
+          <a:effectRef idx="2">
+            <a:schemeClr val="accent1"/>
+          </a:effectRef>
+          <a:fontRef idx="minor">
+            <a:schemeClr val="lt1"/>
+          </a:fontRef>
+        </p:style>
+        <p:txBody>
+          <a:bodyPr rtlCol="0" anchor="ctr"/>
+          <a:lstStyle/>
+          <a:p>
+            <a:pPr algn="ctr"/>
+          </a:p>
+        </p:txBody>
+      </p:sp>
+      <p:sp>
+        <p:nvSpPr>
+          <p:cNvPr id="9017" name="TextBox 9016"/>
+          <p:cNvSpPr txBox="1"/>
+          <p:nvPr/>
+        </p:nvSpPr>
+        <p:spPr>
+          <a:xfrm>
+            <a:off x="9372600" y="2478024"/>
+            <a:ext cx="548640" cy="164592"/>
+          </a:xfrm>
+          <a:prstGeom prst="rect">
+            <a:avLst/>
+          </a:prstGeom>
+          <a:noFill/>
+          <a:effectLst/>
+        </p:spPr>
+        <p:txBody>
+          <a:bodyPr wrap="none" anchor="t" lIns="27432" rIns="27432" tIns="13716" bIns="13716">
+            <a:spAutoFit/>
+          </a:bodyPr>
+          <a:lstStyle/>
+          <a:p>
+            <a:pPr algn="ctr"/>
+            <a:r>
+              <a:rPr sz="650" b="0" lang="en-GB">
+                <a:solidFill>
+                  <a:srgbClr val="6B6B6B"/>
+                </a:solidFill>
+                <a:latin typeface="Calibri"/>
+              </a:rPr>
+              <a:t>Attacker</a:t>
+            </a:r>
+          </a:p>
+        </p:txBody>
+      </p:sp>
+      <p:sp>
+        <p:nvSpPr>
+          <p:cNvPr id="9018" name="Long cone Defender"/>
+          <p:cNvSpPr/>
+          <p:nvPr/>
+        </p:nvSpPr>
+        <p:spPr>
+          <a:xfrm>
+            <a:off x="10010485" y="1844893"/>
+            <a:ext cx="1193109" cy="1193109"/>
+          </a:xfrm>
+          <a:prstGeom prst="pie">
+            <a:avLst>
+              <a:gd name="adj1" fmla="val 14100000"/>
+              <a:gd name="adj2" fmla="val 18300000"/>
+            </a:avLst>
+          </a:prstGeom>
+          <a:solidFill>
+            <a:srgbClr val="6B6B6B">
+              <a:alpha val="20000"/>
+            </a:srgbClr>
+          </a:solidFill>
+          <a:ln w="9525">
+            <a:solidFill>
+              <a:srgbClr val="6B6B6B"/>
+            </a:solidFill>
+          </a:ln>
+          <a:effectLst/>
+        </p:spPr>
+        <p:style>
+          <a:lnRef idx="1">
+            <a:schemeClr val="accent1"/>
+          </a:lnRef>
+          <a:fillRef idx="3">
+            <a:schemeClr val="accent1"/>
+          </a:fillRef>
+          <a:effectRef idx="2">
+            <a:schemeClr val="accent1"/>
+          </a:effectRef>
+          <a:fontRef idx="minor">
+            <a:schemeClr val="lt1"/>
+          </a:fontRef>
+        </p:style>
+        <p:txBody>
+          <a:bodyPr rtlCol="0" anchor="ctr"/>
+          <a:lstStyle/>
+          <a:p>
+            <a:pPr algn="ctr"/>
+          </a:p>
+        </p:txBody>
+      </p:sp>
+      <p:sp>
+        <p:nvSpPr>
+          <p:cNvPr id="9019" name="TextBox 9018"/>
+          <p:cNvSpPr txBox="1"/>
+          <p:nvPr/>
+        </p:nvSpPr>
+        <p:spPr>
+          <a:xfrm>
+            <a:off x="10332720" y="2478024"/>
+            <a:ext cx="548640" cy="164592"/>
+          </a:xfrm>
+          <a:prstGeom prst="rect">
+            <a:avLst/>
+          </a:prstGeom>
+          <a:noFill/>
+          <a:effectLst/>
+        </p:spPr>
+        <p:txBody>
+          <a:bodyPr wrap="none" anchor="t" lIns="27432" rIns="27432" tIns="13716" bIns="13716">
+            <a:spAutoFit/>
+          </a:bodyPr>
+          <a:lstStyle/>
+          <a:p>
+            <a:pPr algn="ctr"/>
+            <a:r>
+              <a:rPr sz="650" b="0" lang="en-GB">
+                <a:solidFill>
+                  <a:srgbClr val="6B6B6B"/>
+                </a:solidFill>
+                <a:latin typeface="Calibri"/>
+              </a:rPr>
+              <a:t>Defender</a:t>
+            </a:r>
+          </a:p>
+        </p:txBody>
+      </p:sp>
+      <p:sp>
+        <p:nvSpPr>
+          <p:cNvPr id="9020" name="Long cone GK"/>
+          <p:cNvSpPr/>
+          <p:nvPr/>
+        </p:nvSpPr>
+        <p:spPr>
+          <a:xfrm>
+            <a:off x="10970605" y="1844893"/>
+            <a:ext cx="1193109" cy="1193109"/>
+          </a:xfrm>
+          <a:prstGeom prst="pie">
+            <a:avLst>
+              <a:gd name="adj1" fmla="val 14100000"/>
+              <a:gd name="adj2" fmla="val 18300000"/>
+            </a:avLst>
+          </a:prstGeom>
+          <a:solidFill>
+            <a:srgbClr val="1A1A1A">
+              <a:alpha val="20000"/>
+            </a:srgbClr>
+          </a:solidFill>
+          <a:ln w="9525">
+            <a:solidFill>
+              <a:srgbClr val="1A1A1A"/>
+            </a:solidFill>
+          </a:ln>
+          <a:effectLst/>
+        </p:spPr>
+        <p:style>
+          <a:lnRef idx="1">
+            <a:schemeClr val="accent1"/>
+          </a:lnRef>
+          <a:fillRef idx="3">
+            <a:schemeClr val="accent1"/>
+          </a:fillRef>
+          <a:effectRef idx="2">
+            <a:schemeClr val="accent1"/>
+          </a:effectRef>
+          <a:fontRef idx="minor">
+            <a:schemeClr val="lt1"/>
+          </a:fontRef>
+        </p:style>
+        <p:txBody>
+          <a:bodyPr rtlCol="0" anchor="ctr"/>
+          <a:lstStyle/>
+          <a:p>
+            <a:pPr algn="ctr"/>
+          </a:p>
+        </p:txBody>
+      </p:sp>
+      <p:sp>
+        <p:nvSpPr>
+          <p:cNvPr id="9021" name="TextBox 9020"/>
+          <p:cNvSpPr txBox="1"/>
+          <p:nvPr/>
+        </p:nvSpPr>
+        <p:spPr>
+          <a:xfrm>
+            <a:off x="11292840" y="2478024"/>
+            <a:ext cx="548640" cy="164592"/>
+          </a:xfrm>
+          <a:prstGeom prst="rect">
+            <a:avLst/>
+          </a:prstGeom>
+          <a:noFill/>
+          <a:effectLst/>
+        </p:spPr>
+        <p:txBody>
+          <a:bodyPr wrap="none" anchor="t" lIns="27432" rIns="27432" tIns="13716" bIns="13716">
+            <a:spAutoFit/>
+          </a:bodyPr>
+          <a:lstStyle/>
+          <a:p>
+            <a:pPr algn="ctr"/>
+            <a:r>
+              <a:rPr sz="650" b="0" lang="en-GB">
+                <a:solidFill>
+                  <a:srgbClr val="6B6B6B"/>
+                </a:solidFill>
+                <a:latin typeface="Calibri"/>
+              </a:rPr>
+              <a:t>GK</a:t>
+            </a:r>
+          </a:p>
+        </p:txBody>
+      </p:sp>
+      <p:sp>
+        <p:nvSpPr>
+          <p:cNvPr id="9022" name="Rectangle 9021"/>
+          <p:cNvSpPr/>
+          <p:nvPr/>
+        </p:nvSpPr>
+        <p:spPr>
+          <a:xfrm>
+            <a:off x="9144000" y="1600200"/>
+            <a:ext cx="36576" cy="146304"/>
+          </a:xfrm>
+          <a:prstGeom prst="rect">
+            <a:avLst/>
+          </a:prstGeom>
+          <a:solidFill>
+            <a:srgbClr val="0057B8"/>
+          </a:solidFill>
+          <a:ln>
+            <a:noFill/>
+          </a:ln>
+          <a:effectLst/>
+        </p:spPr>
+        <p:style>
+          <a:lnRef idx="1">
+            <a:schemeClr val="accent1"/>
+          </a:lnRef>
+          <a:fillRef idx="3">
+            <a:schemeClr val="accent1"/>
+          </a:fillRef>
+          <a:effectRef idx="2">
+            <a:schemeClr val="accent1"/>
+          </a:effectRef>
+          <a:fontRef idx="minor">
+            <a:schemeClr val="lt1"/>
+          </a:fontRef>
+        </p:style>
+        <p:txBody>
+          <a:bodyPr rtlCol="0" anchor="ctr"/>
+          <a:lstStyle/>
+          <a:p>
+            <a:pPr algn="ctr"/>
+          </a:p>
+        </p:txBody>
+      </p:sp>
+      <p:sp>
+        <p:nvSpPr>
+          <p:cNvPr id="9023" name="TextBox 9022"/>
+          <p:cNvSpPr txBox="1"/>
+          <p:nvPr/>
+        </p:nvSpPr>
+        <p:spPr>
+          <a:xfrm>
+            <a:off x="9217152" y="1572768"/>
+            <a:ext cx="2377440" cy="201168"/>
+          </a:xfrm>
+          <a:prstGeom prst="rect">
+            <a:avLst/>
+          </a:prstGeom>
+          <a:noFill/>
+          <a:effectLst/>
+        </p:spPr>
+        <p:txBody>
+          <a:bodyPr wrap="none" anchor="t" lIns="27432" rIns="27432" tIns="13716" bIns="13716">
+            <a:spAutoFit/>
+          </a:bodyPr>
+          <a:lstStyle/>
+          <a:p>
+            <a:pPr algn="l"/>
+            <a:r>
+              <a:rPr sz="900" b="1" lang="en-GB">
+                <a:solidFill>
+                  <a:srgbClr val="1A1A1A"/>
+                </a:solidFill>
+                <a:latin typeface="Calibri"/>
+              </a:rPr>
+              <a:t>LONG VISION CONES  (≈8 m, standalone)</a:t>
+            </a:r>
+          </a:p>
+        </p:txBody>
+      </p:sp>
       <p:cxnSp>
         <p:nvCxnSpPr>
-          <p:cNvPr id="9015" name="Connector 9014"/>
+          <p:cNvPr id="9024" name="Connector 9023"/>
           <p:cNvCxnSpPr/>
           <p:nvPr/>
         </p:nvCxnSpPr>
@@ -26847,7 +27224,7 @@
         </p:grpSpPr>
         <p:sp>
           <p:nvSpPr>
-            <p:cNvPr id="9016" name="Pie 9015"/>
+            <p:cNvPr id="9025" name="Pie 9024"/>
             <p:cNvSpPr/>
             <p:nvPr/>
           </p:nvSpPr>
@@ -26899,7 +27276,7 @@
         </p:sp>
         <p:sp>
           <p:nvSpPr>
-            <p:cNvPr id="9017" name="Oval 9016"/>
+            <p:cNvPr id="9026" name="Oval 9025"/>
             <p:cNvSpPr/>
             <p:nvPr/>
           </p:nvSpPr>
@@ -26953,7 +27330,7 @@
       </p:grpSp>
       <p:sp>
         <p:nvSpPr>
-          <p:cNvPr id="9018" name="TextBox 9017"/>
+          <p:cNvPr id="9027" name="TextBox 9026"/>
           <p:cNvSpPr txBox="1"/>
           <p:nvPr/>
         </p:nvSpPr>
@@ -27003,7 +27380,7 @@
         </p:grpSpPr>
         <p:sp>
           <p:nvSpPr>
-            <p:cNvPr id="9019" name="Pie 9018"/>
+            <p:cNvPr id="9028" name="Pie 9027"/>
             <p:cNvSpPr/>
             <p:nvPr/>
           </p:nvSpPr>
@@ -27055,7 +27432,7 @@
         </p:sp>
         <p:sp>
           <p:nvSpPr>
-            <p:cNvPr id="9020" name="Oval 9019"/>
+            <p:cNvPr id="9029" name="Oval 9028"/>
             <p:cNvSpPr/>
             <p:nvPr/>
           </p:nvSpPr>
@@ -27111,7 +27488,7 @@
       </p:grpSp>
       <p:sp>
         <p:nvSpPr>
-          <p:cNvPr id="9021" name="TextBox 9020"/>
+          <p:cNvPr id="9030" name="TextBox 9029"/>
           <p:cNvSpPr txBox="1"/>
           <p:nvPr/>
         </p:nvSpPr>
@@ -27161,7 +27538,7 @@
         </p:grpSpPr>
         <p:sp>
           <p:nvSpPr>
-            <p:cNvPr id="9022" name="Pie 9021"/>
+            <p:cNvPr id="9031" name="Pie 9030"/>
             <p:cNvSpPr/>
             <p:nvPr/>
           </p:nvSpPr>
@@ -27213,7 +27590,7 @@
         </p:sp>
         <p:sp>
           <p:nvSpPr>
-            <p:cNvPr id="9023" name="Oval 9022"/>
+            <p:cNvPr id="9032" name="Oval 9031"/>
             <p:cNvSpPr/>
             <p:nvPr/>
           </p:nvSpPr>
@@ -27267,7 +27644,7 @@
       </p:grpSp>
       <p:sp>
         <p:nvSpPr>
-          <p:cNvPr id="9024" name="TextBox 9023"/>
+          <p:cNvPr id="9033" name="TextBox 9032"/>
           <p:cNvSpPr txBox="1"/>
           <p:nvPr/>
         </p:nvSpPr>
@@ -27317,7 +27694,7 @@
         </p:grpSpPr>
         <p:sp>
           <p:nvSpPr>
-            <p:cNvPr id="9025" name="Pie 9024"/>
+            <p:cNvPr id="9034" name="Pie 9033"/>
             <p:cNvSpPr/>
             <p:nvPr/>
           </p:nvSpPr>
@@ -27369,7 +27746,7 @@
         </p:sp>
         <p:sp>
           <p:nvSpPr>
-            <p:cNvPr id="9026" name="Pie 9025"/>
+            <p:cNvPr id="9035" name="Pie 9034"/>
             <p:cNvSpPr/>
             <p:nvPr/>
           </p:nvSpPr>
@@ -27418,7 +27795,7 @@
         </p:sp>
         <p:sp>
           <p:nvSpPr>
-            <p:cNvPr id="9027" name="Chord 9026"/>
+            <p:cNvPr id="9036" name="Chord 9035"/>
             <p:cNvSpPr/>
             <p:nvPr/>
           </p:nvSpPr>
@@ -27475,7 +27852,7 @@
       </p:grpSp>
       <p:sp>
         <p:nvSpPr>
-          <p:cNvPr id="9028" name="TextBox 9027"/>
+          <p:cNvPr id="9037" name="TextBox 9036"/>
           <p:cNvSpPr txBox="1"/>
           <p:nvPr/>
         </p:nvSpPr>
@@ -27511,7 +27888,7 @@
       </p:sp>
       <p:sp>
         <p:nvSpPr>
-          <p:cNvPr id="9029" name="Rectangle 9028"/>
+          <p:cNvPr id="9038" name="Rectangle 9037"/>
           <p:cNvSpPr/>
           <p:nvPr/>
         </p:nvSpPr>
@@ -27555,7 +27932,7 @@
       </p:sp>
       <p:sp>
         <p:nvSpPr>
-          <p:cNvPr id="9030" name="TextBox 9029"/>
+          <p:cNvPr id="9039" name="TextBox 9038"/>
           <p:cNvSpPr txBox="1"/>
           <p:nvPr/>
         </p:nvSpPr>
@@ -27591,7 +27968,7 @@
       </p:sp>
       <p:sp>
         <p:nvSpPr>
-          <p:cNvPr id="9031" name="TextBox 9030"/>
+          <p:cNvPr id="9040" name="TextBox 9039"/>
           <p:cNvSpPr txBox="1"/>
           <p:nvPr/>
         </p:nvSpPr>
@@ -27687,7 +28064,7 @@
       </p:sp>
       <p:cxnSp>
         <p:nvCxnSpPr>
-          <p:cNvPr id="9032" name="Connector 9031"/>
+          <p:cNvPr id="9041" name="Connector 9040"/>
           <p:cNvCxnSpPr/>
           <p:nvPr/>
         </p:nvCxnSpPr>
@@ -27723,7 +28100,7 @@
       </p:cxnSp>
       <p:sp>
         <p:nvSpPr>
-          <p:cNvPr id="9033" name="TextBox 9032"/>
+          <p:cNvPr id="9042" name="TextBox 9041"/>
           <p:cNvSpPr txBox="1"/>
           <p:nvPr/>
         </p:nvSpPr>
@@ -27768,7 +28145,7 @@
       </p:sp>
       <p:sp>
         <p:nvSpPr>
-          <p:cNvPr id="9034" name="Chord 9033"/>
+          <p:cNvPr id="9043" name="Chord 9042"/>
           <p:cNvSpPr/>
           <p:nvPr/>
         </p:nvSpPr>
@@ -27824,7 +28201,7 @@
       </p:sp>
       <p:sp>
         <p:nvSpPr>
-          <p:cNvPr id="9035" name="Chord 9034"/>
+          <p:cNvPr id="9044" name="Chord 9043"/>
           <p:cNvSpPr/>
           <p:nvPr/>
         </p:nvSpPr>
@@ -27880,7 +28257,7 @@
       </p:sp>
       <p:sp>
         <p:nvSpPr>
-          <p:cNvPr id="9036" name="Chord 9035"/>
+          <p:cNvPr id="9045" name="Chord 9044"/>
           <p:cNvSpPr/>
           <p:nvPr/>
         </p:nvSpPr>
@@ -27936,7 +28313,7 @@
       </p:sp>
       <p:sp>
         <p:nvSpPr>
-          <p:cNvPr id="9037" name="Chord 9036"/>
+          <p:cNvPr id="9046" name="Chord 9045"/>
           <p:cNvSpPr/>
           <p:nvPr/>
         </p:nvSpPr>
@@ -27992,7 +28369,7 @@
       </p:sp>
       <p:sp>
         <p:nvSpPr>
-          <p:cNvPr id="9038" name="Chord 9037"/>
+          <p:cNvPr id="9047" name="Chord 9046"/>
           <p:cNvSpPr/>
           <p:nvPr/>
         </p:nvSpPr>
@@ -28048,7 +28425,7 @@
       </p:sp>
       <p:sp>
         <p:nvSpPr>
-          <p:cNvPr id="9039" name="TextBox 9038"/>
+          <p:cNvPr id="9048" name="TextBox 9047"/>
           <p:cNvSpPr txBox="1"/>
           <p:nvPr/>
         </p:nvSpPr>
@@ -28093,7 +28470,7 @@
       </p:sp>
       <p:sp>
         <p:nvSpPr>
-          <p:cNvPr id="9040" name="Chord 9039"/>
+          <p:cNvPr id="9049" name="Chord 9048"/>
           <p:cNvSpPr/>
           <p:nvPr/>
         </p:nvSpPr>
@@ -28149,7 +28526,7 @@
       </p:sp>
       <p:sp>
         <p:nvSpPr>
-          <p:cNvPr id="9041" name="Chord 9040"/>
+          <p:cNvPr id="9050" name="Chord 9049"/>
           <p:cNvSpPr/>
           <p:nvPr/>
         </p:nvSpPr>
@@ -28205,7 +28582,7 @@
       </p:sp>
       <p:sp>
         <p:nvSpPr>
-          <p:cNvPr id="9042" name="Chord 9041"/>
+          <p:cNvPr id="9051" name="Chord 9050"/>
           <p:cNvSpPr/>
           <p:nvPr/>
         </p:nvSpPr>
@@ -28261,7 +28638,7 @@
       </p:sp>
       <p:sp>
         <p:nvSpPr>
-          <p:cNvPr id="9043" name="Chord 9042"/>
+          <p:cNvPr id="9052" name="Chord 9051"/>
           <p:cNvSpPr/>
           <p:nvPr/>
         </p:nvSpPr>
@@ -28317,7 +28694,7 @@
       </p:sp>
       <p:sp>
         <p:nvSpPr>
-          <p:cNvPr id="9044" name="Chord 9043"/>
+          <p:cNvPr id="9053" name="Chord 9052"/>
           <p:cNvSpPr/>
           <p:nvPr/>
         </p:nvSpPr>
@@ -28373,7 +28750,7 @@
       </p:sp>
       <p:sp>
         <p:nvSpPr>
-          <p:cNvPr id="9045" name="TextBox 9044"/>
+          <p:cNvPr id="9054" name="TextBox 9053"/>
           <p:cNvSpPr txBox="1"/>
           <p:nvPr/>
         </p:nvSpPr>
@@ -28421,7 +28798,7 @@
       </p:sp>
       <p:cxnSp>
         <p:nvCxnSpPr>
-          <p:cNvPr id="9046" name="Connector 9045"/>
+          <p:cNvPr id="9055" name="Connector 9054"/>
           <p:cNvCxnSpPr/>
           <p:nvPr/>
         </p:nvCxnSpPr>
@@ -28457,7 +28834,7 @@
       </p:cxnSp>
       <p:sp>
         <p:nvSpPr>
-          <p:cNvPr id="9047" name="Rectangle 9046"/>
+          <p:cNvPr id="9056" name="Rectangle 9055"/>
           <p:cNvSpPr/>
           <p:nvPr/>
         </p:nvSpPr>
@@ -28501,7 +28878,7 @@
       </p:sp>
       <p:sp>
         <p:nvSpPr>
-          <p:cNvPr id="9048" name="TextBox 9047"/>
+          <p:cNvPr id="9057" name="TextBox 9056"/>
           <p:cNvSpPr txBox="1"/>
           <p:nvPr/>
         </p:nvSpPr>
@@ -28551,7 +28928,7 @@
         </p:grpSpPr>
         <p:sp>
           <p:nvSpPr>
-            <p:cNvPr id="9049" name="Rectangle 9048"/>
+            <p:cNvPr id="9058" name="Rectangle 9057"/>
             <p:cNvSpPr/>
             <p:nvPr/>
           </p:nvSpPr>
@@ -28595,7 +28972,7 @@
         </p:sp>
         <p:cxnSp>
           <p:nvCxnSpPr>
-            <p:cNvPr id="9050" name="Connector 9049"/>
+            <p:cNvPr id="9059" name="Connector 9058"/>
             <p:cNvCxnSpPr/>
             <p:nvPr/>
           </p:nvCxnSpPr>
@@ -28631,7 +29008,7 @@
         </p:cxnSp>
         <p:sp>
           <p:nvSpPr>
-            <p:cNvPr id="9051" name="Oval 9050"/>
+            <p:cNvPr id="9060" name="Oval 9059"/>
             <p:cNvSpPr/>
             <p:nvPr/>
           </p:nvSpPr>
@@ -28675,7 +29052,7 @@
         </p:sp>
         <p:sp>
           <p:nvSpPr>
-            <p:cNvPr id="9052" name="Oval 9051"/>
+            <p:cNvPr id="9061" name="Oval 9060"/>
             <p:cNvSpPr/>
             <p:nvPr/>
           </p:nvSpPr>
@@ -28719,7 +29096,7 @@
         </p:sp>
         <p:sp>
           <p:nvSpPr>
-            <p:cNvPr id="9053" name="Arc 9052"/>
+            <p:cNvPr id="9062" name="Arc 9061"/>
             <p:cNvSpPr/>
             <p:nvPr/>
           </p:nvSpPr>
@@ -28766,7 +29143,7 @@
         </p:sp>
         <p:sp>
           <p:nvSpPr>
-            <p:cNvPr id="9054" name="Arc 9053"/>
+            <p:cNvPr id="9063" name="Arc 9062"/>
             <p:cNvSpPr/>
             <p:nvPr/>
           </p:nvSpPr>
@@ -28813,7 +29190,7 @@
         </p:sp>
         <p:cxnSp>
           <p:nvCxnSpPr>
-            <p:cNvPr id="9055" name="Connector 9054"/>
+            <p:cNvPr id="9064" name="Connector 9063"/>
             <p:cNvCxnSpPr/>
             <p:nvPr/>
           </p:nvCxnSpPr>
@@ -28849,7 +29226,7 @@
         </p:cxnSp>
         <p:sp>
           <p:nvSpPr>
-            <p:cNvPr id="9056" name="Oval 9055"/>
+            <p:cNvPr id="9065" name="Oval 9064"/>
             <p:cNvSpPr/>
             <p:nvPr/>
           </p:nvSpPr>
@@ -28893,7 +29270,7 @@
         </p:sp>
         <p:sp>
           <p:nvSpPr>
-            <p:cNvPr id="9057" name="Oval 9056"/>
+            <p:cNvPr id="9066" name="Oval 9065"/>
             <p:cNvSpPr/>
             <p:nvPr/>
           </p:nvSpPr>
@@ -28937,7 +29314,7 @@
         </p:sp>
         <p:sp>
           <p:nvSpPr>
-            <p:cNvPr id="9058" name="Rectangle 9057"/>
+            <p:cNvPr id="9067" name="Rectangle 9066"/>
             <p:cNvSpPr/>
             <p:nvPr/>
           </p:nvSpPr>
@@ -28981,7 +29358,7 @@
         </p:sp>
         <p:sp>
           <p:nvSpPr>
-            <p:cNvPr id="9059" name="Arc 9058"/>
+            <p:cNvPr id="9068" name="Arc 9067"/>
             <p:cNvSpPr/>
             <p:nvPr/>
           </p:nvSpPr>
@@ -29028,7 +29405,7 @@
         </p:sp>
         <p:sp>
           <p:nvSpPr>
-            <p:cNvPr id="9060" name="Arc 9059"/>
+            <p:cNvPr id="9069" name="Arc 9068"/>
             <p:cNvSpPr/>
             <p:nvPr/>
           </p:nvSpPr>
@@ -29075,7 +29452,7 @@
         </p:sp>
         <p:cxnSp>
           <p:nvCxnSpPr>
-            <p:cNvPr id="9061" name="Connector 9060"/>
+            <p:cNvPr id="9070" name="Connector 9069"/>
             <p:cNvCxnSpPr/>
             <p:nvPr/>
           </p:nvCxnSpPr>
@@ -29111,7 +29488,7 @@
         </p:cxnSp>
         <p:sp>
           <p:nvSpPr>
-            <p:cNvPr id="9062" name="Oval 9061"/>
+            <p:cNvPr id="9071" name="Oval 9070"/>
             <p:cNvSpPr/>
             <p:nvPr/>
           </p:nvSpPr>
@@ -29155,7 +29532,7 @@
         </p:sp>
         <p:sp>
           <p:nvSpPr>
-            <p:cNvPr id="9063" name="Oval 9062"/>
+            <p:cNvPr id="9072" name="Oval 9071"/>
             <p:cNvSpPr/>
             <p:nvPr/>
           </p:nvSpPr>
@@ -29199,7 +29576,7 @@
         </p:sp>
         <p:sp>
           <p:nvSpPr>
-            <p:cNvPr id="9064" name="Rectangle 9063"/>
+            <p:cNvPr id="9073" name="Rectangle 9072"/>
             <p:cNvSpPr/>
             <p:nvPr/>
           </p:nvSpPr>
@@ -29244,7 +29621,7 @@
       </p:grpSp>
       <p:sp>
         <p:nvSpPr>
-          <p:cNvPr id="9065" name="Rectangle 9064"/>
+          <p:cNvPr id="9074" name="Rectangle 9073"/>
           <p:cNvSpPr/>
           <p:nvPr/>
         </p:nvSpPr>
@@ -29288,7 +29665,7 @@
       </p:sp>
       <p:sp>
         <p:nvSpPr>
-          <p:cNvPr id="9066" name="TextBox 9065"/>
+          <p:cNvPr id="9075" name="TextBox 9074"/>
           <p:cNvSpPr txBox="1"/>
           <p:nvPr/>
         </p:nvSpPr>
@@ -29338,7 +29715,7 @@
         </p:grpSpPr>
         <p:sp>
           <p:nvSpPr>
-            <p:cNvPr id="9067" name="Rectangle 9066"/>
+            <p:cNvPr id="9076" name="Rectangle 9075"/>
             <p:cNvSpPr/>
             <p:nvPr/>
           </p:nvSpPr>
@@ -29382,7 +29759,7 @@
         </p:sp>
         <p:sp>
           <p:nvSpPr>
-            <p:cNvPr id="9068" name="Arc 9067"/>
+            <p:cNvPr id="9077" name="Arc 9076"/>
             <p:cNvSpPr/>
             <p:nvPr/>
           </p:nvSpPr>
@@ -29429,7 +29806,7 @@
         </p:sp>
         <p:sp>
           <p:nvSpPr>
-            <p:cNvPr id="9069" name="Oval 9068"/>
+            <p:cNvPr id="9078" name="Oval 9077"/>
             <p:cNvSpPr/>
             <p:nvPr/>
           </p:nvSpPr>
@@ -29473,7 +29850,7 @@
         </p:sp>
         <p:sp>
           <p:nvSpPr>
-            <p:cNvPr id="9070" name="Arc 9069"/>
+            <p:cNvPr id="9079" name="Arc 9078"/>
             <p:cNvSpPr/>
             <p:nvPr/>
           </p:nvSpPr>
@@ -29520,7 +29897,7 @@
         </p:sp>
         <p:sp>
           <p:nvSpPr>
-            <p:cNvPr id="9071" name="Arc 9070"/>
+            <p:cNvPr id="9080" name="Arc 9079"/>
             <p:cNvSpPr/>
             <p:nvPr/>
           </p:nvSpPr>
@@ -29567,7 +29944,7 @@
         </p:sp>
         <p:cxnSp>
           <p:nvCxnSpPr>
-            <p:cNvPr id="9072" name="Connector 9071"/>
+            <p:cNvPr id="9081" name="Connector 9080"/>
             <p:cNvCxnSpPr/>
             <p:nvPr/>
           </p:nvCxnSpPr>
@@ -29603,7 +29980,7 @@
         </p:cxnSp>
         <p:sp>
           <p:nvSpPr>
-            <p:cNvPr id="9073" name="Oval 9072"/>
+            <p:cNvPr id="9082" name="Oval 9081"/>
             <p:cNvSpPr/>
             <p:nvPr/>
           </p:nvSpPr>
@@ -29647,7 +30024,7 @@
         </p:sp>
         <p:sp>
           <p:nvSpPr>
-            <p:cNvPr id="9074" name="Oval 9073"/>
+            <p:cNvPr id="9083" name="Oval 9082"/>
             <p:cNvSpPr/>
             <p:nvPr/>
           </p:nvSpPr>
@@ -29691,7 +30068,7 @@
         </p:sp>
         <p:sp>
           <p:nvSpPr>
-            <p:cNvPr id="9075" name="Rectangle 9074"/>
+            <p:cNvPr id="9084" name="Rectangle 9083"/>
             <p:cNvSpPr/>
             <p:nvPr/>
           </p:nvSpPr>
@@ -29736,7 +30113,7 @@
       </p:grpSp>
       <p:sp>
         <p:nvSpPr>
-          <p:cNvPr id="9076" name="TextBox 9075"/>
+          <p:cNvPr id="9085" name="TextBox 9084"/>
           <p:cNvSpPr txBox="1"/>
           <p:nvPr/>
         </p:nvSpPr>
@@ -29808,7 +30185,7 @@
       </p:sp>
       <p:sp>
         <p:nvSpPr>
-          <p:cNvPr id="9077" name="TextBox 9076"/>
+          <p:cNvPr id="9086" name="TextBox 9085"/>
           <p:cNvSpPr txBox="1"/>
           <p:nvPr/>
         </p:nvSpPr>
@@ -29837,7 +30214,7 @@
                 </a:solidFill>
                 <a:latin typeface="Calibri"/>
               </a:rPr>
-              <a:t>COMPONENT LIBRARY  —  court-scale tactical symbols  ·  scan zone (180°, 5.5 m) · vision cone (70°, 3 m) · body puck · rotate to orient · combined group available</a:t>
+              <a:t>COMPONENT LIBRARY  —  court-scale tactical symbols  ·  scan zone (180°, 5.5 m) · vision cone (70°, 3 m) · long cone (8 m, standalone) · body puck · rotate to orient · combined group available</a:t>
             </a:r>
           </a:p>
         </p:txBody>

</xml_diff>